<commit_message>
Add closing slide (slide 3) — cinematic radial-pulse emotional layout
'통제 가능한 AI 위에서 / 하나은행의 모든 판단이 움직인다'
3-axis sub-copy + '도입 → 운영' transformation line.
Also updates footer to show x / 3 across all slides.

https://claude.ai/code/session_01FxEo1w4vu492E7Ycwid7Mr
</commit_message>
<xml_diff>
--- a/하나은행_AI_통제하는금융.pptx
+++ b/하나은행_AI_통제하는금융.pptx
@@ -7,6 +7,7 @@
   <p:sldIdLst>
     <p:sldId id="256" r:id="rId7"/>
     <p:sldId id="257" r:id="rId8"/>
+    <p:sldId id="258" r:id="rId9"/>
   </p:sldIdLst>
   <p:sldSz cx="12193200" cy="6858000" type="screen4x3"/>
   <p:notesSz cx="6858000" cy="9144000"/>
@@ -5867,7 +5868,7 @@
                 </a:solidFill>
                 <a:latin typeface="맑은 고딕"/>
               </a:rPr>
-              <a:t>1 / 2</a:t>
+              <a:t>1 / 3</a:t>
             </a:r>
           </a:p>
         </p:txBody>
@@ -9214,7 +9215,1305 @@
                 </a:solidFill>
                 <a:latin typeface="맑은 고딕"/>
               </a:rPr>
-              <a:t>2 / 2</a:t>
+              <a:t>2 / 3</a:t>
+            </a:r>
+          </a:p>
+        </p:txBody>
+      </p:sp>
+    </p:spTree>
+  </p:cSld>
+  <p:clrMapOvr>
+    <a:masterClrMapping/>
+  </p:clrMapOvr>
+</p:sld>
+</file>
+
+<file path=ppt/slides/slide3.xml><?xml version="1.0" encoding="utf-8"?>
+<p:sld xmlns:a="http://schemas.openxmlformats.org/drawingml/2006/main" xmlns:p="http://schemas.openxmlformats.org/presentationml/2006/main" xmlns:r="http://schemas.openxmlformats.org/officeDocument/2006/relationships">
+  <p:cSld>
+    <p:bg>
+      <p:bgPr>
+        <a:solidFill>
+          <a:srgbClr val="040916"/>
+        </a:solidFill>
+        <a:effectLst/>
+      </p:bgPr>
+    </p:bg>
+    <p:spTree>
+      <p:nvGrpSpPr>
+        <p:cNvPr id="1" name=""/>
+        <p:cNvGrpSpPr/>
+        <p:nvPr/>
+      </p:nvGrpSpPr>
+      <p:grpSpPr/>
+      <p:sp>
+        <p:nvSpPr>
+          <p:cNvPr id="2" name="Oval 1"/>
+          <p:cNvSpPr/>
+          <p:nvPr/>
+        </p:nvSpPr>
+        <p:spPr>
+          <a:xfrm>
+            <a:off x="182898" y="102870"/>
+            <a:ext cx="11827404" cy="6652260"/>
+          </a:xfrm>
+          <a:prstGeom prst="ellipse">
+            <a:avLst/>
+          </a:prstGeom>
+          <a:solidFill>
+            <a:srgbClr val="060E20"/>
+          </a:solidFill>
+          <a:ln>
+            <a:noFill/>
+          </a:ln>
+        </p:spPr>
+        <p:style>
+          <a:lnRef idx="1">
+            <a:schemeClr val="accent1"/>
+          </a:lnRef>
+          <a:fillRef idx="3">
+            <a:schemeClr val="accent1"/>
+          </a:fillRef>
+          <a:effectRef idx="2">
+            <a:schemeClr val="accent1"/>
+          </a:effectRef>
+          <a:fontRef idx="minor">
+            <a:schemeClr val="lt1"/>
+          </a:fontRef>
+        </p:style>
+        <p:txBody>
+          <a:bodyPr rtlCol="0" anchor="ctr"/>
+          <a:lstStyle/>
+          <a:p>
+            <a:pPr algn="ctr"/>
+          </a:p>
+        </p:txBody>
+      </p:sp>
+      <p:sp>
+        <p:nvSpPr>
+          <p:cNvPr id="3" name="Oval 2"/>
+          <p:cNvSpPr/>
+          <p:nvPr/>
+        </p:nvSpPr>
+        <p:spPr>
+          <a:xfrm>
+            <a:off x="1097388" y="617220"/>
+            <a:ext cx="9998424" cy="5623560"/>
+          </a:xfrm>
+          <a:prstGeom prst="ellipse">
+            <a:avLst/>
+          </a:prstGeom>
+          <a:solidFill>
+            <a:srgbClr val="081228"/>
+          </a:solidFill>
+          <a:ln>
+            <a:noFill/>
+          </a:ln>
+        </p:spPr>
+        <p:style>
+          <a:lnRef idx="1">
+            <a:schemeClr val="accent1"/>
+          </a:lnRef>
+          <a:fillRef idx="3">
+            <a:schemeClr val="accent1"/>
+          </a:fillRef>
+          <a:effectRef idx="2">
+            <a:schemeClr val="accent1"/>
+          </a:effectRef>
+          <a:fontRef idx="minor">
+            <a:schemeClr val="lt1"/>
+          </a:fontRef>
+        </p:style>
+        <p:txBody>
+          <a:bodyPr rtlCol="0" anchor="ctr"/>
+          <a:lstStyle/>
+          <a:p>
+            <a:pPr algn="ctr"/>
+          </a:p>
+        </p:txBody>
+      </p:sp>
+      <p:sp>
+        <p:nvSpPr>
+          <p:cNvPr id="4" name="Oval 3"/>
+          <p:cNvSpPr/>
+          <p:nvPr/>
+        </p:nvSpPr>
+        <p:spPr>
+          <a:xfrm>
+            <a:off x="2011877" y="1131570"/>
+            <a:ext cx="8169444" cy="4594860"/>
+          </a:xfrm>
+          <a:prstGeom prst="ellipse">
+            <a:avLst/>
+          </a:prstGeom>
+          <a:solidFill>
+            <a:srgbClr val="0B1834"/>
+          </a:solidFill>
+          <a:ln>
+            <a:noFill/>
+          </a:ln>
+        </p:spPr>
+        <p:style>
+          <a:lnRef idx="1">
+            <a:schemeClr val="accent1"/>
+          </a:lnRef>
+          <a:fillRef idx="3">
+            <a:schemeClr val="accent1"/>
+          </a:fillRef>
+          <a:effectRef idx="2">
+            <a:schemeClr val="accent1"/>
+          </a:effectRef>
+          <a:fontRef idx="minor">
+            <a:schemeClr val="lt1"/>
+          </a:fontRef>
+        </p:style>
+        <p:txBody>
+          <a:bodyPr rtlCol="0" anchor="ctr"/>
+          <a:lstStyle/>
+          <a:p>
+            <a:pPr algn="ctr"/>
+          </a:p>
+        </p:txBody>
+      </p:sp>
+      <p:sp>
+        <p:nvSpPr>
+          <p:cNvPr id="5" name="Oval 4"/>
+          <p:cNvSpPr/>
+          <p:nvPr/>
+        </p:nvSpPr>
+        <p:spPr>
+          <a:xfrm>
+            <a:off x="2926368" y="1645920"/>
+            <a:ext cx="6340464" cy="3566160"/>
+          </a:xfrm>
+          <a:prstGeom prst="ellipse">
+            <a:avLst/>
+          </a:prstGeom>
+          <a:solidFill>
+            <a:srgbClr val="0E1F42"/>
+          </a:solidFill>
+          <a:ln>
+            <a:noFill/>
+          </a:ln>
+        </p:spPr>
+        <p:style>
+          <a:lnRef idx="1">
+            <a:schemeClr val="accent1"/>
+          </a:lnRef>
+          <a:fillRef idx="3">
+            <a:schemeClr val="accent1"/>
+          </a:fillRef>
+          <a:effectRef idx="2">
+            <a:schemeClr val="accent1"/>
+          </a:effectRef>
+          <a:fontRef idx="minor">
+            <a:schemeClr val="lt1"/>
+          </a:fontRef>
+        </p:style>
+        <p:txBody>
+          <a:bodyPr rtlCol="0" anchor="ctr"/>
+          <a:lstStyle/>
+          <a:p>
+            <a:pPr algn="ctr"/>
+          </a:p>
+        </p:txBody>
+      </p:sp>
+      <p:sp>
+        <p:nvSpPr>
+          <p:cNvPr id="6" name="Oval 5"/>
+          <p:cNvSpPr/>
+          <p:nvPr/>
+        </p:nvSpPr>
+        <p:spPr>
+          <a:xfrm>
+            <a:off x="3779892" y="2125980"/>
+            <a:ext cx="4633416" cy="2606040"/>
+          </a:xfrm>
+          <a:prstGeom prst="ellipse">
+            <a:avLst/>
+          </a:prstGeom>
+          <a:solidFill>
+            <a:srgbClr val="122850"/>
+          </a:solidFill>
+          <a:ln>
+            <a:noFill/>
+          </a:ln>
+        </p:spPr>
+        <p:style>
+          <a:lnRef idx="1">
+            <a:schemeClr val="accent1"/>
+          </a:lnRef>
+          <a:fillRef idx="3">
+            <a:schemeClr val="accent1"/>
+          </a:fillRef>
+          <a:effectRef idx="2">
+            <a:schemeClr val="accent1"/>
+          </a:effectRef>
+          <a:fontRef idx="minor">
+            <a:schemeClr val="lt1"/>
+          </a:fontRef>
+        </p:style>
+        <p:txBody>
+          <a:bodyPr rtlCol="0" anchor="ctr"/>
+          <a:lstStyle/>
+          <a:p>
+            <a:pPr algn="ctr"/>
+          </a:p>
+        </p:txBody>
+      </p:sp>
+      <p:sp>
+        <p:nvSpPr>
+          <p:cNvPr id="7" name="Oval 6"/>
+          <p:cNvSpPr/>
+          <p:nvPr/>
+        </p:nvSpPr>
+        <p:spPr>
+          <a:xfrm>
+            <a:off x="4511484" y="2537460"/>
+            <a:ext cx="3170232" cy="1783080"/>
+          </a:xfrm>
+          <a:prstGeom prst="ellipse">
+            <a:avLst/>
+          </a:prstGeom>
+          <a:solidFill>
+            <a:srgbClr val="16305A"/>
+          </a:solidFill>
+          <a:ln>
+            <a:noFill/>
+          </a:ln>
+        </p:spPr>
+        <p:style>
+          <a:lnRef idx="1">
+            <a:schemeClr val="accent1"/>
+          </a:lnRef>
+          <a:fillRef idx="3">
+            <a:schemeClr val="accent1"/>
+          </a:fillRef>
+          <a:effectRef idx="2">
+            <a:schemeClr val="accent1"/>
+          </a:effectRef>
+          <a:fontRef idx="minor">
+            <a:schemeClr val="lt1"/>
+          </a:fontRef>
+        </p:style>
+        <p:txBody>
+          <a:bodyPr rtlCol="0" anchor="ctr"/>
+          <a:lstStyle/>
+          <a:p>
+            <a:pPr algn="ctr"/>
+          </a:p>
+        </p:txBody>
+      </p:sp>
+      <p:sp>
+        <p:nvSpPr>
+          <p:cNvPr id="8" name="Oval 7"/>
+          <p:cNvSpPr/>
+          <p:nvPr/>
+        </p:nvSpPr>
+        <p:spPr>
+          <a:xfrm>
+            <a:off x="5182110" y="2914650"/>
+            <a:ext cx="1828980" cy="1028700"/>
+          </a:xfrm>
+          <a:prstGeom prst="ellipse">
+            <a:avLst/>
+          </a:prstGeom>
+          <a:solidFill>
+            <a:srgbClr val="1A3864"/>
+          </a:solidFill>
+          <a:ln>
+            <a:noFill/>
+          </a:ln>
+        </p:spPr>
+        <p:style>
+          <a:lnRef idx="1">
+            <a:schemeClr val="accent1"/>
+          </a:lnRef>
+          <a:fillRef idx="3">
+            <a:schemeClr val="accent1"/>
+          </a:fillRef>
+          <a:effectRef idx="2">
+            <a:schemeClr val="accent1"/>
+          </a:effectRef>
+          <a:fontRef idx="minor">
+            <a:schemeClr val="lt1"/>
+          </a:fontRef>
+        </p:style>
+        <p:txBody>
+          <a:bodyPr rtlCol="0" anchor="ctr"/>
+          <a:lstStyle/>
+          <a:p>
+            <a:pPr algn="ctr"/>
+          </a:p>
+        </p:txBody>
+      </p:sp>
+      <p:sp>
+        <p:nvSpPr>
+          <p:cNvPr id="9" name="Oval 8"/>
+          <p:cNvSpPr/>
+          <p:nvPr/>
+        </p:nvSpPr>
+        <p:spPr>
+          <a:xfrm>
+            <a:off x="1707048" y="960120"/>
+            <a:ext cx="8779104" cy="4937760"/>
+          </a:xfrm>
+          <a:prstGeom prst="ellipse">
+            <a:avLst/>
+          </a:prstGeom>
+          <a:noFill/>
+          <a:ln w="5080">
+            <a:solidFill>
+              <a:srgbClr val="30240A"/>
+            </a:solidFill>
+          </a:ln>
+        </p:spPr>
+        <p:style>
+          <a:lnRef idx="1">
+            <a:schemeClr val="accent1"/>
+          </a:lnRef>
+          <a:fillRef idx="3">
+            <a:schemeClr val="accent1"/>
+          </a:fillRef>
+          <a:effectRef idx="2">
+            <a:schemeClr val="accent1"/>
+          </a:effectRef>
+          <a:fontRef idx="minor">
+            <a:schemeClr val="lt1"/>
+          </a:fontRef>
+        </p:style>
+        <p:txBody>
+          <a:bodyPr rtlCol="0" anchor="ctr"/>
+          <a:lstStyle/>
+          <a:p>
+            <a:pPr algn="ctr"/>
+          </a:p>
+        </p:txBody>
+      </p:sp>
+      <p:sp>
+        <p:nvSpPr>
+          <p:cNvPr id="10" name="Oval 9"/>
+          <p:cNvSpPr/>
+          <p:nvPr/>
+        </p:nvSpPr>
+        <p:spPr>
+          <a:xfrm>
+            <a:off x="2926368" y="1645920"/>
+            <a:ext cx="6340464" cy="3566160"/>
+          </a:xfrm>
+          <a:prstGeom prst="ellipse">
+            <a:avLst/>
+          </a:prstGeom>
+          <a:noFill/>
+          <a:ln w="7620">
+            <a:solidFill>
+              <a:srgbClr val="E5B22D"/>
+            </a:solidFill>
+          </a:ln>
+        </p:spPr>
+        <p:style>
+          <a:lnRef idx="1">
+            <a:schemeClr val="accent1"/>
+          </a:lnRef>
+          <a:fillRef idx="3">
+            <a:schemeClr val="accent1"/>
+          </a:fillRef>
+          <a:effectRef idx="2">
+            <a:schemeClr val="accent1"/>
+          </a:effectRef>
+          <a:fontRef idx="minor">
+            <a:schemeClr val="lt1"/>
+          </a:fontRef>
+        </p:style>
+        <p:txBody>
+          <a:bodyPr rtlCol="0" anchor="ctr"/>
+          <a:lstStyle/>
+          <a:p>
+            <a:pPr algn="ctr"/>
+          </a:p>
+        </p:txBody>
+      </p:sp>
+      <p:sp>
+        <p:nvSpPr>
+          <p:cNvPr id="11" name="Oval 10"/>
+          <p:cNvSpPr/>
+          <p:nvPr/>
+        </p:nvSpPr>
+        <p:spPr>
+          <a:xfrm>
+            <a:off x="4145688" y="2331720"/>
+            <a:ext cx="3901824" cy="2194560"/>
+          </a:xfrm>
+          <a:prstGeom prst="ellipse">
+            <a:avLst/>
+          </a:prstGeom>
+          <a:noFill/>
+          <a:ln w="3810">
+            <a:solidFill>
+              <a:srgbClr val="006A80"/>
+            </a:solidFill>
+          </a:ln>
+        </p:spPr>
+        <p:style>
+          <a:lnRef idx="1">
+            <a:schemeClr val="accent1"/>
+          </a:lnRef>
+          <a:fillRef idx="3">
+            <a:schemeClr val="accent1"/>
+          </a:fillRef>
+          <a:effectRef idx="2">
+            <a:schemeClr val="accent1"/>
+          </a:effectRef>
+          <a:fontRef idx="minor">
+            <a:schemeClr val="lt1"/>
+          </a:fontRef>
+        </p:style>
+        <p:txBody>
+          <a:bodyPr rtlCol="0" anchor="ctr"/>
+          <a:lstStyle/>
+          <a:p>
+            <a:pPr algn="ctr"/>
+          </a:p>
+        </p:txBody>
+      </p:sp>
+      <p:sp>
+        <p:nvSpPr>
+          <p:cNvPr id="12" name="Oval 11"/>
+          <p:cNvSpPr/>
+          <p:nvPr/>
+        </p:nvSpPr>
+        <p:spPr>
+          <a:xfrm>
+            <a:off x="3576600" y="1881000"/>
+            <a:ext cx="5040000" cy="2520000"/>
+          </a:xfrm>
+          <a:prstGeom prst="ellipse">
+            <a:avLst/>
+          </a:prstGeom>
+          <a:solidFill>
+            <a:srgbClr val="1C1604"/>
+          </a:solidFill>
+          <a:ln>
+            <a:noFill/>
+          </a:ln>
+        </p:spPr>
+        <p:style>
+          <a:lnRef idx="1">
+            <a:schemeClr val="accent1"/>
+          </a:lnRef>
+          <a:fillRef idx="3">
+            <a:schemeClr val="accent1"/>
+          </a:fillRef>
+          <a:effectRef idx="2">
+            <a:schemeClr val="accent1"/>
+          </a:effectRef>
+          <a:fontRef idx="minor">
+            <a:schemeClr val="lt1"/>
+          </a:fontRef>
+        </p:style>
+        <p:txBody>
+          <a:bodyPr rtlCol="0" anchor="ctr"/>
+          <a:lstStyle/>
+          <a:p>
+            <a:pPr algn="ctr"/>
+          </a:p>
+        </p:txBody>
+      </p:sp>
+      <p:sp>
+        <p:nvSpPr>
+          <p:cNvPr id="13" name="TextBox 12"/>
+          <p:cNvSpPr txBox="1"/>
+          <p:nvPr/>
+        </p:nvSpPr>
+        <p:spPr>
+          <a:xfrm>
+            <a:off x="0" y="1764000"/>
+            <a:ext cx="12193200" cy="198000"/>
+          </a:xfrm>
+          <a:prstGeom prst="rect">
+            <a:avLst/>
+          </a:prstGeom>
+          <a:noFill/>
+        </p:spPr>
+        <p:txBody>
+          <a:bodyPr wrap="square" lIns="28800" rIns="28800" tIns="14400" bIns="14400">
+            <a:spAutoFit/>
+          </a:bodyPr>
+          <a:lstStyle/>
+          <a:p>
+            <a:pPr algn="ctr"/>
+            <a:r>
+              <a:rPr sz="900" b="0" i="0">
+                <a:solidFill>
+                  <a:srgbClr val="283E5C"/>
+                </a:solidFill>
+                <a:latin typeface="맑은 고딕"/>
+              </a:rPr>
+              <a:t>HANA BANK  ×  AI FOUNDATION  ×  KT</a:t>
+            </a:r>
+          </a:p>
+        </p:txBody>
+      </p:sp>
+      <p:sp>
+        <p:nvSpPr>
+          <p:cNvPr id="14" name="TextBox 13"/>
+          <p:cNvSpPr txBox="1"/>
+          <p:nvPr/>
+        </p:nvSpPr>
+        <p:spPr>
+          <a:xfrm>
+            <a:off x="0" y="2034000"/>
+            <a:ext cx="12193200" cy="468000"/>
+          </a:xfrm>
+          <a:prstGeom prst="rect">
+            <a:avLst/>
+          </a:prstGeom>
+          <a:noFill/>
+        </p:spPr>
+        <p:txBody>
+          <a:bodyPr wrap="square" lIns="28800" rIns="28800" tIns="14400" bIns="14400">
+            <a:spAutoFit/>
+          </a:bodyPr>
+          <a:lstStyle/>
+          <a:p>
+            <a:pPr algn="ctr"/>
+            <a:r>
+              <a:rPr sz="3000" b="0" i="0">
+                <a:solidFill>
+                  <a:srgbClr val="FFFFFF"/>
+                </a:solidFill>
+                <a:latin typeface="맑은 고딕"/>
+              </a:rPr>
+              <a:t>통제 가능한 AI 위에서</a:t>
+            </a:r>
+          </a:p>
+        </p:txBody>
+      </p:sp>
+      <p:sp>
+        <p:nvSpPr>
+          <p:cNvPr id="15" name="TextBox 14"/>
+          <p:cNvSpPr txBox="1"/>
+          <p:nvPr/>
+        </p:nvSpPr>
+        <p:spPr>
+          <a:xfrm>
+            <a:off x="0" y="2556000"/>
+            <a:ext cx="12193200" cy="612000"/>
+          </a:xfrm>
+          <a:prstGeom prst="rect">
+            <a:avLst/>
+          </a:prstGeom>
+          <a:noFill/>
+        </p:spPr>
+        <p:txBody>
+          <a:bodyPr wrap="square" lIns="28800" rIns="28800" tIns="14400" bIns="14400">
+            <a:spAutoFit/>
+          </a:bodyPr>
+          <a:lstStyle/>
+          <a:p>
+            <a:pPr algn="ctr"/>
+            <a:r>
+              <a:rPr sz="4000" b="1" i="0">
+                <a:solidFill>
+                  <a:srgbClr val="E5B22D"/>
+                </a:solidFill>
+                <a:latin typeface="맑은 고딕"/>
+              </a:rPr>
+              <a:t>하나은행의 모든 판단이 움직인다</a:t>
+            </a:r>
+          </a:p>
+        </p:txBody>
+      </p:sp>
+      <p:sp>
+        <p:nvSpPr>
+          <p:cNvPr id="16" name="Rectangle 15"/>
+          <p:cNvSpPr/>
+          <p:nvPr/>
+        </p:nvSpPr>
+        <p:spPr>
+          <a:xfrm>
+            <a:off x="5196600" y="3276000"/>
+            <a:ext cx="1800000" cy="9000"/>
+          </a:xfrm>
+          <a:prstGeom prst="rect">
+            <a:avLst/>
+          </a:prstGeom>
+          <a:solidFill>
+            <a:srgbClr val="E5B22D"/>
+          </a:solidFill>
+          <a:ln>
+            <a:noFill/>
+          </a:ln>
+        </p:spPr>
+        <p:style>
+          <a:lnRef idx="1">
+            <a:schemeClr val="accent1"/>
+          </a:lnRef>
+          <a:fillRef idx="3">
+            <a:schemeClr val="accent1"/>
+          </a:fillRef>
+          <a:effectRef idx="2">
+            <a:schemeClr val="accent1"/>
+          </a:effectRef>
+          <a:fontRef idx="minor">
+            <a:schemeClr val="lt1"/>
+          </a:fontRef>
+        </p:style>
+        <p:txBody>
+          <a:bodyPr rtlCol="0" anchor="ctr"/>
+          <a:lstStyle/>
+          <a:p>
+            <a:pPr algn="ctr"/>
+          </a:p>
+        </p:txBody>
+      </p:sp>
+      <p:sp>
+        <p:nvSpPr>
+          <p:cNvPr id="17" name="Oval 16"/>
+          <p:cNvSpPr/>
+          <p:nvPr/>
+        </p:nvSpPr>
+        <p:spPr>
+          <a:xfrm>
+            <a:off x="5095800" y="3247200"/>
+            <a:ext cx="64800" cy="64800"/>
+          </a:xfrm>
+          <a:prstGeom prst="ellipse">
+            <a:avLst/>
+          </a:prstGeom>
+          <a:solidFill>
+            <a:srgbClr val="E5B22D"/>
+          </a:solidFill>
+          <a:ln>
+            <a:noFill/>
+          </a:ln>
+        </p:spPr>
+        <p:style>
+          <a:lnRef idx="1">
+            <a:schemeClr val="accent1"/>
+          </a:lnRef>
+          <a:fillRef idx="3">
+            <a:schemeClr val="accent1"/>
+          </a:fillRef>
+          <a:effectRef idx="2">
+            <a:schemeClr val="accent1"/>
+          </a:effectRef>
+          <a:fontRef idx="minor">
+            <a:schemeClr val="lt1"/>
+          </a:fontRef>
+        </p:style>
+        <p:txBody>
+          <a:bodyPr rtlCol="0" anchor="ctr"/>
+          <a:lstStyle/>
+          <a:p>
+            <a:pPr algn="ctr"/>
+          </a:p>
+        </p:txBody>
+      </p:sp>
+      <p:sp>
+        <p:nvSpPr>
+          <p:cNvPr id="18" name="Oval 17"/>
+          <p:cNvSpPr/>
+          <p:nvPr/>
+        </p:nvSpPr>
+        <p:spPr>
+          <a:xfrm>
+            <a:off x="7032600" y="3247200"/>
+            <a:ext cx="64800" cy="64800"/>
+          </a:xfrm>
+          <a:prstGeom prst="ellipse">
+            <a:avLst/>
+          </a:prstGeom>
+          <a:solidFill>
+            <a:srgbClr val="E5B22D"/>
+          </a:solidFill>
+          <a:ln>
+            <a:noFill/>
+          </a:ln>
+        </p:spPr>
+        <p:style>
+          <a:lnRef idx="1">
+            <a:schemeClr val="accent1"/>
+          </a:lnRef>
+          <a:fillRef idx="3">
+            <a:schemeClr val="accent1"/>
+          </a:fillRef>
+          <a:effectRef idx="2">
+            <a:schemeClr val="accent1"/>
+          </a:effectRef>
+          <a:fontRef idx="minor">
+            <a:schemeClr val="lt1"/>
+          </a:fontRef>
+        </p:style>
+        <p:txBody>
+          <a:bodyPr rtlCol="0" anchor="ctr"/>
+          <a:lstStyle/>
+          <a:p>
+            <a:pPr algn="ctr"/>
+          </a:p>
+        </p:txBody>
+      </p:sp>
+      <p:sp>
+        <p:nvSpPr>
+          <p:cNvPr id="19" name="Oval 18"/>
+          <p:cNvSpPr/>
+          <p:nvPr/>
+        </p:nvSpPr>
+        <p:spPr>
+          <a:xfrm>
+            <a:off x="1951200" y="3474000"/>
+            <a:ext cx="162000" cy="162000"/>
+          </a:xfrm>
+          <a:prstGeom prst="ellipse">
+            <a:avLst/>
+          </a:prstGeom>
+          <a:solidFill>
+            <a:srgbClr val="00D4FF"/>
+          </a:solidFill>
+          <a:ln>
+            <a:noFill/>
+          </a:ln>
+        </p:spPr>
+        <p:style>
+          <a:lnRef idx="1">
+            <a:schemeClr val="accent1"/>
+          </a:lnRef>
+          <a:fillRef idx="3">
+            <a:schemeClr val="accent1"/>
+          </a:fillRef>
+          <a:effectRef idx="2">
+            <a:schemeClr val="accent1"/>
+          </a:effectRef>
+          <a:fontRef idx="minor">
+            <a:schemeClr val="lt1"/>
+          </a:fontRef>
+        </p:style>
+        <p:txBody>
+          <a:bodyPr rtlCol="0" anchor="ctr"/>
+          <a:lstStyle/>
+          <a:p>
+            <a:pPr algn="ctr"/>
+          </a:p>
+        </p:txBody>
+      </p:sp>
+      <p:sp>
+        <p:nvSpPr>
+          <p:cNvPr id="20" name="TextBox 19"/>
+          <p:cNvSpPr txBox="1"/>
+          <p:nvPr/>
+        </p:nvSpPr>
+        <p:spPr>
+          <a:xfrm>
+            <a:off x="0" y="3690000"/>
+            <a:ext cx="4064400" cy="234000"/>
+          </a:xfrm>
+          <a:prstGeom prst="rect">
+            <a:avLst/>
+          </a:prstGeom>
+          <a:noFill/>
+        </p:spPr>
+        <p:txBody>
+          <a:bodyPr wrap="square" lIns="28800" rIns="28800" tIns="14400" bIns="14400">
+            <a:spAutoFit/>
+          </a:bodyPr>
+          <a:lstStyle/>
+          <a:p>
+            <a:pPr algn="ctr"/>
+            <a:r>
+              <a:rPr sz="1500" b="0" i="0">
+                <a:solidFill>
+                  <a:srgbClr val="CCD6E0"/>
+                </a:solidFill>
+                <a:latin typeface="맑은 고딕"/>
+              </a:rPr>
+              <a:t>고객 경험은</a:t>
+            </a:r>
+          </a:p>
+        </p:txBody>
+      </p:sp>
+      <p:sp>
+        <p:nvSpPr>
+          <p:cNvPr id="21" name="TextBox 20"/>
+          <p:cNvSpPr txBox="1"/>
+          <p:nvPr/>
+        </p:nvSpPr>
+        <p:spPr>
+          <a:xfrm>
+            <a:off x="0" y="3906000"/>
+            <a:ext cx="4064400" cy="234000"/>
+          </a:xfrm>
+          <a:prstGeom prst="rect">
+            <a:avLst/>
+          </a:prstGeom>
+          <a:noFill/>
+        </p:spPr>
+        <p:txBody>
+          <a:bodyPr wrap="square" lIns="28800" rIns="28800" tIns="14400" bIns="14400">
+            <a:spAutoFit/>
+          </a:bodyPr>
+          <a:lstStyle/>
+          <a:p>
+            <a:pPr algn="ctr"/>
+            <a:r>
+              <a:rPr sz="1500" b="1" i="0">
+                <a:solidFill>
+                  <a:srgbClr val="00D4FF"/>
+                </a:solidFill>
+                <a:latin typeface="맑은 고딕"/>
+              </a:rPr>
+              <a:t>더 빨라지고</a:t>
+            </a:r>
+          </a:p>
+        </p:txBody>
+      </p:sp>
+      <p:sp>
+        <p:nvSpPr>
+          <p:cNvPr id="22" name="Oval 21"/>
+          <p:cNvSpPr/>
+          <p:nvPr/>
+        </p:nvSpPr>
+        <p:spPr>
+          <a:xfrm>
+            <a:off x="6015600" y="3474000"/>
+            <a:ext cx="162000" cy="162000"/>
+          </a:xfrm>
+          <a:prstGeom prst="ellipse">
+            <a:avLst/>
+          </a:prstGeom>
+          <a:solidFill>
+            <a:srgbClr val="FFD700"/>
+          </a:solidFill>
+          <a:ln>
+            <a:noFill/>
+          </a:ln>
+        </p:spPr>
+        <p:style>
+          <a:lnRef idx="1">
+            <a:schemeClr val="accent1"/>
+          </a:lnRef>
+          <a:fillRef idx="3">
+            <a:schemeClr val="accent1"/>
+          </a:fillRef>
+          <a:effectRef idx="2">
+            <a:schemeClr val="accent1"/>
+          </a:effectRef>
+          <a:fontRef idx="minor">
+            <a:schemeClr val="lt1"/>
+          </a:fontRef>
+        </p:style>
+        <p:txBody>
+          <a:bodyPr rtlCol="0" anchor="ctr"/>
+          <a:lstStyle/>
+          <a:p>
+            <a:pPr algn="ctr"/>
+          </a:p>
+        </p:txBody>
+      </p:sp>
+      <p:sp>
+        <p:nvSpPr>
+          <p:cNvPr id="23" name="TextBox 22"/>
+          <p:cNvSpPr txBox="1"/>
+          <p:nvPr/>
+        </p:nvSpPr>
+        <p:spPr>
+          <a:xfrm>
+            <a:off x="4064400" y="3690000"/>
+            <a:ext cx="4064400" cy="234000"/>
+          </a:xfrm>
+          <a:prstGeom prst="rect">
+            <a:avLst/>
+          </a:prstGeom>
+          <a:noFill/>
+        </p:spPr>
+        <p:txBody>
+          <a:bodyPr wrap="square" lIns="28800" rIns="28800" tIns="14400" bIns="14400">
+            <a:spAutoFit/>
+          </a:bodyPr>
+          <a:lstStyle/>
+          <a:p>
+            <a:pPr algn="ctr"/>
+            <a:r>
+              <a:rPr sz="1500" b="0" i="0">
+                <a:solidFill>
+                  <a:srgbClr val="CCD6E0"/>
+                </a:solidFill>
+                <a:latin typeface="맑은 고딕"/>
+              </a:rPr>
+              <a:t>직원 업무는</a:t>
+            </a:r>
+          </a:p>
+        </p:txBody>
+      </p:sp>
+      <p:sp>
+        <p:nvSpPr>
+          <p:cNvPr id="24" name="TextBox 23"/>
+          <p:cNvSpPr txBox="1"/>
+          <p:nvPr/>
+        </p:nvSpPr>
+        <p:spPr>
+          <a:xfrm>
+            <a:off x="4064400" y="3906000"/>
+            <a:ext cx="4064400" cy="234000"/>
+          </a:xfrm>
+          <a:prstGeom prst="rect">
+            <a:avLst/>
+          </a:prstGeom>
+          <a:noFill/>
+        </p:spPr>
+        <p:txBody>
+          <a:bodyPr wrap="square" lIns="28800" rIns="28800" tIns="14400" bIns="14400">
+            <a:spAutoFit/>
+          </a:bodyPr>
+          <a:lstStyle/>
+          <a:p>
+            <a:pPr algn="ctr"/>
+            <a:r>
+              <a:rPr sz="1500" b="1" i="0">
+                <a:solidFill>
+                  <a:srgbClr val="FFD700"/>
+                </a:solidFill>
+                <a:latin typeface="맑은 고딕"/>
+              </a:rPr>
+              <a:t>더 효율화되며</a:t>
+            </a:r>
+          </a:p>
+        </p:txBody>
+      </p:sp>
+      <p:sp>
+        <p:nvSpPr>
+          <p:cNvPr id="25" name="Oval 24"/>
+          <p:cNvSpPr/>
+          <p:nvPr/>
+        </p:nvSpPr>
+        <p:spPr>
+          <a:xfrm>
+            <a:off x="10080000" y="3474000"/>
+            <a:ext cx="162000" cy="162000"/>
+          </a:xfrm>
+          <a:prstGeom prst="ellipse">
+            <a:avLst/>
+          </a:prstGeom>
+          <a:solidFill>
+            <a:srgbClr val="FF6B35"/>
+          </a:solidFill>
+          <a:ln>
+            <a:noFill/>
+          </a:ln>
+        </p:spPr>
+        <p:style>
+          <a:lnRef idx="1">
+            <a:schemeClr val="accent1"/>
+          </a:lnRef>
+          <a:fillRef idx="3">
+            <a:schemeClr val="accent1"/>
+          </a:fillRef>
+          <a:effectRef idx="2">
+            <a:schemeClr val="accent1"/>
+          </a:effectRef>
+          <a:fontRef idx="minor">
+            <a:schemeClr val="lt1"/>
+          </a:fontRef>
+        </p:style>
+        <p:txBody>
+          <a:bodyPr rtlCol="0" anchor="ctr"/>
+          <a:lstStyle/>
+          <a:p>
+            <a:pPr algn="ctr"/>
+          </a:p>
+        </p:txBody>
+      </p:sp>
+      <p:sp>
+        <p:nvSpPr>
+          <p:cNvPr id="26" name="TextBox 25"/>
+          <p:cNvSpPr txBox="1"/>
+          <p:nvPr/>
+        </p:nvSpPr>
+        <p:spPr>
+          <a:xfrm>
+            <a:off x="8128800" y="3690000"/>
+            <a:ext cx="4064400" cy="234000"/>
+          </a:xfrm>
+          <a:prstGeom prst="rect">
+            <a:avLst/>
+          </a:prstGeom>
+          <a:noFill/>
+        </p:spPr>
+        <p:txBody>
+          <a:bodyPr wrap="square" lIns="28800" rIns="28800" tIns="14400" bIns="14400">
+            <a:spAutoFit/>
+          </a:bodyPr>
+          <a:lstStyle/>
+          <a:p>
+            <a:pPr algn="ctr"/>
+            <a:r>
+              <a:rPr sz="1500" b="0" i="0">
+                <a:solidFill>
+                  <a:srgbClr val="CCD6E0"/>
+                </a:solidFill>
+                <a:latin typeface="맑은 고딕"/>
+              </a:rPr>
+              <a:t>리스크는</a:t>
+            </a:r>
+          </a:p>
+        </p:txBody>
+      </p:sp>
+      <p:sp>
+        <p:nvSpPr>
+          <p:cNvPr id="27" name="TextBox 26"/>
+          <p:cNvSpPr txBox="1"/>
+          <p:nvPr/>
+        </p:nvSpPr>
+        <p:spPr>
+          <a:xfrm>
+            <a:off x="8128800" y="3906000"/>
+            <a:ext cx="4064400" cy="234000"/>
+          </a:xfrm>
+          <a:prstGeom prst="rect">
+            <a:avLst/>
+          </a:prstGeom>
+          <a:noFill/>
+        </p:spPr>
+        <p:txBody>
+          <a:bodyPr wrap="square" lIns="28800" rIns="28800" tIns="14400" bIns="14400">
+            <a:spAutoFit/>
+          </a:bodyPr>
+          <a:lstStyle/>
+          <a:p>
+            <a:pPr algn="ctr"/>
+            <a:r>
+              <a:rPr sz="1500" b="1" i="0">
+                <a:solidFill>
+                  <a:srgbClr val="FF6B35"/>
+                </a:solidFill>
+                <a:latin typeface="맑은 고딕"/>
+              </a:rPr>
+              <a:t>더 정교하게 통제된다</a:t>
+            </a:r>
+          </a:p>
+        </p:txBody>
+      </p:sp>
+      <p:sp>
+        <p:nvSpPr>
+          <p:cNvPr id="28" name="Rectangle 27"/>
+          <p:cNvSpPr/>
+          <p:nvPr/>
+        </p:nvSpPr>
+        <p:spPr>
+          <a:xfrm>
+            <a:off x="1440000" y="4140000"/>
+            <a:ext cx="9313200" cy="7200"/>
+          </a:xfrm>
+          <a:prstGeom prst="rect">
+            <a:avLst/>
+          </a:prstGeom>
+          <a:solidFill>
+            <a:srgbClr val="182A44"/>
+          </a:solidFill>
+          <a:ln>
+            <a:noFill/>
+          </a:ln>
+        </p:spPr>
+        <p:style>
+          <a:lnRef idx="1">
+            <a:schemeClr val="accent1"/>
+          </a:lnRef>
+          <a:fillRef idx="3">
+            <a:schemeClr val="accent1"/>
+          </a:fillRef>
+          <a:effectRef idx="2">
+            <a:schemeClr val="accent1"/>
+          </a:effectRef>
+          <a:fontRef idx="minor">
+            <a:schemeClr val="lt1"/>
+          </a:fontRef>
+        </p:style>
+        <p:txBody>
+          <a:bodyPr rtlCol="0" anchor="ctr"/>
+          <a:lstStyle/>
+          <a:p>
+            <a:pPr algn="ctr"/>
+          </a:p>
+        </p:txBody>
+      </p:sp>
+      <p:sp>
+        <p:nvSpPr>
+          <p:cNvPr id="29" name="Rectangle 28"/>
+          <p:cNvSpPr/>
+          <p:nvPr/>
+        </p:nvSpPr>
+        <p:spPr>
+          <a:xfrm>
+            <a:off x="0" y="4464000"/>
+            <a:ext cx="12193200" cy="900000"/>
+          </a:xfrm>
+          <a:prstGeom prst="rect">
+            <a:avLst/>
+          </a:prstGeom>
+          <a:solidFill>
+            <a:srgbClr val="060E1E"/>
+          </a:solidFill>
+          <a:ln>
+            <a:noFill/>
+          </a:ln>
+        </p:spPr>
+        <p:style>
+          <a:lnRef idx="1">
+            <a:schemeClr val="accent1"/>
+          </a:lnRef>
+          <a:fillRef idx="3">
+            <a:schemeClr val="accent1"/>
+          </a:fillRef>
+          <a:effectRef idx="2">
+            <a:schemeClr val="accent1"/>
+          </a:effectRef>
+          <a:fontRef idx="minor">
+            <a:schemeClr val="lt1"/>
+          </a:fontRef>
+        </p:style>
+        <p:txBody>
+          <a:bodyPr rtlCol="0" anchor="ctr"/>
+          <a:lstStyle/>
+          <a:p>
+            <a:pPr algn="ctr"/>
+          </a:p>
+        </p:txBody>
+      </p:sp>
+      <p:sp>
+        <p:nvSpPr>
+          <p:cNvPr id="30" name="TextBox 29"/>
+          <p:cNvSpPr txBox="1"/>
+          <p:nvPr/>
+        </p:nvSpPr>
+        <p:spPr>
+          <a:xfrm>
+            <a:off x="360000" y="4626000"/>
+            <a:ext cx="5556600" cy="342000"/>
+          </a:xfrm>
+          <a:prstGeom prst="rect">
+            <a:avLst/>
+          </a:prstGeom>
+          <a:noFill/>
+        </p:spPr>
+        <p:txBody>
+          <a:bodyPr wrap="square" lIns="28800" rIns="28800" tIns="14400" bIns="14400">
+            <a:spAutoFit/>
+          </a:bodyPr>
+          <a:lstStyle/>
+          <a:p>
+            <a:pPr algn="r"/>
+            <a:r>
+              <a:rPr sz="2000" b="0" i="0">
+                <a:solidFill>
+                  <a:srgbClr val="A0B8CC"/>
+                </a:solidFill>
+                <a:latin typeface="맑은 고딕"/>
+              </a:rPr>
+              <a:t>AI를 도입하는 은행에서</a:t>
+            </a:r>
+          </a:p>
+        </p:txBody>
+      </p:sp>
+      <p:sp>
+        <p:nvSpPr>
+          <p:cNvPr id="31" name="TextBox 30"/>
+          <p:cNvSpPr txBox="1"/>
+          <p:nvPr/>
+        </p:nvSpPr>
+        <p:spPr>
+          <a:xfrm>
+            <a:off x="5736600" y="4626000"/>
+            <a:ext cx="720000" cy="342000"/>
+          </a:xfrm>
+          <a:prstGeom prst="rect">
+            <a:avLst/>
+          </a:prstGeom>
+          <a:noFill/>
+        </p:spPr>
+        <p:txBody>
+          <a:bodyPr wrap="square" lIns="28800" rIns="28800" tIns="14400" bIns="14400">
+            <a:spAutoFit/>
+          </a:bodyPr>
+          <a:lstStyle/>
+          <a:p>
+            <a:pPr algn="ctr"/>
+            <a:r>
+              <a:rPr sz="2400" b="1" i="0">
+                <a:solidFill>
+                  <a:srgbClr val="E5B22D"/>
+                </a:solidFill>
+                <a:latin typeface="맑은 고딕"/>
+              </a:rPr>
+              <a:t>→</a:t>
+            </a:r>
+          </a:p>
+        </p:txBody>
+      </p:sp>
+      <p:sp>
+        <p:nvSpPr>
+          <p:cNvPr id="32" name="TextBox 31"/>
+          <p:cNvSpPr txBox="1"/>
+          <p:nvPr/>
+        </p:nvSpPr>
+        <p:spPr>
+          <a:xfrm>
+            <a:off x="6348599" y="4626000"/>
+            <a:ext cx="5484600" cy="342000"/>
+          </a:xfrm>
+          <a:prstGeom prst="rect">
+            <a:avLst/>
+          </a:prstGeom>
+          <a:noFill/>
+        </p:spPr>
+        <p:txBody>
+          <a:bodyPr wrap="square" lIns="28800" rIns="28800" tIns="14400" bIns="14400">
+            <a:spAutoFit/>
+          </a:bodyPr>
+          <a:lstStyle/>
+          <a:p>
+            <a:pPr algn="l"/>
+            <a:r>
+              <a:rPr sz="2400" b="1" i="0">
+                <a:solidFill>
+                  <a:srgbClr val="FFFFFF"/>
+                </a:solidFill>
+                <a:latin typeface="맑은 고딕"/>
+              </a:rPr>
+              <a:t>AI를 운영하는 은행으로</a:t>
+            </a:r>
+          </a:p>
+        </p:txBody>
+      </p:sp>
+      <p:sp>
+        <p:nvSpPr>
+          <p:cNvPr id="33" name="TextBox 32"/>
+          <p:cNvSpPr txBox="1"/>
+          <p:nvPr/>
+        </p:nvSpPr>
+        <p:spPr>
+          <a:xfrm>
+            <a:off x="0" y="6534000"/>
+            <a:ext cx="12193200" cy="234000"/>
+          </a:xfrm>
+          <a:prstGeom prst="rect">
+            <a:avLst/>
+          </a:prstGeom>
+          <a:noFill/>
+        </p:spPr>
+        <p:txBody>
+          <a:bodyPr wrap="square" lIns="28800" rIns="28800" tIns="14400" bIns="14400">
+            <a:spAutoFit/>
+          </a:bodyPr>
+          <a:lstStyle/>
+          <a:p>
+            <a:pPr algn="ctr"/>
+            <a:r>
+              <a:rPr sz="900" b="0" i="0">
+                <a:solidFill>
+                  <a:srgbClr val="20324A"/>
+                </a:solidFill>
+                <a:latin typeface="맑은 고딕"/>
+              </a:rPr>
+              <a:t>KT B2B 수주전략팀  ·  2026.05</a:t>
             </a:r>
           </a:p>
         </p:txBody>

</xml_diff>

<commit_message>
Redesign slide 1 — 4-layer stacked foundation (KT infra base)
- LAYER 04 (Surface): 대고객·대직원 안정감의 지속
- LAYER 03 (Control): 리스크 통제 (출처·감사·접근·품질 4축 가드레일)
- LAYER 02 (Platform): 비정형 데이터 플랫폼 (수집→저장→가공 chevron)
- LAYER 01 (Foundation): KT INFRASTRUCTURE — 8개 기둥으로 받치는 시각화
Each layer connected with upward arrows, WHY KT singular: 인프라 운영 DNA.

https://claude.ai/code/session_01FxEo1w4vu492E7Ycwid7Mr
</commit_message>
<xml_diff>
--- a/하나은행_AI_통제하는금융.pptx
+++ b/하나은행_AI_통제하는금융.pptx
@@ -3107,7 +3107,7 @@
         <p:spPr>
           <a:xfrm>
             <a:off x="0" y="0"/>
-            <a:ext cx="12193200" cy="1224000"/>
+            <a:ext cx="12193200" cy="1044000"/>
           </a:xfrm>
           <a:prstGeom prst="rect">
             <a:avLst/>
@@ -3150,13 +3150,13 @@
         <p:spPr>
           <a:xfrm>
             <a:off x="0" y="0"/>
-            <a:ext cx="90000" cy="1224000"/>
+            <a:ext cx="90000" cy="1044000"/>
           </a:xfrm>
           <a:prstGeom prst="rect">
             <a:avLst/>
           </a:prstGeom>
           <a:solidFill>
-            <a:srgbClr val="E31435"/>
+            <a:srgbClr val="E5B22D"/>
           </a:solidFill>
           <a:ln>
             <a:noFill/>
@@ -3192,14 +3192,14 @@
         </p:nvSpPr>
         <p:spPr>
           <a:xfrm>
-            <a:off x="432000" y="162000"/>
-            <a:ext cx="2880000" cy="198000"/>
+            <a:off x="432000" y="125999"/>
+            <a:ext cx="3420000" cy="180000"/>
           </a:xfrm>
           <a:prstGeom prst="rect">
             <a:avLst/>
           </a:prstGeom>
           <a:solidFill>
-            <a:srgbClr val="E31435"/>
+            <a:srgbClr val="E5B22D"/>
           </a:solidFill>
           <a:ln>
             <a:noFill/>
@@ -3235,8 +3235,8 @@
         </p:nvSpPr>
         <p:spPr>
           <a:xfrm>
-            <a:off x="432000" y="162000"/>
-            <a:ext cx="2880000" cy="198000"/>
+            <a:off x="432000" y="125999"/>
+            <a:ext cx="3420000" cy="180000"/>
           </a:xfrm>
           <a:prstGeom prst="rect">
             <a:avLst/>
@@ -3251,13 +3251,13 @@
           <a:p>
             <a:pPr algn="ctr"/>
             <a:r>
-              <a:rPr sz="1000" b="1" i="0">
-                <a:solidFill>
-                  <a:srgbClr val="FFFFFF"/>
-                </a:solidFill>
-                <a:latin typeface="맑은 고딕"/>
-              </a:rPr>
-              <a:t>AI 시대 금융의 통제권 전쟁  ·  WHY NOW</a:t>
+              <a:rPr sz="900" b="1" i="0">
+                <a:solidFill>
+                  <a:srgbClr val="07101E"/>
+                </a:solidFill>
+                <a:latin typeface="맑은 고딕"/>
+              </a:rPr>
+              <a:t>관통 메시지  ·  THE FOUNDATION OF TRUST</a:t>
             </a:r>
           </a:p>
         </p:txBody>
@@ -3270,8 +3270,8 @@
         </p:nvSpPr>
         <p:spPr>
           <a:xfrm>
-            <a:off x="432000" y="396000"/>
-            <a:ext cx="11329200" cy="432000"/>
+            <a:off x="432000" y="342000"/>
+            <a:ext cx="11329200" cy="378000"/>
           </a:xfrm>
           <a:prstGeom prst="rect">
             <a:avLst/>
@@ -3286,13 +3286,13 @@
           <a:p>
             <a:pPr algn="l"/>
             <a:r>
-              <a:rPr sz="2600" b="1" i="0">
+              <a:rPr sz="2300" b="1" i="0">
                 <a:solidFill>
                   <a:srgbClr val="FFFFFF"/>
                 </a:solidFill>
                 <a:latin typeface="맑은 고딕"/>
               </a:rPr>
-              <a:t>AI는 이미 충분히 똑똑해졌습니다. 이제 경쟁력은 통제력입니다.</a:t>
+              <a:t>리스크를 통제할 때, 고객과 직원의 안정감이 지속됩니다.</a:t>
             </a:r>
           </a:p>
         </p:txBody>
@@ -3305,8 +3305,8 @@
         </p:nvSpPr>
         <p:spPr>
           <a:xfrm>
-            <a:off x="432000" y="900000"/>
-            <a:ext cx="11329200" cy="251999"/>
+            <a:off x="432000" y="756000"/>
+            <a:ext cx="11329200" cy="216000"/>
           </a:xfrm>
           <a:prstGeom prst="rect">
             <a:avLst/>
@@ -3321,73 +3321,125 @@
           <a:p>
             <a:pPr algn="l"/>
             <a:r>
-              <a:rPr sz="1400" b="0">
+              <a:rPr sz="1200" b="0">
                 <a:solidFill>
                   <a:srgbClr val="CCD6E0"/>
                 </a:solidFill>
                 <a:latin typeface="맑은 고딕"/>
               </a:rPr>
-              <a:t>은행은 </a:t>
-            </a:r>
-            <a:r>
-              <a:rPr sz="1400" b="1">
+              <a:t>수집부터 가공까지  ─  </a:t>
+            </a:r>
+            <a:r>
+              <a:rPr sz="1200" b="1">
+                <a:solidFill>
+                  <a:srgbClr val="00D4FF"/>
+                </a:solidFill>
+                <a:latin typeface="맑은 고딕"/>
+              </a:rPr>
+              <a:t>AI 통제 가능한 비정형 데이터 플랫폼</a:t>
+            </a:r>
+            <a:r>
+              <a:rPr sz="1200" b="0">
+                <a:solidFill>
+                  <a:srgbClr val="CCD6E0"/>
+                </a:solidFill>
+                <a:latin typeface="맑은 고딕"/>
+              </a:rPr>
+              <a:t>이 그 토대입니다.</a:t>
+            </a:r>
+          </a:p>
+        </p:txBody>
+      </p:sp>
+      <p:sp>
+        <p:nvSpPr>
+          <p:cNvPr id="8" name="TextBox 7"/>
+          <p:cNvSpPr txBox="1"/>
+          <p:nvPr/>
+        </p:nvSpPr>
+        <p:spPr>
+          <a:xfrm>
+            <a:off x="9313200" y="342000"/>
+            <a:ext cx="2520000" cy="180000"/>
+          </a:xfrm>
+          <a:prstGeom prst="rect">
+            <a:avLst/>
+          </a:prstGeom>
+          <a:noFill/>
+        </p:spPr>
+        <p:txBody>
+          <a:bodyPr wrap="square" lIns="28800" rIns="28800" tIns="14400" bIns="14400">
+            <a:spAutoFit/>
+          </a:bodyPr>
+          <a:lstStyle/>
+          <a:p>
+            <a:pPr algn="r"/>
+            <a:r>
+              <a:rPr sz="900" b="0" i="1">
                 <a:solidFill>
                   <a:srgbClr val="A0B8CC"/>
                 </a:solidFill>
                 <a:latin typeface="맑은 고딕"/>
               </a:rPr>
-              <a:t>답변하는 조직</a:t>
-            </a:r>
-            <a:r>
-              <a:rPr sz="1400" b="0">
-                <a:solidFill>
-                  <a:srgbClr val="CCD6E0"/>
-                </a:solidFill>
-                <a:latin typeface="맑은 고딕"/>
-              </a:rPr>
-              <a:t>이 아니라  ─  </a:t>
-            </a:r>
-            <a:r>
-              <a:rPr sz="1400" b="1">
+              <a:t>▼  표면 (사람이 느끼는 것)</a:t>
+            </a:r>
+          </a:p>
+        </p:txBody>
+      </p:sp>
+      <p:sp>
+        <p:nvSpPr>
+          <p:cNvPr id="9" name="TextBox 8"/>
+          <p:cNvSpPr txBox="1"/>
+          <p:nvPr/>
+        </p:nvSpPr>
+        <p:spPr>
+          <a:xfrm>
+            <a:off x="9313200" y="540000"/>
+            <a:ext cx="2520000" cy="180000"/>
+          </a:xfrm>
+          <a:prstGeom prst="rect">
+            <a:avLst/>
+          </a:prstGeom>
+          <a:noFill/>
+        </p:spPr>
+        <p:txBody>
+          <a:bodyPr wrap="square" lIns="28800" rIns="28800" tIns="14400" bIns="14400">
+            <a:spAutoFit/>
+          </a:bodyPr>
+          <a:lstStyle/>
+          <a:p>
+            <a:pPr algn="r"/>
+            <a:r>
+              <a:rPr sz="900" b="0" i="1">
                 <a:solidFill>
                   <a:srgbClr val="E5B22D"/>
                 </a:solidFill>
                 <a:latin typeface="맑은 고딕"/>
               </a:rPr>
-              <a:t>책임지는 조직</a:t>
-            </a:r>
-            <a:r>
-              <a:rPr sz="1400" b="0">
-                <a:solidFill>
-                  <a:srgbClr val="CCD6E0"/>
-                </a:solidFill>
-                <a:latin typeface="맑은 고딕"/>
-              </a:rPr>
-              <a:t>입니다.</a:t>
-            </a:r>
-          </a:p>
-        </p:txBody>
-      </p:sp>
-      <p:sp>
-        <p:nvSpPr>
-          <p:cNvPr id="8" name="Rectangle 7"/>
+              <a:t>▲  토대 (받쳐주는 것)</a:t>
+            </a:r>
+          </a:p>
+        </p:txBody>
+      </p:sp>
+      <p:sp>
+        <p:nvSpPr>
+          <p:cNvPr id="10" name="Rectangle 9"/>
           <p:cNvSpPr/>
           <p:nvPr/>
         </p:nvSpPr>
         <p:spPr>
           <a:xfrm>
-            <a:off x="432000" y="1386000"/>
-            <a:ext cx="5556600" cy="4031999"/>
+            <a:off x="1529999" y="1116000"/>
+            <a:ext cx="10231201" cy="972000"/>
           </a:xfrm>
           <a:prstGeom prst="rect">
             <a:avLst/>
           </a:prstGeom>
           <a:solidFill>
-            <a:srgbClr val="0D1F3C"/>
+            <a:srgbClr val="1A170C"/>
           </a:solidFill>
-          <a:ln w="12700">
+          <a:ln w="7620">
             <a:solidFill>
-              <a:srgbClr val="FF4D4D"/>
+              <a:srgbClr val="E5B22D"/>
             </a:solidFill>
           </a:ln>
         </p:spPr>
@@ -3415,14 +3467,708 @@
       </p:sp>
       <p:sp>
         <p:nvSpPr>
-          <p:cNvPr id="9" name="Rectangle 8"/>
+          <p:cNvPr id="11" name="Rectangle 10"/>
           <p:cNvSpPr/>
           <p:nvPr/>
         </p:nvSpPr>
         <p:spPr>
           <a:xfrm>
-            <a:off x="432000" y="1386000"/>
-            <a:ext cx="64800" cy="4031999"/>
+            <a:off x="1529999" y="1116000"/>
+            <a:ext cx="64800" cy="972000"/>
+          </a:xfrm>
+          <a:prstGeom prst="rect">
+            <a:avLst/>
+          </a:prstGeom>
+          <a:solidFill>
+            <a:srgbClr val="E5B22D"/>
+          </a:solidFill>
+          <a:ln>
+            <a:noFill/>
+          </a:ln>
+        </p:spPr>
+        <p:style>
+          <a:lnRef idx="1">
+            <a:schemeClr val="accent1"/>
+          </a:lnRef>
+          <a:fillRef idx="3">
+            <a:schemeClr val="accent1"/>
+          </a:fillRef>
+          <a:effectRef idx="2">
+            <a:schemeClr val="accent1"/>
+          </a:effectRef>
+          <a:fontRef idx="minor">
+            <a:schemeClr val="lt1"/>
+          </a:fontRef>
+        </p:style>
+        <p:txBody>
+          <a:bodyPr rtlCol="0" anchor="ctr"/>
+          <a:lstStyle/>
+          <a:p>
+            <a:pPr algn="ctr"/>
+          </a:p>
+        </p:txBody>
+      </p:sp>
+      <p:sp>
+        <p:nvSpPr>
+          <p:cNvPr id="12" name="Rectangle 11"/>
+          <p:cNvSpPr/>
+          <p:nvPr/>
+        </p:nvSpPr>
+        <p:spPr>
+          <a:xfrm>
+            <a:off x="432000" y="1116000"/>
+            <a:ext cx="1007999" cy="972000"/>
+          </a:xfrm>
+          <a:prstGeom prst="rect">
+            <a:avLst/>
+          </a:prstGeom>
+          <a:solidFill>
+            <a:srgbClr val="0D1F3C"/>
+          </a:solidFill>
+          <a:ln w="5080">
+            <a:solidFill>
+              <a:srgbClr val="E5B22D"/>
+            </a:solidFill>
+          </a:ln>
+        </p:spPr>
+        <p:style>
+          <a:lnRef idx="1">
+            <a:schemeClr val="accent1"/>
+          </a:lnRef>
+          <a:fillRef idx="3">
+            <a:schemeClr val="accent1"/>
+          </a:fillRef>
+          <a:effectRef idx="2">
+            <a:schemeClr val="accent1"/>
+          </a:effectRef>
+          <a:fontRef idx="minor">
+            <a:schemeClr val="lt1"/>
+          </a:fontRef>
+        </p:style>
+        <p:txBody>
+          <a:bodyPr rtlCol="0" anchor="ctr"/>
+          <a:lstStyle/>
+          <a:p>
+            <a:pPr algn="ctr"/>
+          </a:p>
+        </p:txBody>
+      </p:sp>
+      <p:sp>
+        <p:nvSpPr>
+          <p:cNvPr id="13" name="TextBox 12"/>
+          <p:cNvSpPr txBox="1"/>
+          <p:nvPr/>
+        </p:nvSpPr>
+        <p:spPr>
+          <a:xfrm>
+            <a:off x="432000" y="1260000"/>
+            <a:ext cx="1007999" cy="162000"/>
+          </a:xfrm>
+          <a:prstGeom prst="rect">
+            <a:avLst/>
+          </a:prstGeom>
+          <a:noFill/>
+        </p:spPr>
+        <p:txBody>
+          <a:bodyPr wrap="square" lIns="28800" rIns="28800" tIns="14400" bIns="14400">
+            <a:spAutoFit/>
+          </a:bodyPr>
+          <a:lstStyle/>
+          <a:p>
+            <a:pPr algn="ctr"/>
+            <a:r>
+              <a:rPr sz="1000" b="1" i="0">
+                <a:solidFill>
+                  <a:srgbClr val="E5B22D"/>
+                </a:solidFill>
+                <a:latin typeface="맑은 고딕"/>
+              </a:rPr>
+              <a:t>LAYER 04</a:t>
+            </a:r>
+          </a:p>
+        </p:txBody>
+      </p:sp>
+      <p:sp>
+        <p:nvSpPr>
+          <p:cNvPr id="14" name="TextBox 13"/>
+          <p:cNvSpPr txBox="1"/>
+          <p:nvPr/>
+        </p:nvSpPr>
+        <p:spPr>
+          <a:xfrm>
+            <a:off x="432000" y="1422000"/>
+            <a:ext cx="1007999" cy="251999"/>
+          </a:xfrm>
+          <a:prstGeom prst="rect">
+            <a:avLst/>
+          </a:prstGeom>
+          <a:noFill/>
+        </p:spPr>
+        <p:txBody>
+          <a:bodyPr wrap="square" lIns="28800" rIns="28800" tIns="14400" bIns="14400">
+            <a:spAutoFit/>
+          </a:bodyPr>
+          <a:lstStyle/>
+          <a:p>
+            <a:pPr algn="ctr"/>
+            <a:r>
+              <a:rPr sz="1800" b="1" i="0">
+                <a:solidFill>
+                  <a:srgbClr val="FFFFFF"/>
+                </a:solidFill>
+                <a:latin typeface="맑은 고딕"/>
+              </a:rPr>
+              <a:t>표면</a:t>
+            </a:r>
+          </a:p>
+        </p:txBody>
+      </p:sp>
+      <p:sp>
+        <p:nvSpPr>
+          <p:cNvPr id="15" name="TextBox 14"/>
+          <p:cNvSpPr txBox="1"/>
+          <p:nvPr/>
+        </p:nvSpPr>
+        <p:spPr>
+          <a:xfrm>
+            <a:off x="432000" y="1674000"/>
+            <a:ext cx="1007999" cy="144000"/>
+          </a:xfrm>
+          <a:prstGeom prst="rect">
+            <a:avLst/>
+          </a:prstGeom>
+          <a:noFill/>
+        </p:spPr>
+        <p:txBody>
+          <a:bodyPr wrap="square" lIns="28800" rIns="28800" tIns="14400" bIns="14400">
+            <a:spAutoFit/>
+          </a:bodyPr>
+          <a:lstStyle/>
+          <a:p>
+            <a:pPr algn="ctr"/>
+            <a:r>
+              <a:rPr sz="800" b="0" i="1">
+                <a:solidFill>
+                  <a:srgbClr val="A0B8CC"/>
+                </a:solidFill>
+                <a:latin typeface="맑은 고딕"/>
+              </a:rPr>
+              <a:t>Surface</a:t>
+            </a:r>
+          </a:p>
+        </p:txBody>
+      </p:sp>
+      <p:sp>
+        <p:nvSpPr>
+          <p:cNvPr id="16" name="TextBox 15"/>
+          <p:cNvSpPr txBox="1"/>
+          <p:nvPr/>
+        </p:nvSpPr>
+        <p:spPr>
+          <a:xfrm>
+            <a:off x="1709999" y="1188000"/>
+            <a:ext cx="9871201" cy="198000"/>
+          </a:xfrm>
+          <a:prstGeom prst="rect">
+            <a:avLst/>
+          </a:prstGeom>
+          <a:noFill/>
+        </p:spPr>
+        <p:txBody>
+          <a:bodyPr wrap="square" lIns="28800" rIns="28800" tIns="14400" bIns="14400">
+            <a:spAutoFit/>
+          </a:bodyPr>
+          <a:lstStyle/>
+          <a:p>
+            <a:pPr algn="l"/>
+            <a:r>
+              <a:rPr sz="1200" b="1" i="0">
+                <a:solidFill>
+                  <a:srgbClr val="E5B22D"/>
+                </a:solidFill>
+                <a:latin typeface="맑은 고딕"/>
+              </a:rPr>
+              <a:t>안정감의 지속  ─  사람이 흔들리지 않는다</a:t>
+            </a:r>
+          </a:p>
+        </p:txBody>
+      </p:sp>
+      <p:sp>
+        <p:nvSpPr>
+          <p:cNvPr id="17" name="Rectangle 16"/>
+          <p:cNvSpPr/>
+          <p:nvPr/>
+        </p:nvSpPr>
+        <p:spPr>
+          <a:xfrm>
+            <a:off x="1709999" y="1422000"/>
+            <a:ext cx="4863600" cy="594000"/>
+          </a:xfrm>
+          <a:prstGeom prst="rect">
+            <a:avLst/>
+          </a:prstGeom>
+          <a:solidFill>
+            <a:srgbClr val="132A4D"/>
+          </a:solidFill>
+          <a:ln w="7620">
+            <a:solidFill>
+              <a:srgbClr val="00D4FF"/>
+            </a:solidFill>
+          </a:ln>
+        </p:spPr>
+        <p:style>
+          <a:lnRef idx="1">
+            <a:schemeClr val="accent1"/>
+          </a:lnRef>
+          <a:fillRef idx="3">
+            <a:schemeClr val="accent1"/>
+          </a:fillRef>
+          <a:effectRef idx="2">
+            <a:schemeClr val="accent1"/>
+          </a:effectRef>
+          <a:fontRef idx="minor">
+            <a:schemeClr val="lt1"/>
+          </a:fontRef>
+        </p:style>
+        <p:txBody>
+          <a:bodyPr rtlCol="0" anchor="ctr"/>
+          <a:lstStyle/>
+          <a:p>
+            <a:pPr algn="ctr"/>
+          </a:p>
+        </p:txBody>
+      </p:sp>
+      <p:sp>
+        <p:nvSpPr>
+          <p:cNvPr id="18" name="Oval 17"/>
+          <p:cNvSpPr/>
+          <p:nvPr/>
+        </p:nvSpPr>
+        <p:spPr>
+          <a:xfrm>
+            <a:off x="1853999" y="1547999"/>
+            <a:ext cx="306000" cy="306000"/>
+          </a:xfrm>
+          <a:prstGeom prst="ellipse">
+            <a:avLst/>
+          </a:prstGeom>
+          <a:solidFill>
+            <a:srgbClr val="00D4FF"/>
+          </a:solidFill>
+          <a:ln>
+            <a:noFill/>
+          </a:ln>
+        </p:spPr>
+        <p:style>
+          <a:lnRef idx="1">
+            <a:schemeClr val="accent1"/>
+          </a:lnRef>
+          <a:fillRef idx="3">
+            <a:schemeClr val="accent1"/>
+          </a:fillRef>
+          <a:effectRef idx="2">
+            <a:schemeClr val="accent1"/>
+          </a:effectRef>
+          <a:fontRef idx="minor">
+            <a:schemeClr val="lt1"/>
+          </a:fontRef>
+        </p:style>
+        <p:txBody>
+          <a:bodyPr rtlCol="0" anchor="ctr"/>
+          <a:lstStyle/>
+          <a:p>
+            <a:pPr algn="ctr"/>
+          </a:p>
+        </p:txBody>
+      </p:sp>
+      <p:sp>
+        <p:nvSpPr>
+          <p:cNvPr id="19" name="TextBox 18"/>
+          <p:cNvSpPr txBox="1"/>
+          <p:nvPr/>
+        </p:nvSpPr>
+        <p:spPr>
+          <a:xfrm>
+            <a:off x="1853999" y="1547999"/>
+            <a:ext cx="306000" cy="306000"/>
+          </a:xfrm>
+          <a:prstGeom prst="rect">
+            <a:avLst/>
+          </a:prstGeom>
+          <a:noFill/>
+        </p:spPr>
+        <p:txBody>
+          <a:bodyPr wrap="square" lIns="28800" rIns="28800" tIns="14400" bIns="14400">
+            <a:spAutoFit/>
+          </a:bodyPr>
+          <a:lstStyle/>
+          <a:p>
+            <a:pPr algn="ctr"/>
+            <a:r>
+              <a:rPr sz="1400" b="1" i="0">
+                <a:solidFill>
+                  <a:srgbClr val="07101E"/>
+                </a:solidFill>
+                <a:latin typeface="맑은 고딕"/>
+              </a:rPr>
+              <a:t>고</a:t>
+            </a:r>
+          </a:p>
+        </p:txBody>
+      </p:sp>
+      <p:sp>
+        <p:nvSpPr>
+          <p:cNvPr id="20" name="TextBox 19"/>
+          <p:cNvSpPr txBox="1"/>
+          <p:nvPr/>
+        </p:nvSpPr>
+        <p:spPr>
+          <a:xfrm>
+            <a:off x="2231999" y="1530000"/>
+            <a:ext cx="4251600" cy="180000"/>
+          </a:xfrm>
+          <a:prstGeom prst="rect">
+            <a:avLst/>
+          </a:prstGeom>
+          <a:noFill/>
+        </p:spPr>
+        <p:txBody>
+          <a:bodyPr wrap="square" lIns="28800" rIns="28800" tIns="14400" bIns="14400">
+            <a:spAutoFit/>
+          </a:bodyPr>
+          <a:lstStyle/>
+          <a:p>
+            <a:pPr algn="l"/>
+            <a:r>
+              <a:rPr sz="1100" b="1" i="0">
+                <a:solidFill>
+                  <a:srgbClr val="00D4FF"/>
+                </a:solidFill>
+                <a:latin typeface="맑은 고딕"/>
+              </a:rPr>
+              <a:t>대고객</a:t>
+            </a:r>
+          </a:p>
+        </p:txBody>
+      </p:sp>
+      <p:sp>
+        <p:nvSpPr>
+          <p:cNvPr id="21" name="TextBox 20"/>
+          <p:cNvSpPr txBox="1"/>
+          <p:nvPr/>
+        </p:nvSpPr>
+        <p:spPr>
+          <a:xfrm>
+            <a:off x="2231999" y="1702800"/>
+            <a:ext cx="4251600" cy="234000"/>
+          </a:xfrm>
+          <a:prstGeom prst="rect">
+            <a:avLst/>
+          </a:prstGeom>
+          <a:noFill/>
+        </p:spPr>
+        <p:txBody>
+          <a:bodyPr wrap="square" lIns="28800" rIns="28800" tIns="14400" bIns="14400">
+            <a:spAutoFit/>
+          </a:bodyPr>
+          <a:lstStyle/>
+          <a:p>
+            <a:pPr algn="l"/>
+            <a:r>
+              <a:rPr sz="1500" b="1" i="0">
+                <a:solidFill>
+                  <a:srgbClr val="FFFFFF"/>
+                </a:solidFill>
+                <a:latin typeface="맑은 고딕"/>
+              </a:rPr>
+              <a:t>흔들리지 않는 응대</a:t>
+            </a:r>
+          </a:p>
+        </p:txBody>
+      </p:sp>
+      <p:sp>
+        <p:nvSpPr>
+          <p:cNvPr id="22" name="Rectangle 21"/>
+          <p:cNvSpPr/>
+          <p:nvPr/>
+        </p:nvSpPr>
+        <p:spPr>
+          <a:xfrm>
+            <a:off x="6717599" y="1422000"/>
+            <a:ext cx="4863600" cy="594000"/>
+          </a:xfrm>
+          <a:prstGeom prst="rect">
+            <a:avLst/>
+          </a:prstGeom>
+          <a:solidFill>
+            <a:srgbClr val="132A4D"/>
+          </a:solidFill>
+          <a:ln w="7620">
+            <a:solidFill>
+              <a:srgbClr val="FFD700"/>
+            </a:solidFill>
+          </a:ln>
+        </p:spPr>
+        <p:style>
+          <a:lnRef idx="1">
+            <a:schemeClr val="accent1"/>
+          </a:lnRef>
+          <a:fillRef idx="3">
+            <a:schemeClr val="accent1"/>
+          </a:fillRef>
+          <a:effectRef idx="2">
+            <a:schemeClr val="accent1"/>
+          </a:effectRef>
+          <a:fontRef idx="minor">
+            <a:schemeClr val="lt1"/>
+          </a:fontRef>
+        </p:style>
+        <p:txBody>
+          <a:bodyPr rtlCol="0" anchor="ctr"/>
+          <a:lstStyle/>
+          <a:p>
+            <a:pPr algn="ctr"/>
+          </a:p>
+        </p:txBody>
+      </p:sp>
+      <p:sp>
+        <p:nvSpPr>
+          <p:cNvPr id="23" name="Oval 22"/>
+          <p:cNvSpPr/>
+          <p:nvPr/>
+        </p:nvSpPr>
+        <p:spPr>
+          <a:xfrm>
+            <a:off x="6861599" y="1547999"/>
+            <a:ext cx="306000" cy="306000"/>
+          </a:xfrm>
+          <a:prstGeom prst="ellipse">
+            <a:avLst/>
+          </a:prstGeom>
+          <a:solidFill>
+            <a:srgbClr val="FFD700"/>
+          </a:solidFill>
+          <a:ln>
+            <a:noFill/>
+          </a:ln>
+        </p:spPr>
+        <p:style>
+          <a:lnRef idx="1">
+            <a:schemeClr val="accent1"/>
+          </a:lnRef>
+          <a:fillRef idx="3">
+            <a:schemeClr val="accent1"/>
+          </a:fillRef>
+          <a:effectRef idx="2">
+            <a:schemeClr val="accent1"/>
+          </a:effectRef>
+          <a:fontRef idx="minor">
+            <a:schemeClr val="lt1"/>
+          </a:fontRef>
+        </p:style>
+        <p:txBody>
+          <a:bodyPr rtlCol="0" anchor="ctr"/>
+          <a:lstStyle/>
+          <a:p>
+            <a:pPr algn="ctr"/>
+          </a:p>
+        </p:txBody>
+      </p:sp>
+      <p:sp>
+        <p:nvSpPr>
+          <p:cNvPr id="24" name="TextBox 23"/>
+          <p:cNvSpPr txBox="1"/>
+          <p:nvPr/>
+        </p:nvSpPr>
+        <p:spPr>
+          <a:xfrm>
+            <a:off x="6861599" y="1547999"/>
+            <a:ext cx="306000" cy="306000"/>
+          </a:xfrm>
+          <a:prstGeom prst="rect">
+            <a:avLst/>
+          </a:prstGeom>
+          <a:noFill/>
+        </p:spPr>
+        <p:txBody>
+          <a:bodyPr wrap="square" lIns="28800" rIns="28800" tIns="14400" bIns="14400">
+            <a:spAutoFit/>
+          </a:bodyPr>
+          <a:lstStyle/>
+          <a:p>
+            <a:pPr algn="ctr"/>
+            <a:r>
+              <a:rPr sz="1400" b="1" i="0">
+                <a:solidFill>
+                  <a:srgbClr val="07101E"/>
+                </a:solidFill>
+                <a:latin typeface="맑은 고딕"/>
+              </a:rPr>
+              <a:t>직</a:t>
+            </a:r>
+          </a:p>
+        </p:txBody>
+      </p:sp>
+      <p:sp>
+        <p:nvSpPr>
+          <p:cNvPr id="25" name="TextBox 24"/>
+          <p:cNvSpPr txBox="1"/>
+          <p:nvPr/>
+        </p:nvSpPr>
+        <p:spPr>
+          <a:xfrm>
+            <a:off x="7239599" y="1530000"/>
+            <a:ext cx="4251600" cy="180000"/>
+          </a:xfrm>
+          <a:prstGeom prst="rect">
+            <a:avLst/>
+          </a:prstGeom>
+          <a:noFill/>
+        </p:spPr>
+        <p:txBody>
+          <a:bodyPr wrap="square" lIns="28800" rIns="28800" tIns="14400" bIns="14400">
+            <a:spAutoFit/>
+          </a:bodyPr>
+          <a:lstStyle/>
+          <a:p>
+            <a:pPr algn="l"/>
+            <a:r>
+              <a:rPr sz="1100" b="1" i="0">
+                <a:solidFill>
+                  <a:srgbClr val="FFD700"/>
+                </a:solidFill>
+                <a:latin typeface="맑은 고딕"/>
+              </a:rPr>
+              <a:t>대직원</a:t>
+            </a:r>
+          </a:p>
+        </p:txBody>
+      </p:sp>
+      <p:sp>
+        <p:nvSpPr>
+          <p:cNvPr id="26" name="TextBox 25"/>
+          <p:cNvSpPr txBox="1"/>
+          <p:nvPr/>
+        </p:nvSpPr>
+        <p:spPr>
+          <a:xfrm>
+            <a:off x="7239599" y="1702800"/>
+            <a:ext cx="4251600" cy="234000"/>
+          </a:xfrm>
+          <a:prstGeom prst="rect">
+            <a:avLst/>
+          </a:prstGeom>
+          <a:noFill/>
+        </p:spPr>
+        <p:txBody>
+          <a:bodyPr wrap="square" lIns="28800" rIns="28800" tIns="14400" bIns="14400">
+            <a:spAutoFit/>
+          </a:bodyPr>
+          <a:lstStyle/>
+          <a:p>
+            <a:pPr algn="l"/>
+            <a:r>
+              <a:rPr sz="1500" b="1" i="0">
+                <a:solidFill>
+                  <a:srgbClr val="FFFFFF"/>
+                </a:solidFill>
+                <a:latin typeface="맑은 고딕"/>
+              </a:rPr>
+              <a:t>흔들리지 않는 판단</a:t>
+            </a:r>
+          </a:p>
+        </p:txBody>
+      </p:sp>
+      <p:sp>
+        <p:nvSpPr>
+          <p:cNvPr id="27" name="TextBox 26"/>
+          <p:cNvSpPr txBox="1"/>
+          <p:nvPr/>
+        </p:nvSpPr>
+        <p:spPr>
+          <a:xfrm>
+            <a:off x="1529999" y="2088000"/>
+            <a:ext cx="10231201" cy="144000"/>
+          </a:xfrm>
+          <a:prstGeom prst="rect">
+            <a:avLst/>
+          </a:prstGeom>
+          <a:noFill/>
+        </p:spPr>
+        <p:txBody>
+          <a:bodyPr wrap="square" lIns="28800" rIns="28800" tIns="14400" bIns="14400">
+            <a:spAutoFit/>
+          </a:bodyPr>
+          <a:lstStyle/>
+          <a:p>
+            <a:pPr algn="ctr"/>
+            <a:r>
+              <a:rPr sz="900" b="0" i="1">
+                <a:solidFill>
+                  <a:srgbClr val="A0B8CC"/>
+                </a:solidFill>
+                <a:latin typeface="맑은 고딕"/>
+              </a:rPr>
+              <a:t>▲   보호받는다</a:t>
+            </a:r>
+          </a:p>
+        </p:txBody>
+      </p:sp>
+      <p:sp>
+        <p:nvSpPr>
+          <p:cNvPr id="28" name="Rectangle 27"/>
+          <p:cNvSpPr/>
+          <p:nvPr/>
+        </p:nvSpPr>
+        <p:spPr>
+          <a:xfrm>
+            <a:off x="1529999" y="2250000"/>
+            <a:ext cx="10231201" cy="756000"/>
+          </a:xfrm>
+          <a:prstGeom prst="rect">
+            <a:avLst/>
+          </a:prstGeom>
+          <a:solidFill>
+            <a:srgbClr val="0D1F3C"/>
+          </a:solidFill>
+          <a:ln w="8890">
+            <a:solidFill>
+              <a:srgbClr val="FF4D4D"/>
+            </a:solidFill>
+          </a:ln>
+        </p:spPr>
+        <p:style>
+          <a:lnRef idx="1">
+            <a:schemeClr val="accent1"/>
+          </a:lnRef>
+          <a:fillRef idx="3">
+            <a:schemeClr val="accent1"/>
+          </a:fillRef>
+          <a:effectRef idx="2">
+            <a:schemeClr val="accent1"/>
+          </a:effectRef>
+          <a:fontRef idx="minor">
+            <a:schemeClr val="lt1"/>
+          </a:fontRef>
+        </p:style>
+        <p:txBody>
+          <a:bodyPr rtlCol="0" anchor="ctr"/>
+          <a:lstStyle/>
+          <a:p>
+            <a:pPr algn="ctr"/>
+          </a:p>
+        </p:txBody>
+      </p:sp>
+      <p:sp>
+        <p:nvSpPr>
+          <p:cNvPr id="29" name="Rectangle 28"/>
+          <p:cNvSpPr/>
+          <p:nvPr/>
+        </p:nvSpPr>
+        <p:spPr>
+          <a:xfrm>
+            <a:off x="1529999" y="2250000"/>
+            <a:ext cx="64800" cy="756000"/>
           </a:xfrm>
           <a:prstGeom prst="rect">
             <a:avLst/>
@@ -3458,23 +4204,25 @@
       </p:sp>
       <p:sp>
         <p:nvSpPr>
-          <p:cNvPr id="10" name="Rectangle 9"/>
+          <p:cNvPr id="30" name="Rectangle 29"/>
           <p:cNvSpPr/>
           <p:nvPr/>
         </p:nvSpPr>
         <p:spPr>
           <a:xfrm>
-            <a:off x="648000" y="1566000"/>
-            <a:ext cx="1007999" cy="198000"/>
+            <a:off x="432000" y="2250000"/>
+            <a:ext cx="1007999" cy="756000"/>
           </a:xfrm>
           <a:prstGeom prst="rect">
             <a:avLst/>
           </a:prstGeom>
           <a:solidFill>
-            <a:srgbClr val="FF4D4D"/>
+            <a:srgbClr val="0D1F3C"/>
           </a:solidFill>
-          <a:ln>
-            <a:noFill/>
+          <a:ln w="5080">
+            <a:solidFill>
+              <a:srgbClr val="FF4D4D"/>
+            </a:solidFill>
           </a:ln>
         </p:spPr>
         <p:style>
@@ -3501,14 +4249,14 @@
       </p:sp>
       <p:sp>
         <p:nvSpPr>
-          <p:cNvPr id="11" name="TextBox 10"/>
+          <p:cNvPr id="31" name="TextBox 30"/>
           <p:cNvSpPr txBox="1"/>
           <p:nvPr/>
         </p:nvSpPr>
         <p:spPr>
           <a:xfrm>
-            <a:off x="648000" y="1566000"/>
-            <a:ext cx="1007999" cy="198000"/>
+            <a:off x="432000" y="2340000"/>
+            <a:ext cx="1007999" cy="162000"/>
           </a:xfrm>
           <a:prstGeom prst="rect">
             <a:avLst/>
@@ -3523,27 +4271,27 @@
           <a:p>
             <a:pPr algn="ctr"/>
             <a:r>
-              <a:rPr sz="800" b="1" i="0">
-                <a:solidFill>
-                  <a:srgbClr val="FFFFFF"/>
-                </a:solidFill>
-                <a:latin typeface="맑은 고딕"/>
-              </a:rPr>
-              <a:t>AI ORGANIZATIONAL RISK</a:t>
-            </a:r>
-          </a:p>
-        </p:txBody>
-      </p:sp>
-      <p:sp>
-        <p:nvSpPr>
-          <p:cNvPr id="12" name="TextBox 11"/>
+              <a:rPr sz="1000" b="1" i="0">
+                <a:solidFill>
+                  <a:srgbClr val="FF4D4D"/>
+                </a:solidFill>
+                <a:latin typeface="맑은 고딕"/>
+              </a:rPr>
+              <a:t>LAYER 03</a:t>
+            </a:r>
+          </a:p>
+        </p:txBody>
+      </p:sp>
+      <p:sp>
+        <p:nvSpPr>
+          <p:cNvPr id="32" name="TextBox 31"/>
           <p:cNvSpPr txBox="1"/>
           <p:nvPr/>
         </p:nvSpPr>
         <p:spPr>
           <a:xfrm>
-            <a:off x="648000" y="1799999"/>
-            <a:ext cx="5124600" cy="288000"/>
+            <a:off x="432000" y="2501999"/>
+            <a:ext cx="1007999" cy="251999"/>
           </a:xfrm>
           <a:prstGeom prst="rect">
             <a:avLst/>
@@ -3556,7 +4304,7 @@
           </a:bodyPr>
           <a:lstStyle/>
           <a:p>
-            <a:pPr algn="l"/>
+            <a:pPr algn="ctr"/>
             <a:r>
               <a:rPr sz="1800" b="1" i="0">
                 <a:solidFill>
@@ -3564,21 +4312,21 @@
                 </a:solidFill>
                 <a:latin typeface="맑은 고딕"/>
               </a:rPr>
-              <a:t>은행이 직면한 진짜 공포</a:t>
-            </a:r>
-          </a:p>
-        </p:txBody>
-      </p:sp>
-      <p:sp>
-        <p:nvSpPr>
-          <p:cNvPr id="13" name="TextBox 12"/>
+              <a:t>통제</a:t>
+            </a:r>
+          </a:p>
+        </p:txBody>
+      </p:sp>
+      <p:sp>
+        <p:nvSpPr>
+          <p:cNvPr id="33" name="TextBox 32"/>
           <p:cNvSpPr txBox="1"/>
           <p:nvPr/>
         </p:nvSpPr>
         <p:spPr>
           <a:xfrm>
-            <a:off x="648000" y="2088000"/>
-            <a:ext cx="5124600" cy="198000"/>
+            <a:off x="432000" y="2753999"/>
+            <a:ext cx="1007999" cy="144000"/>
           </a:xfrm>
           <a:prstGeom prst="rect">
             <a:avLst/>
@@ -3591,31 +4339,66 @@
           </a:bodyPr>
           <a:lstStyle/>
           <a:p>
+            <a:pPr algn="ctr"/>
+            <a:r>
+              <a:rPr sz="800" b="0" i="1">
+                <a:solidFill>
+                  <a:srgbClr val="A0B8CC"/>
+                </a:solidFill>
+                <a:latin typeface="맑은 고딕"/>
+              </a:rPr>
+              <a:t>Control</a:t>
+            </a:r>
+          </a:p>
+        </p:txBody>
+      </p:sp>
+      <p:sp>
+        <p:nvSpPr>
+          <p:cNvPr id="34" name="TextBox 33"/>
+          <p:cNvSpPr txBox="1"/>
+          <p:nvPr/>
+        </p:nvSpPr>
+        <p:spPr>
+          <a:xfrm>
+            <a:off x="1709999" y="2304000"/>
+            <a:ext cx="9871201" cy="180000"/>
+          </a:xfrm>
+          <a:prstGeom prst="rect">
+            <a:avLst/>
+          </a:prstGeom>
+          <a:noFill/>
+        </p:spPr>
+        <p:txBody>
+          <a:bodyPr wrap="square" lIns="28800" rIns="28800" tIns="14400" bIns="14400">
+            <a:spAutoFit/>
+          </a:bodyPr>
+          <a:lstStyle/>
+          <a:p>
             <a:pPr algn="l"/>
             <a:r>
-              <a:rPr sz="1100" b="0" i="1">
+              <a:rPr sz="1200" b="1" i="0">
                 <a:solidFill>
                   <a:srgbClr val="FF4D4D"/>
                 </a:solidFill>
                 <a:latin typeface="맑은 고딕"/>
               </a:rPr>
-              <a:t>기술 문제가 아닙니다. 은행의 의사결정 구조가 흔들리는 문제입니다.</a:t>
-            </a:r>
-          </a:p>
-        </p:txBody>
-      </p:sp>
-      <p:sp>
-        <p:nvSpPr>
-          <p:cNvPr id="14" name="Rectangle 13"/>
+              <a:t>리스크 통제  ─  4축 가드레일</a:t>
+            </a:r>
+          </a:p>
+        </p:txBody>
+      </p:sp>
+      <p:sp>
+        <p:nvSpPr>
+          <p:cNvPr id="35" name="Pentagon 34"/>
           <p:cNvSpPr/>
           <p:nvPr/>
         </p:nvSpPr>
         <p:spPr>
           <a:xfrm>
-            <a:off x="648000" y="2376000"/>
-            <a:ext cx="5124600" cy="666000"/>
-          </a:xfrm>
-          <a:prstGeom prst="rect">
+            <a:off x="1709999" y="2520000"/>
+            <a:ext cx="2400300" cy="414000"/>
+          </a:xfrm>
+          <a:prstGeom prst="homePlate">
             <a:avLst/>
           </a:prstGeom>
           <a:solidFill>
@@ -3623,7 +4406,7 @@
           </a:solidFill>
           <a:ln w="6350">
             <a:solidFill>
-              <a:srgbClr val="B82A2A"/>
+              <a:srgbClr val="FFD700"/>
             </a:solidFill>
           </a:ln>
         </p:spPr>
@@ -3651,20 +4434,20 @@
       </p:sp>
       <p:sp>
         <p:nvSpPr>
-          <p:cNvPr id="15" name="Rectangle 14"/>
+          <p:cNvPr id="36" name="Oval 35"/>
           <p:cNvSpPr/>
           <p:nvPr/>
         </p:nvSpPr>
         <p:spPr>
           <a:xfrm>
-            <a:off x="720000" y="2484000"/>
-            <a:ext cx="396000" cy="251999"/>
-          </a:xfrm>
-          <a:prstGeom prst="rect">
+            <a:off x="2852549" y="2574000"/>
+            <a:ext cx="115200" cy="115200"/>
+          </a:xfrm>
+          <a:prstGeom prst="ellipse">
             <a:avLst/>
           </a:prstGeom>
           <a:solidFill>
-            <a:srgbClr val="B82A2A"/>
+            <a:srgbClr val="FFD700"/>
           </a:solidFill>
           <a:ln>
             <a:noFill/>
@@ -3694,14 +4477,14 @@
       </p:sp>
       <p:sp>
         <p:nvSpPr>
-          <p:cNvPr id="16" name="TextBox 15"/>
+          <p:cNvPr id="37" name="TextBox 36"/>
           <p:cNvSpPr txBox="1"/>
           <p:nvPr/>
         </p:nvSpPr>
         <p:spPr>
           <a:xfrm>
-            <a:off x="720000" y="2484000"/>
-            <a:ext cx="396000" cy="251999"/>
+            <a:off x="1709999" y="2700000"/>
+            <a:ext cx="2400300" cy="198000"/>
           </a:xfrm>
           <a:prstGeom prst="rect">
             <a:avLst/>
@@ -3716,27 +4499,27 @@
           <a:p>
             <a:pPr algn="ctr"/>
             <a:r>
-              <a:rPr sz="1200" b="1" i="0">
-                <a:solidFill>
-                  <a:srgbClr val="FFFFFF"/>
-                </a:solidFill>
-                <a:latin typeface="맑은 고딕"/>
-              </a:rPr>
-              <a:t>Q1</a:t>
-            </a:r>
-          </a:p>
-        </p:txBody>
-      </p:sp>
-      <p:sp>
-        <p:nvSpPr>
-          <p:cNvPr id="17" name="TextBox 16"/>
+              <a:rPr sz="1300" b="1" i="0">
+                <a:solidFill>
+                  <a:srgbClr val="FFD700"/>
+                </a:solidFill>
+                <a:latin typeface="맑은 고딕"/>
+              </a:rPr>
+              <a:t>출처</a:t>
+            </a:r>
+          </a:p>
+        </p:txBody>
+      </p:sp>
+      <p:sp>
+        <p:nvSpPr>
+          <p:cNvPr id="38" name="TextBox 37"/>
           <p:cNvSpPr txBox="1"/>
           <p:nvPr/>
         </p:nvSpPr>
         <p:spPr>
           <a:xfrm>
-            <a:off x="1188000" y="2466000"/>
-            <a:ext cx="4548601" cy="251999"/>
+            <a:off x="1709999" y="2880000"/>
+            <a:ext cx="2400300" cy="144000"/>
           </a:xfrm>
           <a:prstGeom prst="rect">
             <a:avLst/>
@@ -3749,66 +4532,31 @@
           </a:bodyPr>
           <a:lstStyle/>
           <a:p>
-            <a:pPr algn="l"/>
-            <a:r>
-              <a:rPr sz="1300" b="1" i="0">
-                <a:solidFill>
-                  <a:srgbClr val="FFFFFF"/>
-                </a:solidFill>
-                <a:latin typeface="맑은 고딕"/>
-              </a:rPr>
-              <a:t>AI가 잘못 판단하면</a:t>
-            </a:r>
-          </a:p>
-        </p:txBody>
-      </p:sp>
-      <p:sp>
-        <p:nvSpPr>
-          <p:cNvPr id="18" name="TextBox 17"/>
-          <p:cNvSpPr txBox="1"/>
-          <p:nvPr/>
-        </p:nvSpPr>
-        <p:spPr>
-          <a:xfrm>
-            <a:off x="1188000" y="2718000"/>
-            <a:ext cx="4548601" cy="251999"/>
-          </a:xfrm>
-          <a:prstGeom prst="rect">
-            <a:avLst/>
-          </a:prstGeom>
-          <a:noFill/>
-        </p:spPr>
-        <p:txBody>
-          <a:bodyPr wrap="square" lIns="28800" rIns="28800" tIns="14400" bIns="14400">
-            <a:spAutoFit/>
-          </a:bodyPr>
-          <a:lstStyle/>
-          <a:p>
-            <a:pPr algn="l"/>
-            <a:r>
-              <a:rPr sz="1300" b="1" i="0">
-                <a:solidFill>
-                  <a:srgbClr val="FF4D4D"/>
-                </a:solidFill>
-                <a:latin typeface="맑은 고딕"/>
-              </a:rPr>
-              <a:t>— 누가 책임지는가?</a:t>
-            </a:r>
-          </a:p>
-        </p:txBody>
-      </p:sp>
-      <p:sp>
-        <p:nvSpPr>
-          <p:cNvPr id="19" name="Rectangle 18"/>
+            <a:pPr algn="ctr"/>
+            <a:r>
+              <a:rPr sz="800" b="0" i="1">
+                <a:solidFill>
+                  <a:srgbClr val="CCD6E0"/>
+                </a:solidFill>
+                <a:latin typeface="맑은 고딕"/>
+              </a:rPr>
+              <a:t>Provenance</a:t>
+            </a:r>
+          </a:p>
+        </p:txBody>
+      </p:sp>
+      <p:sp>
+        <p:nvSpPr>
+          <p:cNvPr id="39" name="Pentagon 38"/>
           <p:cNvSpPr/>
           <p:nvPr/>
         </p:nvSpPr>
         <p:spPr>
           <a:xfrm>
-            <a:off x="648000" y="3096000"/>
-            <a:ext cx="5124600" cy="666000"/>
-          </a:xfrm>
-          <a:prstGeom prst="rect">
+            <a:off x="4200299" y="2520000"/>
+            <a:ext cx="2400300" cy="414000"/>
+          </a:xfrm>
+          <a:prstGeom prst="homePlate">
             <a:avLst/>
           </a:prstGeom>
           <a:solidFill>
@@ -3816,7 +4564,7 @@
           </a:solidFill>
           <a:ln w="6350">
             <a:solidFill>
-              <a:srgbClr val="B82A2A"/>
+              <a:srgbClr val="B46BFF"/>
             </a:solidFill>
           </a:ln>
         </p:spPr>
@@ -3844,20 +4592,20 @@
       </p:sp>
       <p:sp>
         <p:nvSpPr>
-          <p:cNvPr id="20" name="Rectangle 19"/>
+          <p:cNvPr id="40" name="Oval 39"/>
           <p:cNvSpPr/>
           <p:nvPr/>
         </p:nvSpPr>
         <p:spPr>
           <a:xfrm>
-            <a:off x="720000" y="3204000"/>
-            <a:ext cx="396000" cy="251999"/>
-          </a:xfrm>
-          <a:prstGeom prst="rect">
+            <a:off x="5342849" y="2574000"/>
+            <a:ext cx="115200" cy="115200"/>
+          </a:xfrm>
+          <a:prstGeom prst="ellipse">
             <a:avLst/>
           </a:prstGeom>
           <a:solidFill>
-            <a:srgbClr val="B82A2A"/>
+            <a:srgbClr val="B46BFF"/>
           </a:solidFill>
           <a:ln>
             <a:noFill/>
@@ -3887,14 +4635,14 @@
       </p:sp>
       <p:sp>
         <p:nvSpPr>
-          <p:cNvPr id="21" name="TextBox 20"/>
+          <p:cNvPr id="41" name="TextBox 40"/>
           <p:cNvSpPr txBox="1"/>
           <p:nvPr/>
         </p:nvSpPr>
         <p:spPr>
           <a:xfrm>
-            <a:off x="720000" y="3204000"/>
-            <a:ext cx="396000" cy="251999"/>
+            <a:off x="4200299" y="2700000"/>
+            <a:ext cx="2400300" cy="198000"/>
           </a:xfrm>
           <a:prstGeom prst="rect">
             <a:avLst/>
@@ -3909,27 +4657,27 @@
           <a:p>
             <a:pPr algn="ctr"/>
             <a:r>
-              <a:rPr sz="1200" b="1" i="0">
-                <a:solidFill>
-                  <a:srgbClr val="FFFFFF"/>
-                </a:solidFill>
-                <a:latin typeface="맑은 고딕"/>
-              </a:rPr>
-              <a:t>Q2</a:t>
-            </a:r>
-          </a:p>
-        </p:txBody>
-      </p:sp>
-      <p:sp>
-        <p:nvSpPr>
-          <p:cNvPr id="22" name="TextBox 21"/>
+              <a:rPr sz="1300" b="1" i="0">
+                <a:solidFill>
+                  <a:srgbClr val="B46BFF"/>
+                </a:solidFill>
+                <a:latin typeface="맑은 고딕"/>
+              </a:rPr>
+              <a:t>감사</a:t>
+            </a:r>
+          </a:p>
+        </p:txBody>
+      </p:sp>
+      <p:sp>
+        <p:nvSpPr>
+          <p:cNvPr id="42" name="TextBox 41"/>
           <p:cNvSpPr txBox="1"/>
           <p:nvPr/>
         </p:nvSpPr>
         <p:spPr>
           <a:xfrm>
-            <a:off x="1188000" y="3186000"/>
-            <a:ext cx="4548601" cy="251999"/>
+            <a:off x="4200299" y="2880000"/>
+            <a:ext cx="2400300" cy="144000"/>
           </a:xfrm>
           <a:prstGeom prst="rect">
             <a:avLst/>
@@ -3942,811 +4690,31 @@
           </a:bodyPr>
           <a:lstStyle/>
           <a:p>
-            <a:pPr algn="l"/>
-            <a:r>
-              <a:rPr sz="1300" b="1" i="0">
-                <a:solidFill>
-                  <a:srgbClr val="FFFFFF"/>
-                </a:solidFill>
-                <a:latin typeface="맑은 고딕"/>
-              </a:rPr>
-              <a:t>직원이 AI만 믿기 시작하면</a:t>
-            </a:r>
-          </a:p>
-        </p:txBody>
-      </p:sp>
-      <p:sp>
-        <p:nvSpPr>
-          <p:cNvPr id="23" name="TextBox 22"/>
-          <p:cNvSpPr txBox="1"/>
-          <p:nvPr/>
-        </p:nvSpPr>
-        <p:spPr>
-          <a:xfrm>
-            <a:off x="1188000" y="3438000"/>
-            <a:ext cx="4548601" cy="251999"/>
-          </a:xfrm>
-          <a:prstGeom prst="rect">
-            <a:avLst/>
-          </a:prstGeom>
-          <a:noFill/>
-        </p:spPr>
-        <p:txBody>
-          <a:bodyPr wrap="square" lIns="28800" rIns="28800" tIns="14400" bIns="14400">
-            <a:spAutoFit/>
-          </a:bodyPr>
-          <a:lstStyle/>
-          <a:p>
-            <a:pPr algn="l"/>
-            <a:r>
-              <a:rPr sz="1300" b="1" i="0">
-                <a:solidFill>
-                  <a:srgbClr val="FF4D4D"/>
-                </a:solidFill>
-                <a:latin typeface="맑은 고딕"/>
-              </a:rPr>
-              <a:t>— 조직의 판단력은 어디로?</a:t>
-            </a:r>
-          </a:p>
-        </p:txBody>
-      </p:sp>
-      <p:sp>
-        <p:nvSpPr>
-          <p:cNvPr id="24" name="Rectangle 23"/>
+            <a:pPr algn="ctr"/>
+            <a:r>
+              <a:rPr sz="800" b="0" i="1">
+                <a:solidFill>
+                  <a:srgbClr val="CCD6E0"/>
+                </a:solidFill>
+                <a:latin typeface="맑은 고딕"/>
+              </a:rPr>
+              <a:t>Audit</a:t>
+            </a:r>
+          </a:p>
+        </p:txBody>
+      </p:sp>
+      <p:sp>
+        <p:nvSpPr>
+          <p:cNvPr id="43" name="Pentagon 42"/>
           <p:cNvSpPr/>
           <p:nvPr/>
         </p:nvSpPr>
         <p:spPr>
           <a:xfrm>
-            <a:off x="648000" y="3816000"/>
-            <a:ext cx="5124600" cy="666000"/>
-          </a:xfrm>
-          <a:prstGeom prst="rect">
-            <a:avLst/>
-          </a:prstGeom>
-          <a:solidFill>
-            <a:srgbClr val="132A4D"/>
-          </a:solidFill>
-          <a:ln w="6350">
-            <a:solidFill>
-              <a:srgbClr val="B82A2A"/>
-            </a:solidFill>
-          </a:ln>
-        </p:spPr>
-        <p:style>
-          <a:lnRef idx="1">
-            <a:schemeClr val="accent1"/>
-          </a:lnRef>
-          <a:fillRef idx="3">
-            <a:schemeClr val="accent1"/>
-          </a:fillRef>
-          <a:effectRef idx="2">
-            <a:schemeClr val="accent1"/>
-          </a:effectRef>
-          <a:fontRef idx="minor">
-            <a:schemeClr val="lt1"/>
-          </a:fontRef>
-        </p:style>
-        <p:txBody>
-          <a:bodyPr rtlCol="0" anchor="ctr"/>
-          <a:lstStyle/>
-          <a:p>
-            <a:pPr algn="ctr"/>
-          </a:p>
-        </p:txBody>
-      </p:sp>
-      <p:sp>
-        <p:nvSpPr>
-          <p:cNvPr id="25" name="Rectangle 24"/>
-          <p:cNvSpPr/>
-          <p:nvPr/>
-        </p:nvSpPr>
-        <p:spPr>
-          <a:xfrm>
-            <a:off x="720000" y="3924000"/>
-            <a:ext cx="396000" cy="251999"/>
-          </a:xfrm>
-          <a:prstGeom prst="rect">
-            <a:avLst/>
-          </a:prstGeom>
-          <a:solidFill>
-            <a:srgbClr val="B82A2A"/>
-          </a:solidFill>
-          <a:ln>
-            <a:noFill/>
-          </a:ln>
-        </p:spPr>
-        <p:style>
-          <a:lnRef idx="1">
-            <a:schemeClr val="accent1"/>
-          </a:lnRef>
-          <a:fillRef idx="3">
-            <a:schemeClr val="accent1"/>
-          </a:fillRef>
-          <a:effectRef idx="2">
-            <a:schemeClr val="accent1"/>
-          </a:effectRef>
-          <a:fontRef idx="minor">
-            <a:schemeClr val="lt1"/>
-          </a:fontRef>
-        </p:style>
-        <p:txBody>
-          <a:bodyPr rtlCol="0" anchor="ctr"/>
-          <a:lstStyle/>
-          <a:p>
-            <a:pPr algn="ctr"/>
-          </a:p>
-        </p:txBody>
-      </p:sp>
-      <p:sp>
-        <p:nvSpPr>
-          <p:cNvPr id="26" name="TextBox 25"/>
-          <p:cNvSpPr txBox="1"/>
-          <p:nvPr/>
-        </p:nvSpPr>
-        <p:spPr>
-          <a:xfrm>
-            <a:off x="720000" y="3924000"/>
-            <a:ext cx="396000" cy="251999"/>
-          </a:xfrm>
-          <a:prstGeom prst="rect">
-            <a:avLst/>
-          </a:prstGeom>
-          <a:noFill/>
-        </p:spPr>
-        <p:txBody>
-          <a:bodyPr wrap="square" lIns="28800" rIns="28800" tIns="14400" bIns="14400">
-            <a:spAutoFit/>
-          </a:bodyPr>
-          <a:lstStyle/>
-          <a:p>
-            <a:pPr algn="ctr"/>
-            <a:r>
-              <a:rPr sz="1200" b="1" i="0">
-                <a:solidFill>
-                  <a:srgbClr val="FFFFFF"/>
-                </a:solidFill>
-                <a:latin typeface="맑은 고딕"/>
-              </a:rPr>
-              <a:t>Q3</a:t>
-            </a:r>
-          </a:p>
-        </p:txBody>
-      </p:sp>
-      <p:sp>
-        <p:nvSpPr>
-          <p:cNvPr id="27" name="TextBox 26"/>
-          <p:cNvSpPr txBox="1"/>
-          <p:nvPr/>
-        </p:nvSpPr>
-        <p:spPr>
-          <a:xfrm>
-            <a:off x="1188000" y="3906000"/>
-            <a:ext cx="4548601" cy="251999"/>
-          </a:xfrm>
-          <a:prstGeom prst="rect">
-            <a:avLst/>
-          </a:prstGeom>
-          <a:noFill/>
-        </p:spPr>
-        <p:txBody>
-          <a:bodyPr wrap="square" lIns="28800" rIns="28800" tIns="14400" bIns="14400">
-            <a:spAutoFit/>
-          </a:bodyPr>
-          <a:lstStyle/>
-          <a:p>
-            <a:pPr algn="l"/>
-            <a:r>
-              <a:rPr sz="1300" b="1" i="0">
-                <a:solidFill>
-                  <a:srgbClr val="FFFFFF"/>
-                </a:solidFill>
-                <a:latin typeface="맑은 고딕"/>
-              </a:rPr>
-              <a:t>최신 규정과 충돌하는 답변이 나가면</a:t>
-            </a:r>
-          </a:p>
-        </p:txBody>
-      </p:sp>
-      <p:sp>
-        <p:nvSpPr>
-          <p:cNvPr id="28" name="TextBox 27"/>
-          <p:cNvSpPr txBox="1"/>
-          <p:nvPr/>
-        </p:nvSpPr>
-        <p:spPr>
-          <a:xfrm>
-            <a:off x="1188000" y="4158000"/>
-            <a:ext cx="4548601" cy="251999"/>
-          </a:xfrm>
-          <a:prstGeom prst="rect">
-            <a:avLst/>
-          </a:prstGeom>
-          <a:noFill/>
-        </p:spPr>
-        <p:txBody>
-          <a:bodyPr wrap="square" lIns="28800" rIns="28800" tIns="14400" bIns="14400">
-            <a:spAutoFit/>
-          </a:bodyPr>
-          <a:lstStyle/>
-          <a:p>
-            <a:pPr algn="l"/>
-            <a:r>
-              <a:rPr sz="1300" b="1" i="0">
-                <a:solidFill>
-                  <a:srgbClr val="FF4D4D"/>
-                </a:solidFill>
-                <a:latin typeface="맑은 고딕"/>
-              </a:rPr>
-              <a:t>— 어떻게 막는가?</a:t>
-            </a:r>
-          </a:p>
-        </p:txBody>
-      </p:sp>
-      <p:sp>
-        <p:nvSpPr>
-          <p:cNvPr id="29" name="Rectangle 28"/>
-          <p:cNvSpPr/>
-          <p:nvPr/>
-        </p:nvSpPr>
-        <p:spPr>
-          <a:xfrm>
-            <a:off x="648000" y="4536000"/>
-            <a:ext cx="5124600" cy="666000"/>
-          </a:xfrm>
-          <a:prstGeom prst="rect">
-            <a:avLst/>
-          </a:prstGeom>
-          <a:solidFill>
-            <a:srgbClr val="132A4D"/>
-          </a:solidFill>
-          <a:ln w="6350">
-            <a:solidFill>
-              <a:srgbClr val="B82A2A"/>
-            </a:solidFill>
-          </a:ln>
-        </p:spPr>
-        <p:style>
-          <a:lnRef idx="1">
-            <a:schemeClr val="accent1"/>
-          </a:lnRef>
-          <a:fillRef idx="3">
-            <a:schemeClr val="accent1"/>
-          </a:fillRef>
-          <a:effectRef idx="2">
-            <a:schemeClr val="accent1"/>
-          </a:effectRef>
-          <a:fontRef idx="minor">
-            <a:schemeClr val="lt1"/>
-          </a:fontRef>
-        </p:style>
-        <p:txBody>
-          <a:bodyPr rtlCol="0" anchor="ctr"/>
-          <a:lstStyle/>
-          <a:p>
-            <a:pPr algn="ctr"/>
-          </a:p>
-        </p:txBody>
-      </p:sp>
-      <p:sp>
-        <p:nvSpPr>
-          <p:cNvPr id="30" name="Rectangle 29"/>
-          <p:cNvSpPr/>
-          <p:nvPr/>
-        </p:nvSpPr>
-        <p:spPr>
-          <a:xfrm>
-            <a:off x="720000" y="4644000"/>
-            <a:ext cx="396000" cy="251999"/>
-          </a:xfrm>
-          <a:prstGeom prst="rect">
-            <a:avLst/>
-          </a:prstGeom>
-          <a:solidFill>
-            <a:srgbClr val="B82A2A"/>
-          </a:solidFill>
-          <a:ln>
-            <a:noFill/>
-          </a:ln>
-        </p:spPr>
-        <p:style>
-          <a:lnRef idx="1">
-            <a:schemeClr val="accent1"/>
-          </a:lnRef>
-          <a:fillRef idx="3">
-            <a:schemeClr val="accent1"/>
-          </a:fillRef>
-          <a:effectRef idx="2">
-            <a:schemeClr val="accent1"/>
-          </a:effectRef>
-          <a:fontRef idx="minor">
-            <a:schemeClr val="lt1"/>
-          </a:fontRef>
-        </p:style>
-        <p:txBody>
-          <a:bodyPr rtlCol="0" anchor="ctr"/>
-          <a:lstStyle/>
-          <a:p>
-            <a:pPr algn="ctr"/>
-          </a:p>
-        </p:txBody>
-      </p:sp>
-      <p:sp>
-        <p:nvSpPr>
-          <p:cNvPr id="31" name="TextBox 30"/>
-          <p:cNvSpPr txBox="1"/>
-          <p:nvPr/>
-        </p:nvSpPr>
-        <p:spPr>
-          <a:xfrm>
-            <a:off x="720000" y="4644000"/>
-            <a:ext cx="396000" cy="251999"/>
-          </a:xfrm>
-          <a:prstGeom prst="rect">
-            <a:avLst/>
-          </a:prstGeom>
-          <a:noFill/>
-        </p:spPr>
-        <p:txBody>
-          <a:bodyPr wrap="square" lIns="28800" rIns="28800" tIns="14400" bIns="14400">
-            <a:spAutoFit/>
-          </a:bodyPr>
-          <a:lstStyle/>
-          <a:p>
-            <a:pPr algn="ctr"/>
-            <a:r>
-              <a:rPr sz="1200" b="1" i="0">
-                <a:solidFill>
-                  <a:srgbClr val="FFFFFF"/>
-                </a:solidFill>
-                <a:latin typeface="맑은 고딕"/>
-              </a:rPr>
-              <a:t>Q4</a:t>
-            </a:r>
-          </a:p>
-        </p:txBody>
-      </p:sp>
-      <p:sp>
-        <p:nvSpPr>
-          <p:cNvPr id="32" name="TextBox 31"/>
-          <p:cNvSpPr txBox="1"/>
-          <p:nvPr/>
-        </p:nvSpPr>
-        <p:spPr>
-          <a:xfrm>
-            <a:off x="1188000" y="4626000"/>
-            <a:ext cx="4548601" cy="251999"/>
-          </a:xfrm>
-          <a:prstGeom prst="rect">
-            <a:avLst/>
-          </a:prstGeom>
-          <a:noFill/>
-        </p:spPr>
-        <p:txBody>
-          <a:bodyPr wrap="square" lIns="28800" rIns="28800" tIns="14400" bIns="14400">
-            <a:spAutoFit/>
-          </a:bodyPr>
-          <a:lstStyle/>
-          <a:p>
-            <a:pPr algn="l"/>
-            <a:r>
-              <a:rPr sz="1300" b="1" i="0">
-                <a:solidFill>
-                  <a:srgbClr val="FFFFFF"/>
-                </a:solidFill>
-                <a:latin typeface="맑은 고딕"/>
-              </a:rPr>
-              <a:t>감사 시점에 재현이 불가능하면</a:t>
-            </a:r>
-          </a:p>
-        </p:txBody>
-      </p:sp>
-      <p:sp>
-        <p:nvSpPr>
-          <p:cNvPr id="33" name="TextBox 32"/>
-          <p:cNvSpPr txBox="1"/>
-          <p:nvPr/>
-        </p:nvSpPr>
-        <p:spPr>
-          <a:xfrm>
-            <a:off x="1188000" y="4878000"/>
-            <a:ext cx="4548601" cy="251999"/>
-          </a:xfrm>
-          <a:prstGeom prst="rect">
-            <a:avLst/>
-          </a:prstGeom>
-          <a:noFill/>
-        </p:spPr>
-        <p:txBody>
-          <a:bodyPr wrap="square" lIns="28800" rIns="28800" tIns="14400" bIns="14400">
-            <a:spAutoFit/>
-          </a:bodyPr>
-          <a:lstStyle/>
-          <a:p>
-            <a:pPr algn="l"/>
-            <a:r>
-              <a:rPr sz="1300" b="1" i="0">
-                <a:solidFill>
-                  <a:srgbClr val="FF4D4D"/>
-                </a:solidFill>
-                <a:latin typeface="맑은 고딕"/>
-              </a:rPr>
-              <a:t>— 통제는 존재했다고 할 수 있는가?</a:t>
-            </a:r>
-          </a:p>
-        </p:txBody>
-      </p:sp>
-      <p:sp>
-        <p:nvSpPr>
-          <p:cNvPr id="34" name="Rectangle 33"/>
-          <p:cNvSpPr/>
-          <p:nvPr/>
-        </p:nvSpPr>
-        <p:spPr>
-          <a:xfrm>
-            <a:off x="6204600" y="1386000"/>
-            <a:ext cx="5556600" cy="4031999"/>
-          </a:xfrm>
-          <a:prstGeom prst="rect">
-            <a:avLst/>
-          </a:prstGeom>
-          <a:solidFill>
-            <a:srgbClr val="0D1F3C"/>
-          </a:solidFill>
-          <a:ln w="12700">
-            <a:solidFill>
-              <a:srgbClr val="00D4FF"/>
-            </a:solidFill>
-          </a:ln>
-        </p:spPr>
-        <p:style>
-          <a:lnRef idx="1">
-            <a:schemeClr val="accent1"/>
-          </a:lnRef>
-          <a:fillRef idx="3">
-            <a:schemeClr val="accent1"/>
-          </a:fillRef>
-          <a:effectRef idx="2">
-            <a:schemeClr val="accent1"/>
-          </a:effectRef>
-          <a:fontRef idx="minor">
-            <a:schemeClr val="lt1"/>
-          </a:fontRef>
-        </p:style>
-        <p:txBody>
-          <a:bodyPr rtlCol="0" anchor="ctr"/>
-          <a:lstStyle/>
-          <a:p>
-            <a:pPr algn="ctr"/>
-          </a:p>
-        </p:txBody>
-      </p:sp>
-      <p:sp>
-        <p:nvSpPr>
-          <p:cNvPr id="35" name="Rectangle 34"/>
-          <p:cNvSpPr/>
-          <p:nvPr/>
-        </p:nvSpPr>
-        <p:spPr>
-          <a:xfrm>
-            <a:off x="6204600" y="1386000"/>
-            <a:ext cx="64800" cy="4031999"/>
-          </a:xfrm>
-          <a:prstGeom prst="rect">
-            <a:avLst/>
-          </a:prstGeom>
-          <a:solidFill>
-            <a:srgbClr val="00D4FF"/>
-          </a:solidFill>
-          <a:ln>
-            <a:noFill/>
-          </a:ln>
-        </p:spPr>
-        <p:style>
-          <a:lnRef idx="1">
-            <a:schemeClr val="accent1"/>
-          </a:lnRef>
-          <a:fillRef idx="3">
-            <a:schemeClr val="accent1"/>
-          </a:fillRef>
-          <a:effectRef idx="2">
-            <a:schemeClr val="accent1"/>
-          </a:effectRef>
-          <a:fontRef idx="minor">
-            <a:schemeClr val="lt1"/>
-          </a:fontRef>
-        </p:style>
-        <p:txBody>
-          <a:bodyPr rtlCol="0" anchor="ctr"/>
-          <a:lstStyle/>
-          <a:p>
-            <a:pPr algn="ctr"/>
-          </a:p>
-        </p:txBody>
-      </p:sp>
-      <p:sp>
-        <p:nvSpPr>
-          <p:cNvPr id="36" name="Rectangle 35"/>
-          <p:cNvSpPr/>
-          <p:nvPr/>
-        </p:nvSpPr>
-        <p:spPr>
-          <a:xfrm>
-            <a:off x="6420600" y="1566000"/>
-            <a:ext cx="1007999" cy="198000"/>
-          </a:xfrm>
-          <a:prstGeom prst="rect">
-            <a:avLst/>
-          </a:prstGeom>
-          <a:solidFill>
-            <a:srgbClr val="00D4FF"/>
-          </a:solidFill>
-          <a:ln>
-            <a:noFill/>
-          </a:ln>
-        </p:spPr>
-        <p:style>
-          <a:lnRef idx="1">
-            <a:schemeClr val="accent1"/>
-          </a:lnRef>
-          <a:fillRef idx="3">
-            <a:schemeClr val="accent1"/>
-          </a:fillRef>
-          <a:effectRef idx="2">
-            <a:schemeClr val="accent1"/>
-          </a:effectRef>
-          <a:fontRef idx="minor">
-            <a:schemeClr val="lt1"/>
-          </a:fontRef>
-        </p:style>
-        <p:txBody>
-          <a:bodyPr rtlCol="0" anchor="ctr"/>
-          <a:lstStyle/>
-          <a:p>
-            <a:pPr algn="ctr"/>
-          </a:p>
-        </p:txBody>
-      </p:sp>
-      <p:sp>
-        <p:nvSpPr>
-          <p:cNvPr id="37" name="TextBox 36"/>
-          <p:cNvSpPr txBox="1"/>
-          <p:nvPr/>
-        </p:nvSpPr>
-        <p:spPr>
-          <a:xfrm>
-            <a:off x="6420600" y="1566000"/>
-            <a:ext cx="1007999" cy="198000"/>
-          </a:xfrm>
-          <a:prstGeom prst="rect">
-            <a:avLst/>
-          </a:prstGeom>
-          <a:noFill/>
-        </p:spPr>
-        <p:txBody>
-          <a:bodyPr wrap="square" lIns="28800" rIns="28800" tIns="14400" bIns="14400">
-            <a:spAutoFit/>
-          </a:bodyPr>
-          <a:lstStyle/>
-          <a:p>
-            <a:pPr algn="ctr"/>
-            <a:r>
-              <a:rPr sz="1000" b="1" i="0">
-                <a:solidFill>
-                  <a:srgbClr val="07101E"/>
-                </a:solidFill>
-                <a:latin typeface="맑은 고딕"/>
-              </a:rPr>
-              <a:t>WHY KT</a:t>
-            </a:r>
-          </a:p>
-        </p:txBody>
-      </p:sp>
-      <p:sp>
-        <p:nvSpPr>
-          <p:cNvPr id="38" name="TextBox 37"/>
-          <p:cNvSpPr txBox="1"/>
-          <p:nvPr/>
-        </p:nvSpPr>
-        <p:spPr>
-          <a:xfrm>
-            <a:off x="6420600" y="1799999"/>
-            <a:ext cx="5124600" cy="288000"/>
-          </a:xfrm>
-          <a:prstGeom prst="rect">
-            <a:avLst/>
-          </a:prstGeom>
-          <a:noFill/>
-        </p:spPr>
-        <p:txBody>
-          <a:bodyPr wrap="square" lIns="28800" rIns="28800" tIns="14400" bIns="14400">
-            <a:spAutoFit/>
-          </a:bodyPr>
-          <a:lstStyle/>
-          <a:p>
-            <a:pPr algn="l"/>
-            <a:r>
-              <a:rPr sz="1800" b="1" i="0">
-                <a:solidFill>
-                  <a:srgbClr val="FFFFFF"/>
-                </a:solidFill>
-                <a:latin typeface="맑은 고딕"/>
-              </a:rPr>
-              <a:t>통제권 전쟁의 답 — KT의 정체성</a:t>
-            </a:r>
-          </a:p>
-        </p:txBody>
-      </p:sp>
-      <p:sp>
-        <p:nvSpPr>
-          <p:cNvPr id="39" name="Rectangle 38"/>
-          <p:cNvSpPr/>
-          <p:nvPr/>
-        </p:nvSpPr>
-        <p:spPr>
-          <a:xfrm>
-            <a:off x="6420600" y="2106000"/>
-            <a:ext cx="5124600" cy="792000"/>
-          </a:xfrm>
-          <a:prstGeom prst="rect">
-            <a:avLst/>
-          </a:prstGeom>
-          <a:solidFill>
-            <a:srgbClr val="18335A"/>
-          </a:solidFill>
-          <a:ln w="9525">
-            <a:solidFill>
-              <a:srgbClr val="E5B22D"/>
-            </a:solidFill>
-          </a:ln>
-        </p:spPr>
-        <p:style>
-          <a:lnRef idx="1">
-            <a:schemeClr val="accent1"/>
-          </a:lnRef>
-          <a:fillRef idx="3">
-            <a:schemeClr val="accent1"/>
-          </a:fillRef>
-          <a:effectRef idx="2">
-            <a:schemeClr val="accent1"/>
-          </a:effectRef>
-          <a:fontRef idx="minor">
-            <a:schemeClr val="lt1"/>
-          </a:fontRef>
-        </p:style>
-        <p:txBody>
-          <a:bodyPr rtlCol="0" anchor="ctr"/>
-          <a:lstStyle/>
-          <a:p>
-            <a:pPr algn="ctr"/>
-          </a:p>
-        </p:txBody>
-      </p:sp>
-      <p:sp>
-        <p:nvSpPr>
-          <p:cNvPr id="40" name="Rectangle 39"/>
-          <p:cNvSpPr/>
-          <p:nvPr/>
-        </p:nvSpPr>
-        <p:spPr>
-          <a:xfrm>
-            <a:off x="6420600" y="2106000"/>
-            <a:ext cx="28800" cy="792000"/>
-          </a:xfrm>
-          <a:prstGeom prst="rect">
-            <a:avLst/>
-          </a:prstGeom>
-          <a:solidFill>
-            <a:srgbClr val="E5B22D"/>
-          </a:solidFill>
-          <a:ln>
-            <a:noFill/>
-          </a:ln>
-        </p:spPr>
-        <p:style>
-          <a:lnRef idx="1">
-            <a:schemeClr val="accent1"/>
-          </a:lnRef>
-          <a:fillRef idx="3">
-            <a:schemeClr val="accent1"/>
-          </a:fillRef>
-          <a:effectRef idx="2">
-            <a:schemeClr val="accent1"/>
-          </a:effectRef>
-          <a:fontRef idx="minor">
-            <a:schemeClr val="lt1"/>
-          </a:fontRef>
-        </p:style>
-        <p:txBody>
-          <a:bodyPr rtlCol="0" anchor="ctr"/>
-          <a:lstStyle/>
-          <a:p>
-            <a:pPr algn="ctr"/>
-          </a:p>
-        </p:txBody>
-      </p:sp>
-      <p:sp>
-        <p:nvSpPr>
-          <p:cNvPr id="41" name="TextBox 40"/>
-          <p:cNvSpPr txBox="1"/>
-          <p:nvPr/>
-        </p:nvSpPr>
-        <p:spPr>
-          <a:xfrm>
-            <a:off x="6528600" y="2214000"/>
-            <a:ext cx="4908600" cy="251999"/>
-          </a:xfrm>
-          <a:prstGeom prst="rect">
-            <a:avLst/>
-          </a:prstGeom>
-          <a:noFill/>
-        </p:spPr>
-        <p:txBody>
-          <a:bodyPr wrap="square" lIns="28800" rIns="28800" tIns="14400" bIns="14400">
-            <a:spAutoFit/>
-          </a:bodyPr>
-          <a:lstStyle/>
-          <a:p>
-            <a:pPr algn="l"/>
-            <a:r>
-              <a:rPr sz="1400" b="0" i="1">
-                <a:solidFill>
-                  <a:srgbClr val="CCD6E0"/>
-                </a:solidFill>
-                <a:latin typeface="맑은 고딕"/>
-              </a:rPr>
-              <a:t>KT는 AI를 화려하게 만드는 회사가 아닙니다.</a:t>
-            </a:r>
-          </a:p>
-        </p:txBody>
-      </p:sp>
-      <p:sp>
-        <p:nvSpPr>
-          <p:cNvPr id="42" name="TextBox 41"/>
-          <p:cNvSpPr txBox="1"/>
-          <p:nvPr/>
-        </p:nvSpPr>
-        <p:spPr>
-          <a:xfrm>
-            <a:off x="6528600" y="2466000"/>
-            <a:ext cx="4908600" cy="324000"/>
-          </a:xfrm>
-          <a:prstGeom prst="rect">
-            <a:avLst/>
-          </a:prstGeom>
-          <a:noFill/>
-        </p:spPr>
-        <p:txBody>
-          <a:bodyPr wrap="square" lIns="28800" rIns="28800" tIns="14400" bIns="14400">
-            <a:spAutoFit/>
-          </a:bodyPr>
-          <a:lstStyle/>
-          <a:p>
-            <a:pPr algn="l"/>
-            <a:r>
-              <a:rPr sz="1800" b="1" i="0">
-                <a:solidFill>
-                  <a:srgbClr val="E5B22D"/>
-                </a:solidFill>
-                <a:latin typeface="맑은 고딕"/>
-              </a:rPr>
-              <a:t>멈추면 안 되는 시스템을 운영해온 회사입니다.</a:t>
-            </a:r>
-          </a:p>
-        </p:txBody>
-      </p:sp>
-      <p:sp>
-        <p:nvSpPr>
-          <p:cNvPr id="43" name="Rectangle 42"/>
-          <p:cNvSpPr/>
-          <p:nvPr/>
-        </p:nvSpPr>
-        <p:spPr>
-          <a:xfrm>
-            <a:off x="6420600" y="3006000"/>
-            <a:ext cx="2526300" cy="1133999"/>
-          </a:xfrm>
-          <a:prstGeom prst="rect">
+            <a:off x="6690599" y="2520000"/>
+            <a:ext cx="2400300" cy="414000"/>
+          </a:xfrm>
+          <a:prstGeom prst="homePlate">
             <a:avLst/>
           </a:prstGeom>
           <a:solidFill>
@@ -4788,8 +4756,8 @@
         </p:nvSpPr>
         <p:spPr>
           <a:xfrm>
-            <a:off x="6528600" y="3114000"/>
-            <a:ext cx="144000" cy="144000"/>
+            <a:off x="7833149" y="2574000"/>
+            <a:ext cx="115200" cy="115200"/>
           </a:xfrm>
           <a:prstGeom prst="ellipse">
             <a:avLst/>
@@ -4831,8 +4799,8 @@
         </p:nvSpPr>
         <p:spPr>
           <a:xfrm>
-            <a:off x="6528600" y="3114000"/>
-            <a:ext cx="144000" cy="144000"/>
+            <a:off x="6690599" y="2700000"/>
+            <a:ext cx="2400300" cy="198000"/>
           </a:xfrm>
           <a:prstGeom prst="rect">
             <a:avLst/>
@@ -4847,13 +4815,13 @@
           <a:p>
             <a:pPr algn="ctr"/>
             <a:r>
-              <a:rPr sz="900" b="1" i="0">
-                <a:solidFill>
-                  <a:srgbClr val="07101E"/>
-                </a:solidFill>
-                <a:latin typeface="맑은 고딕"/>
-              </a:rPr>
-              <a:t>1</a:t>
+              <a:rPr sz="1300" b="1" i="0">
+                <a:solidFill>
+                  <a:srgbClr val="00D4FF"/>
+                </a:solidFill>
+                <a:latin typeface="맑은 고딕"/>
+              </a:rPr>
+              <a:t>접근</a:t>
             </a:r>
           </a:p>
         </p:txBody>
@@ -4866,8 +4834,8 @@
         </p:nvSpPr>
         <p:spPr>
           <a:xfrm>
-            <a:off x="6726600" y="3096000"/>
-            <a:ext cx="2166300" cy="216000"/>
+            <a:off x="6690599" y="2880000"/>
+            <a:ext cx="2400300" cy="144000"/>
           </a:xfrm>
           <a:prstGeom prst="rect">
             <a:avLst/>
@@ -4880,29 +4848,117 @@
           </a:bodyPr>
           <a:lstStyle/>
           <a:p>
-            <a:pPr algn="l"/>
-            <a:r>
-              <a:rPr sz="1300" b="1" i="0">
-                <a:solidFill>
-                  <a:srgbClr val="00D4FF"/>
-                </a:solidFill>
-                <a:latin typeface="맑은 고딕"/>
-              </a:rPr>
-              <a:t>국가 인프라 DNA</a:t>
-            </a:r>
-          </a:p>
-        </p:txBody>
-      </p:sp>
-      <p:sp>
-        <p:nvSpPr>
-          <p:cNvPr id="47" name="TextBox 46"/>
+            <a:pPr algn="ctr"/>
+            <a:r>
+              <a:rPr sz="800" b="0" i="1">
+                <a:solidFill>
+                  <a:srgbClr val="CCD6E0"/>
+                </a:solidFill>
+                <a:latin typeface="맑은 고딕"/>
+              </a:rPr>
+              <a:t>Access</a:t>
+            </a:r>
+          </a:p>
+        </p:txBody>
+      </p:sp>
+      <p:sp>
+        <p:nvSpPr>
+          <p:cNvPr id="47" name="Pentagon 46"/>
+          <p:cNvSpPr/>
+          <p:nvPr/>
+        </p:nvSpPr>
+        <p:spPr>
+          <a:xfrm>
+            <a:off x="9180899" y="2520000"/>
+            <a:ext cx="2400300" cy="414000"/>
+          </a:xfrm>
+          <a:prstGeom prst="homePlate">
+            <a:avLst/>
+          </a:prstGeom>
+          <a:solidFill>
+            <a:srgbClr val="132A4D"/>
+          </a:solidFill>
+          <a:ln w="6350">
+            <a:solidFill>
+              <a:srgbClr val="00E096"/>
+            </a:solidFill>
+          </a:ln>
+        </p:spPr>
+        <p:style>
+          <a:lnRef idx="1">
+            <a:schemeClr val="accent1"/>
+          </a:lnRef>
+          <a:fillRef idx="3">
+            <a:schemeClr val="accent1"/>
+          </a:fillRef>
+          <a:effectRef idx="2">
+            <a:schemeClr val="accent1"/>
+          </a:effectRef>
+          <a:fontRef idx="minor">
+            <a:schemeClr val="lt1"/>
+          </a:fontRef>
+        </p:style>
+        <p:txBody>
+          <a:bodyPr rtlCol="0" anchor="ctr"/>
+          <a:lstStyle/>
+          <a:p>
+            <a:pPr algn="ctr"/>
+          </a:p>
+        </p:txBody>
+      </p:sp>
+      <p:sp>
+        <p:nvSpPr>
+          <p:cNvPr id="48" name="Oval 47"/>
+          <p:cNvSpPr/>
+          <p:nvPr/>
+        </p:nvSpPr>
+        <p:spPr>
+          <a:xfrm>
+            <a:off x="10323449" y="2574000"/>
+            <a:ext cx="115200" cy="115200"/>
+          </a:xfrm>
+          <a:prstGeom prst="ellipse">
+            <a:avLst/>
+          </a:prstGeom>
+          <a:solidFill>
+            <a:srgbClr val="00E096"/>
+          </a:solidFill>
+          <a:ln>
+            <a:noFill/>
+          </a:ln>
+        </p:spPr>
+        <p:style>
+          <a:lnRef idx="1">
+            <a:schemeClr val="accent1"/>
+          </a:lnRef>
+          <a:fillRef idx="3">
+            <a:schemeClr val="accent1"/>
+          </a:fillRef>
+          <a:effectRef idx="2">
+            <a:schemeClr val="accent1"/>
+          </a:effectRef>
+          <a:fontRef idx="minor">
+            <a:schemeClr val="lt1"/>
+          </a:fontRef>
+        </p:style>
+        <p:txBody>
+          <a:bodyPr rtlCol="0" anchor="ctr"/>
+          <a:lstStyle/>
+          <a:p>
+            <a:pPr algn="ctr"/>
+          </a:p>
+        </p:txBody>
+      </p:sp>
+      <p:sp>
+        <p:nvSpPr>
+          <p:cNvPr id="49" name="TextBox 48"/>
           <p:cNvSpPr txBox="1"/>
           <p:nvPr/>
         </p:nvSpPr>
         <p:spPr>
           <a:xfrm>
-            <a:off x="6546599" y="3348000"/>
-            <a:ext cx="2346300" cy="198000"/>
+            <a:off x="9180899" y="2700000"/>
+            <a:ext cx="2400300" cy="198000"/>
           </a:xfrm>
           <a:prstGeom prst="rect">
             <a:avLst/>
@@ -4915,29 +4971,29 @@
           </a:bodyPr>
           <a:lstStyle/>
           <a:p>
-            <a:pPr algn="l"/>
-            <a:r>
-              <a:rPr sz="1100" b="0" i="0">
-                <a:solidFill>
-                  <a:srgbClr val="FFFFFF"/>
-                </a:solidFill>
-                <a:latin typeface="맑은 고딕"/>
-              </a:rPr>
-              <a:t>통신망 24×365 운영</a:t>
-            </a:r>
-          </a:p>
-        </p:txBody>
-      </p:sp>
-      <p:sp>
-        <p:nvSpPr>
-          <p:cNvPr id="48" name="TextBox 47"/>
+            <a:pPr algn="ctr"/>
+            <a:r>
+              <a:rPr sz="1300" b="1" i="0">
+                <a:solidFill>
+                  <a:srgbClr val="00E096"/>
+                </a:solidFill>
+                <a:latin typeface="맑은 고딕"/>
+              </a:rPr>
+              <a:t>품질</a:t>
+            </a:r>
+          </a:p>
+        </p:txBody>
+      </p:sp>
+      <p:sp>
+        <p:nvSpPr>
+          <p:cNvPr id="50" name="TextBox 49"/>
           <p:cNvSpPr txBox="1"/>
           <p:nvPr/>
         </p:nvSpPr>
         <p:spPr>
           <a:xfrm>
-            <a:off x="6546599" y="3546000"/>
-            <a:ext cx="2346300" cy="198000"/>
+            <a:off x="9180899" y="2880000"/>
+            <a:ext cx="2400300" cy="144000"/>
           </a:xfrm>
           <a:prstGeom prst="rect">
             <a:avLst/>
@@ -4950,29 +5006,337 @@
           </a:bodyPr>
           <a:lstStyle/>
           <a:p>
+            <a:pPr algn="ctr"/>
+            <a:r>
+              <a:rPr sz="800" b="0" i="1">
+                <a:solidFill>
+                  <a:srgbClr val="CCD6E0"/>
+                </a:solidFill>
+                <a:latin typeface="맑은 고딕"/>
+              </a:rPr>
+              <a:t>Quality</a:t>
+            </a:r>
+          </a:p>
+        </p:txBody>
+      </p:sp>
+      <p:sp>
+        <p:nvSpPr>
+          <p:cNvPr id="51" name="TextBox 50"/>
+          <p:cNvSpPr txBox="1"/>
+          <p:nvPr/>
+        </p:nvSpPr>
+        <p:spPr>
+          <a:xfrm>
+            <a:off x="1529999" y="3006000"/>
+            <a:ext cx="10231201" cy="144000"/>
+          </a:xfrm>
+          <a:prstGeom prst="rect">
+            <a:avLst/>
+          </a:prstGeom>
+          <a:noFill/>
+        </p:spPr>
+        <p:txBody>
+          <a:bodyPr wrap="square" lIns="28800" rIns="28800" tIns="14400" bIns="14400">
+            <a:spAutoFit/>
+          </a:bodyPr>
+          <a:lstStyle/>
+          <a:p>
+            <a:pPr algn="ctr"/>
+            <a:r>
+              <a:rPr sz="900" b="0" i="1">
+                <a:solidFill>
+                  <a:srgbClr val="A0B8CC"/>
+                </a:solidFill>
+                <a:latin typeface="맑은 고딕"/>
+              </a:rPr>
+              <a:t>▲   통제 가능한 형태로 가공되어 올라온다</a:t>
+            </a:r>
+          </a:p>
+        </p:txBody>
+      </p:sp>
+      <p:sp>
+        <p:nvSpPr>
+          <p:cNvPr id="52" name="Rectangle 51"/>
+          <p:cNvSpPr/>
+          <p:nvPr/>
+        </p:nvSpPr>
+        <p:spPr>
+          <a:xfrm>
+            <a:off x="1529999" y="3168000"/>
+            <a:ext cx="10231201" cy="827999"/>
+          </a:xfrm>
+          <a:prstGeom prst="rect">
+            <a:avLst/>
+          </a:prstGeom>
+          <a:solidFill>
+            <a:srgbClr val="0D1F3C"/>
+          </a:solidFill>
+          <a:ln w="8890">
+            <a:solidFill>
+              <a:srgbClr val="00D4FF"/>
+            </a:solidFill>
+          </a:ln>
+        </p:spPr>
+        <p:style>
+          <a:lnRef idx="1">
+            <a:schemeClr val="accent1"/>
+          </a:lnRef>
+          <a:fillRef idx="3">
+            <a:schemeClr val="accent1"/>
+          </a:fillRef>
+          <a:effectRef idx="2">
+            <a:schemeClr val="accent1"/>
+          </a:effectRef>
+          <a:fontRef idx="minor">
+            <a:schemeClr val="lt1"/>
+          </a:fontRef>
+        </p:style>
+        <p:txBody>
+          <a:bodyPr rtlCol="0" anchor="ctr"/>
+          <a:lstStyle/>
+          <a:p>
+            <a:pPr algn="ctr"/>
+          </a:p>
+        </p:txBody>
+      </p:sp>
+      <p:sp>
+        <p:nvSpPr>
+          <p:cNvPr id="53" name="Rectangle 52"/>
+          <p:cNvSpPr/>
+          <p:nvPr/>
+        </p:nvSpPr>
+        <p:spPr>
+          <a:xfrm>
+            <a:off x="1529999" y="3168000"/>
+            <a:ext cx="64800" cy="827999"/>
+          </a:xfrm>
+          <a:prstGeom prst="rect">
+            <a:avLst/>
+          </a:prstGeom>
+          <a:solidFill>
+            <a:srgbClr val="00D4FF"/>
+          </a:solidFill>
+          <a:ln>
+            <a:noFill/>
+          </a:ln>
+        </p:spPr>
+        <p:style>
+          <a:lnRef idx="1">
+            <a:schemeClr val="accent1"/>
+          </a:lnRef>
+          <a:fillRef idx="3">
+            <a:schemeClr val="accent1"/>
+          </a:fillRef>
+          <a:effectRef idx="2">
+            <a:schemeClr val="accent1"/>
+          </a:effectRef>
+          <a:fontRef idx="minor">
+            <a:schemeClr val="lt1"/>
+          </a:fontRef>
+        </p:style>
+        <p:txBody>
+          <a:bodyPr rtlCol="0" anchor="ctr"/>
+          <a:lstStyle/>
+          <a:p>
+            <a:pPr algn="ctr"/>
+          </a:p>
+        </p:txBody>
+      </p:sp>
+      <p:sp>
+        <p:nvSpPr>
+          <p:cNvPr id="54" name="Rectangle 53"/>
+          <p:cNvSpPr/>
+          <p:nvPr/>
+        </p:nvSpPr>
+        <p:spPr>
+          <a:xfrm>
+            <a:off x="432000" y="3168000"/>
+            <a:ext cx="1007999" cy="827999"/>
+          </a:xfrm>
+          <a:prstGeom prst="rect">
+            <a:avLst/>
+          </a:prstGeom>
+          <a:solidFill>
+            <a:srgbClr val="0D1F3C"/>
+          </a:solidFill>
+          <a:ln w="5080">
+            <a:solidFill>
+              <a:srgbClr val="00D4FF"/>
+            </a:solidFill>
+          </a:ln>
+        </p:spPr>
+        <p:style>
+          <a:lnRef idx="1">
+            <a:schemeClr val="accent1"/>
+          </a:lnRef>
+          <a:fillRef idx="3">
+            <a:schemeClr val="accent1"/>
+          </a:fillRef>
+          <a:effectRef idx="2">
+            <a:schemeClr val="accent1"/>
+          </a:effectRef>
+          <a:fontRef idx="minor">
+            <a:schemeClr val="lt1"/>
+          </a:fontRef>
+        </p:style>
+        <p:txBody>
+          <a:bodyPr rtlCol="0" anchor="ctr"/>
+          <a:lstStyle/>
+          <a:p>
+            <a:pPr algn="ctr"/>
+          </a:p>
+        </p:txBody>
+      </p:sp>
+      <p:sp>
+        <p:nvSpPr>
+          <p:cNvPr id="55" name="TextBox 54"/>
+          <p:cNvSpPr txBox="1"/>
+          <p:nvPr/>
+        </p:nvSpPr>
+        <p:spPr>
+          <a:xfrm>
+            <a:off x="432000" y="3276000"/>
+            <a:ext cx="1007999" cy="162000"/>
+          </a:xfrm>
+          <a:prstGeom prst="rect">
+            <a:avLst/>
+          </a:prstGeom>
+          <a:noFill/>
+        </p:spPr>
+        <p:txBody>
+          <a:bodyPr wrap="square" lIns="28800" rIns="28800" tIns="14400" bIns="14400">
+            <a:spAutoFit/>
+          </a:bodyPr>
+          <a:lstStyle/>
+          <a:p>
+            <a:pPr algn="ctr"/>
+            <a:r>
+              <a:rPr sz="1000" b="1" i="0">
+                <a:solidFill>
+                  <a:srgbClr val="00D4FF"/>
+                </a:solidFill>
+                <a:latin typeface="맑은 고딕"/>
+              </a:rPr>
+              <a:t>LAYER 02</a:t>
+            </a:r>
+          </a:p>
+        </p:txBody>
+      </p:sp>
+      <p:sp>
+        <p:nvSpPr>
+          <p:cNvPr id="56" name="TextBox 55"/>
+          <p:cNvSpPr txBox="1"/>
+          <p:nvPr/>
+        </p:nvSpPr>
+        <p:spPr>
+          <a:xfrm>
+            <a:off x="432000" y="3448800"/>
+            <a:ext cx="1007999" cy="251999"/>
+          </a:xfrm>
+          <a:prstGeom prst="rect">
+            <a:avLst/>
+          </a:prstGeom>
+          <a:noFill/>
+        </p:spPr>
+        <p:txBody>
+          <a:bodyPr wrap="square" lIns="28800" rIns="28800" tIns="14400" bIns="14400">
+            <a:spAutoFit/>
+          </a:bodyPr>
+          <a:lstStyle/>
+          <a:p>
+            <a:pPr algn="ctr"/>
+            <a:r>
+              <a:rPr sz="1800" b="1" i="0">
+                <a:solidFill>
+                  <a:srgbClr val="FFFFFF"/>
+                </a:solidFill>
+                <a:latin typeface="맑은 고딕"/>
+              </a:rPr>
+              <a:t>플랫폼</a:t>
+            </a:r>
+          </a:p>
+        </p:txBody>
+      </p:sp>
+      <p:sp>
+        <p:nvSpPr>
+          <p:cNvPr id="57" name="TextBox 56"/>
+          <p:cNvSpPr txBox="1"/>
+          <p:nvPr/>
+        </p:nvSpPr>
+        <p:spPr>
+          <a:xfrm>
+            <a:off x="432000" y="3708000"/>
+            <a:ext cx="1007999" cy="144000"/>
+          </a:xfrm>
+          <a:prstGeom prst="rect">
+            <a:avLst/>
+          </a:prstGeom>
+          <a:noFill/>
+        </p:spPr>
+        <p:txBody>
+          <a:bodyPr wrap="square" lIns="28800" rIns="28800" tIns="14400" bIns="14400">
+            <a:spAutoFit/>
+          </a:bodyPr>
+          <a:lstStyle/>
+          <a:p>
+            <a:pPr algn="ctr"/>
+            <a:r>
+              <a:rPr sz="800" b="0" i="1">
+                <a:solidFill>
+                  <a:srgbClr val="A0B8CC"/>
+                </a:solidFill>
+                <a:latin typeface="맑은 고딕"/>
+              </a:rPr>
+              <a:t>Platform</a:t>
+            </a:r>
+          </a:p>
+        </p:txBody>
+      </p:sp>
+      <p:sp>
+        <p:nvSpPr>
+          <p:cNvPr id="58" name="TextBox 57"/>
+          <p:cNvSpPr txBox="1"/>
+          <p:nvPr/>
+        </p:nvSpPr>
+        <p:spPr>
+          <a:xfrm>
+            <a:off x="1709999" y="3222000"/>
+            <a:ext cx="9871201" cy="180000"/>
+          </a:xfrm>
+          <a:prstGeom prst="rect">
+            <a:avLst/>
+          </a:prstGeom>
+          <a:noFill/>
+        </p:spPr>
+        <p:txBody>
+          <a:bodyPr wrap="square" lIns="28800" rIns="28800" tIns="14400" bIns="14400">
+            <a:spAutoFit/>
+          </a:bodyPr>
+          <a:lstStyle/>
+          <a:p>
             <a:pPr algn="l"/>
             <a:r>
-              <a:rPr sz="1000" b="0" i="1">
-                <a:solidFill>
-                  <a:srgbClr val="E5B22D"/>
-                </a:solidFill>
-                <a:latin typeface="맑은 고딕"/>
-              </a:rPr>
-              <a:t>▸  장애 = 국가 단위 영향</a:t>
-            </a:r>
-          </a:p>
-        </p:txBody>
-      </p:sp>
-      <p:sp>
-        <p:nvSpPr>
-          <p:cNvPr id="49" name="Rectangle 48"/>
+              <a:rPr sz="1200" b="1" i="0">
+                <a:solidFill>
+                  <a:srgbClr val="00D4FF"/>
+                </a:solidFill>
+                <a:latin typeface="맑은 고딕"/>
+              </a:rPr>
+              <a:t>비정형 데이터 플랫폼  ─  수집부터 가공까지 통제 가능한 흐름</a:t>
+            </a:r>
+          </a:p>
+        </p:txBody>
+      </p:sp>
+      <p:sp>
+        <p:nvSpPr>
+          <p:cNvPr id="59" name="Rectangle 58"/>
           <p:cNvSpPr/>
           <p:nvPr/>
         </p:nvSpPr>
         <p:spPr>
           <a:xfrm>
-            <a:off x="9018900" y="3006000"/>
-            <a:ext cx="2526300" cy="1133999"/>
+            <a:off x="1709999" y="3438000"/>
+            <a:ext cx="3170400" cy="485999"/>
           </a:xfrm>
           <a:prstGeom prst="rect">
             <a:avLst/>
@@ -5010,16 +5374,199 @@
       </p:sp>
       <p:sp>
         <p:nvSpPr>
-          <p:cNvPr id="50" name="Oval 49"/>
+          <p:cNvPr id="60" name="Rectangle 59"/>
           <p:cNvSpPr/>
           <p:nvPr/>
         </p:nvSpPr>
         <p:spPr>
           <a:xfrm>
-            <a:off x="9126900" y="3114000"/>
-            <a:ext cx="144000" cy="144000"/>
-          </a:xfrm>
-          <a:prstGeom prst="ellipse">
+            <a:off x="1709999" y="3438000"/>
+            <a:ext cx="3170400" cy="198000"/>
+          </a:xfrm>
+          <a:prstGeom prst="rect">
+            <a:avLst/>
+          </a:prstGeom>
+          <a:solidFill>
+            <a:srgbClr val="0088A8"/>
+          </a:solidFill>
+          <a:ln>
+            <a:noFill/>
+          </a:ln>
+        </p:spPr>
+        <p:style>
+          <a:lnRef idx="1">
+            <a:schemeClr val="accent1"/>
+          </a:lnRef>
+          <a:fillRef idx="3">
+            <a:schemeClr val="accent1"/>
+          </a:fillRef>
+          <a:effectRef idx="2">
+            <a:schemeClr val="accent1"/>
+          </a:effectRef>
+          <a:fontRef idx="minor">
+            <a:schemeClr val="lt1"/>
+          </a:fontRef>
+        </p:style>
+        <p:txBody>
+          <a:bodyPr rtlCol="0" anchor="ctr"/>
+          <a:lstStyle/>
+          <a:p>
+            <a:pPr algn="ctr"/>
+          </a:p>
+        </p:txBody>
+      </p:sp>
+      <p:sp>
+        <p:nvSpPr>
+          <p:cNvPr id="61" name="TextBox 60"/>
+          <p:cNvSpPr txBox="1"/>
+          <p:nvPr/>
+        </p:nvSpPr>
+        <p:spPr>
+          <a:xfrm>
+            <a:off x="1799999" y="3466800"/>
+            <a:ext cx="360000" cy="144000"/>
+          </a:xfrm>
+          <a:prstGeom prst="rect">
+            <a:avLst/>
+          </a:prstGeom>
+          <a:noFill/>
+        </p:spPr>
+        <p:txBody>
+          <a:bodyPr wrap="square" lIns="28800" rIns="28800" tIns="14400" bIns="14400">
+            <a:spAutoFit/>
+          </a:bodyPr>
+          <a:lstStyle/>
+          <a:p>
+            <a:pPr algn="l"/>
+            <a:r>
+              <a:rPr sz="1000" b="1" i="0">
+                <a:solidFill>
+                  <a:srgbClr val="07101E"/>
+                </a:solidFill>
+                <a:latin typeface="맑은 고딕"/>
+              </a:rPr>
+              <a:t>01</a:t>
+            </a:r>
+          </a:p>
+        </p:txBody>
+      </p:sp>
+      <p:sp>
+        <p:nvSpPr>
+          <p:cNvPr id="62" name="TextBox 61"/>
+          <p:cNvSpPr txBox="1"/>
+          <p:nvPr/>
+        </p:nvSpPr>
+        <p:spPr>
+          <a:xfrm>
+            <a:off x="1709999" y="3466800"/>
+            <a:ext cx="3170400" cy="144000"/>
+          </a:xfrm>
+          <a:prstGeom prst="rect">
+            <a:avLst/>
+          </a:prstGeom>
+          <a:noFill/>
+        </p:spPr>
+        <p:txBody>
+          <a:bodyPr wrap="square" lIns="28800" rIns="28800" tIns="14400" bIns="14400">
+            <a:spAutoFit/>
+          </a:bodyPr>
+          <a:lstStyle/>
+          <a:p>
+            <a:pPr algn="ctr"/>
+            <a:r>
+              <a:rPr sz="1200" b="1" i="0">
+                <a:solidFill>
+                  <a:srgbClr val="07101E"/>
+                </a:solidFill>
+                <a:latin typeface="맑은 고딕"/>
+              </a:rPr>
+              <a:t>수집</a:t>
+            </a:r>
+          </a:p>
+        </p:txBody>
+      </p:sp>
+      <p:sp>
+        <p:nvSpPr>
+          <p:cNvPr id="63" name="TextBox 62"/>
+          <p:cNvSpPr txBox="1"/>
+          <p:nvPr/>
+        </p:nvSpPr>
+        <p:spPr>
+          <a:xfrm>
+            <a:off x="1709999" y="3672000"/>
+            <a:ext cx="3170400" cy="144000"/>
+          </a:xfrm>
+          <a:prstGeom prst="rect">
+            <a:avLst/>
+          </a:prstGeom>
+          <a:noFill/>
+        </p:spPr>
+        <p:txBody>
+          <a:bodyPr wrap="square" lIns="28800" rIns="28800" tIns="14400" bIns="14400">
+            <a:spAutoFit/>
+          </a:bodyPr>
+          <a:lstStyle/>
+          <a:p>
+            <a:pPr algn="ctr"/>
+            <a:r>
+              <a:rPr sz="900" b="0" i="1">
+                <a:solidFill>
+                  <a:srgbClr val="00D4FF"/>
+                </a:solidFill>
+                <a:latin typeface="맑은 고딕"/>
+              </a:rPr>
+              <a:t>Ingest</a:t>
+            </a:r>
+          </a:p>
+        </p:txBody>
+      </p:sp>
+      <p:sp>
+        <p:nvSpPr>
+          <p:cNvPr id="64" name="TextBox 63"/>
+          <p:cNvSpPr txBox="1"/>
+          <p:nvPr/>
+        </p:nvSpPr>
+        <p:spPr>
+          <a:xfrm>
+            <a:off x="1799999" y="3816000"/>
+            <a:ext cx="2990400" cy="180000"/>
+          </a:xfrm>
+          <a:prstGeom prst="rect">
+            <a:avLst/>
+          </a:prstGeom>
+          <a:noFill/>
+        </p:spPr>
+        <p:txBody>
+          <a:bodyPr wrap="square" lIns="28800" rIns="28800" tIns="14400" bIns="14400">
+            <a:spAutoFit/>
+          </a:bodyPr>
+          <a:lstStyle/>
+          <a:p>
+            <a:pPr algn="ctr"/>
+            <a:r>
+              <a:rPr sz="1000" b="0" i="0">
+                <a:solidFill>
+                  <a:srgbClr val="FFFFFF"/>
+                </a:solidFill>
+                <a:latin typeface="맑은 고딕"/>
+              </a:rPr>
+              <a:t>원천 + 출처 태그</a:t>
+            </a:r>
+          </a:p>
+        </p:txBody>
+      </p:sp>
+      <p:sp>
+        <p:nvSpPr>
+          <p:cNvPr id="65" name="Chevron 64"/>
+          <p:cNvSpPr/>
+          <p:nvPr/>
+        </p:nvSpPr>
+        <p:spPr>
+          <a:xfrm>
+            <a:off x="4880399" y="3601799"/>
+            <a:ext cx="108000" cy="162000"/>
+          </a:xfrm>
+          <a:prstGeom prst="chevron">
             <a:avLst/>
           </a:prstGeom>
           <a:solidFill>
@@ -5053,154 +5600,14 @@
       </p:sp>
       <p:sp>
         <p:nvSpPr>
-          <p:cNvPr id="51" name="TextBox 50"/>
-          <p:cNvSpPr txBox="1"/>
-          <p:nvPr/>
-        </p:nvSpPr>
-        <p:spPr>
-          <a:xfrm>
-            <a:off x="9126900" y="3114000"/>
-            <a:ext cx="144000" cy="144000"/>
-          </a:xfrm>
-          <a:prstGeom prst="rect">
-            <a:avLst/>
-          </a:prstGeom>
-          <a:noFill/>
-        </p:spPr>
-        <p:txBody>
-          <a:bodyPr wrap="square" lIns="28800" rIns="28800" tIns="14400" bIns="14400">
-            <a:spAutoFit/>
-          </a:bodyPr>
-          <a:lstStyle/>
-          <a:p>
-            <a:pPr algn="ctr"/>
-            <a:r>
-              <a:rPr sz="900" b="1" i="0">
-                <a:solidFill>
-                  <a:srgbClr val="07101E"/>
-                </a:solidFill>
-                <a:latin typeface="맑은 고딕"/>
-              </a:rPr>
-              <a:t>2</a:t>
-            </a:r>
-          </a:p>
-        </p:txBody>
-      </p:sp>
-      <p:sp>
-        <p:nvSpPr>
-          <p:cNvPr id="52" name="TextBox 51"/>
-          <p:cNvSpPr txBox="1"/>
-          <p:nvPr/>
-        </p:nvSpPr>
-        <p:spPr>
-          <a:xfrm>
-            <a:off x="9324900" y="3096000"/>
-            <a:ext cx="2166300" cy="216000"/>
-          </a:xfrm>
-          <a:prstGeom prst="rect">
-            <a:avLst/>
-          </a:prstGeom>
-          <a:noFill/>
-        </p:spPr>
-        <p:txBody>
-          <a:bodyPr wrap="square" lIns="28800" rIns="28800" tIns="14400" bIns="14400">
-            <a:spAutoFit/>
-          </a:bodyPr>
-          <a:lstStyle/>
-          <a:p>
-            <a:pPr algn="l"/>
-            <a:r>
-              <a:rPr sz="1300" b="1" i="0">
-                <a:solidFill>
-                  <a:srgbClr val="00D4FF"/>
-                </a:solidFill>
-                <a:latin typeface="맑은 고딕"/>
-              </a:rPr>
-              <a:t>미션 크리티컬 관제</a:t>
-            </a:r>
-          </a:p>
-        </p:txBody>
-      </p:sp>
-      <p:sp>
-        <p:nvSpPr>
-          <p:cNvPr id="53" name="TextBox 52"/>
-          <p:cNvSpPr txBox="1"/>
-          <p:nvPr/>
-        </p:nvSpPr>
-        <p:spPr>
-          <a:xfrm>
-            <a:off x="9144899" y="3348000"/>
-            <a:ext cx="2346300" cy="198000"/>
-          </a:xfrm>
-          <a:prstGeom prst="rect">
-            <a:avLst/>
-          </a:prstGeom>
-          <a:noFill/>
-        </p:spPr>
-        <p:txBody>
-          <a:bodyPr wrap="square" lIns="28800" rIns="28800" tIns="14400" bIns="14400">
-            <a:spAutoFit/>
-          </a:bodyPr>
-          <a:lstStyle/>
-          <a:p>
-            <a:pPr algn="l"/>
-            <a:r>
-              <a:rPr sz="1100" b="0" i="0">
-                <a:solidFill>
-                  <a:srgbClr val="FFFFFF"/>
-                </a:solidFill>
-                <a:latin typeface="맑은 고딕"/>
-              </a:rPr>
-              <a:t>관제 · 장애 대응 · 이중화</a:t>
-            </a:r>
-          </a:p>
-        </p:txBody>
-      </p:sp>
-      <p:sp>
-        <p:nvSpPr>
-          <p:cNvPr id="54" name="TextBox 53"/>
-          <p:cNvSpPr txBox="1"/>
-          <p:nvPr/>
-        </p:nvSpPr>
-        <p:spPr>
-          <a:xfrm>
-            <a:off x="9144899" y="3546000"/>
-            <a:ext cx="2346300" cy="198000"/>
-          </a:xfrm>
-          <a:prstGeom prst="rect">
-            <a:avLst/>
-          </a:prstGeom>
-          <a:noFill/>
-        </p:spPr>
-        <p:txBody>
-          <a:bodyPr wrap="square" lIns="28800" rIns="28800" tIns="14400" bIns="14400">
-            <a:spAutoFit/>
-          </a:bodyPr>
-          <a:lstStyle/>
-          <a:p>
-            <a:pPr algn="l"/>
-            <a:r>
-              <a:rPr sz="1000" b="0" i="1">
-                <a:solidFill>
-                  <a:srgbClr val="E5B22D"/>
-                </a:solidFill>
-                <a:latin typeface="맑은 고딕"/>
-              </a:rPr>
-              <a:t>▸  멈춤이 허용되지 않는 운영</a:t>
-            </a:r>
-          </a:p>
-        </p:txBody>
-      </p:sp>
-      <p:sp>
-        <p:nvSpPr>
-          <p:cNvPr id="55" name="Rectangle 54"/>
+          <p:cNvPr id="66" name="Rectangle 65"/>
           <p:cNvSpPr/>
           <p:nvPr/>
         </p:nvSpPr>
         <p:spPr>
           <a:xfrm>
-            <a:off x="6420600" y="4193999"/>
-            <a:ext cx="2526300" cy="1133999"/>
+            <a:off x="4952399" y="3438000"/>
+            <a:ext cx="3170400" cy="485999"/>
           </a:xfrm>
           <a:prstGeom prst="rect">
             <a:avLst/>
@@ -5238,16 +5645,199 @@
       </p:sp>
       <p:sp>
         <p:nvSpPr>
-          <p:cNvPr id="56" name="Oval 55"/>
+          <p:cNvPr id="67" name="Rectangle 66"/>
           <p:cNvSpPr/>
           <p:nvPr/>
         </p:nvSpPr>
         <p:spPr>
           <a:xfrm>
-            <a:off x="6528600" y="4301999"/>
-            <a:ext cx="144000" cy="144000"/>
-          </a:xfrm>
-          <a:prstGeom prst="ellipse">
+            <a:off x="4952399" y="3438000"/>
+            <a:ext cx="3170400" cy="198000"/>
+          </a:xfrm>
+          <a:prstGeom prst="rect">
+            <a:avLst/>
+          </a:prstGeom>
+          <a:solidFill>
+            <a:srgbClr val="0088A8"/>
+          </a:solidFill>
+          <a:ln>
+            <a:noFill/>
+          </a:ln>
+        </p:spPr>
+        <p:style>
+          <a:lnRef idx="1">
+            <a:schemeClr val="accent1"/>
+          </a:lnRef>
+          <a:fillRef idx="3">
+            <a:schemeClr val="accent1"/>
+          </a:fillRef>
+          <a:effectRef idx="2">
+            <a:schemeClr val="accent1"/>
+          </a:effectRef>
+          <a:fontRef idx="minor">
+            <a:schemeClr val="lt1"/>
+          </a:fontRef>
+        </p:style>
+        <p:txBody>
+          <a:bodyPr rtlCol="0" anchor="ctr"/>
+          <a:lstStyle/>
+          <a:p>
+            <a:pPr algn="ctr"/>
+          </a:p>
+        </p:txBody>
+      </p:sp>
+      <p:sp>
+        <p:nvSpPr>
+          <p:cNvPr id="68" name="TextBox 67"/>
+          <p:cNvSpPr txBox="1"/>
+          <p:nvPr/>
+        </p:nvSpPr>
+        <p:spPr>
+          <a:xfrm>
+            <a:off x="5042399" y="3466800"/>
+            <a:ext cx="360000" cy="144000"/>
+          </a:xfrm>
+          <a:prstGeom prst="rect">
+            <a:avLst/>
+          </a:prstGeom>
+          <a:noFill/>
+        </p:spPr>
+        <p:txBody>
+          <a:bodyPr wrap="square" lIns="28800" rIns="28800" tIns="14400" bIns="14400">
+            <a:spAutoFit/>
+          </a:bodyPr>
+          <a:lstStyle/>
+          <a:p>
+            <a:pPr algn="l"/>
+            <a:r>
+              <a:rPr sz="1000" b="1" i="0">
+                <a:solidFill>
+                  <a:srgbClr val="07101E"/>
+                </a:solidFill>
+                <a:latin typeface="맑은 고딕"/>
+              </a:rPr>
+              <a:t>02</a:t>
+            </a:r>
+          </a:p>
+        </p:txBody>
+      </p:sp>
+      <p:sp>
+        <p:nvSpPr>
+          <p:cNvPr id="69" name="TextBox 68"/>
+          <p:cNvSpPr txBox="1"/>
+          <p:nvPr/>
+        </p:nvSpPr>
+        <p:spPr>
+          <a:xfrm>
+            <a:off x="4952399" y="3466800"/>
+            <a:ext cx="3170400" cy="144000"/>
+          </a:xfrm>
+          <a:prstGeom prst="rect">
+            <a:avLst/>
+          </a:prstGeom>
+          <a:noFill/>
+        </p:spPr>
+        <p:txBody>
+          <a:bodyPr wrap="square" lIns="28800" rIns="28800" tIns="14400" bIns="14400">
+            <a:spAutoFit/>
+          </a:bodyPr>
+          <a:lstStyle/>
+          <a:p>
+            <a:pPr algn="ctr"/>
+            <a:r>
+              <a:rPr sz="1200" b="1" i="0">
+                <a:solidFill>
+                  <a:srgbClr val="07101E"/>
+                </a:solidFill>
+                <a:latin typeface="맑은 고딕"/>
+              </a:rPr>
+              <a:t>저장</a:t>
+            </a:r>
+          </a:p>
+        </p:txBody>
+      </p:sp>
+      <p:sp>
+        <p:nvSpPr>
+          <p:cNvPr id="70" name="TextBox 69"/>
+          <p:cNvSpPr txBox="1"/>
+          <p:nvPr/>
+        </p:nvSpPr>
+        <p:spPr>
+          <a:xfrm>
+            <a:off x="4952399" y="3672000"/>
+            <a:ext cx="3170400" cy="144000"/>
+          </a:xfrm>
+          <a:prstGeom prst="rect">
+            <a:avLst/>
+          </a:prstGeom>
+          <a:noFill/>
+        </p:spPr>
+        <p:txBody>
+          <a:bodyPr wrap="square" lIns="28800" rIns="28800" tIns="14400" bIns="14400">
+            <a:spAutoFit/>
+          </a:bodyPr>
+          <a:lstStyle/>
+          <a:p>
+            <a:pPr algn="ctr"/>
+            <a:r>
+              <a:rPr sz="900" b="0" i="1">
+                <a:solidFill>
+                  <a:srgbClr val="00D4FF"/>
+                </a:solidFill>
+                <a:latin typeface="맑은 고딕"/>
+              </a:rPr>
+              <a:t>Govern</a:t>
+            </a:r>
+          </a:p>
+        </p:txBody>
+      </p:sp>
+      <p:sp>
+        <p:nvSpPr>
+          <p:cNvPr id="71" name="TextBox 70"/>
+          <p:cNvSpPr txBox="1"/>
+          <p:nvPr/>
+        </p:nvSpPr>
+        <p:spPr>
+          <a:xfrm>
+            <a:off x="5042399" y="3816000"/>
+            <a:ext cx="2990400" cy="180000"/>
+          </a:xfrm>
+          <a:prstGeom prst="rect">
+            <a:avLst/>
+          </a:prstGeom>
+          <a:noFill/>
+        </p:spPr>
+        <p:txBody>
+          <a:bodyPr wrap="square" lIns="28800" rIns="28800" tIns="14400" bIns="14400">
+            <a:spAutoFit/>
+          </a:bodyPr>
+          <a:lstStyle/>
+          <a:p>
+            <a:pPr algn="ctr"/>
+            <a:r>
+              <a:rPr sz="1000" b="0" i="0">
+                <a:solidFill>
+                  <a:srgbClr val="FFFFFF"/>
+                </a:solidFill>
+                <a:latin typeface="맑은 고딕"/>
+              </a:rPr>
+              <a:t>보존 + 접근 통제</a:t>
+            </a:r>
+          </a:p>
+        </p:txBody>
+      </p:sp>
+      <p:sp>
+        <p:nvSpPr>
+          <p:cNvPr id="72" name="Chevron 71"/>
+          <p:cNvSpPr/>
+          <p:nvPr/>
+        </p:nvSpPr>
+        <p:spPr>
+          <a:xfrm>
+            <a:off x="8122799" y="3601799"/>
+            <a:ext cx="108000" cy="162000"/>
+          </a:xfrm>
+          <a:prstGeom prst="chevron">
             <a:avLst/>
           </a:prstGeom>
           <a:solidFill>
@@ -5281,154 +5871,14 @@
       </p:sp>
       <p:sp>
         <p:nvSpPr>
-          <p:cNvPr id="57" name="TextBox 56"/>
-          <p:cNvSpPr txBox="1"/>
-          <p:nvPr/>
-        </p:nvSpPr>
-        <p:spPr>
-          <a:xfrm>
-            <a:off x="6528600" y="4301999"/>
-            <a:ext cx="144000" cy="144000"/>
-          </a:xfrm>
-          <a:prstGeom prst="rect">
-            <a:avLst/>
-          </a:prstGeom>
-          <a:noFill/>
-        </p:spPr>
-        <p:txBody>
-          <a:bodyPr wrap="square" lIns="28800" rIns="28800" tIns="14400" bIns="14400">
-            <a:spAutoFit/>
-          </a:bodyPr>
-          <a:lstStyle/>
-          <a:p>
-            <a:pPr algn="ctr"/>
-            <a:r>
-              <a:rPr sz="900" b="1" i="0">
-                <a:solidFill>
-                  <a:srgbClr val="07101E"/>
-                </a:solidFill>
-                <a:latin typeface="맑은 고딕"/>
-              </a:rPr>
-              <a:t>3</a:t>
-            </a:r>
-          </a:p>
-        </p:txBody>
-      </p:sp>
-      <p:sp>
-        <p:nvSpPr>
-          <p:cNvPr id="58" name="TextBox 57"/>
-          <p:cNvSpPr txBox="1"/>
-          <p:nvPr/>
-        </p:nvSpPr>
-        <p:spPr>
-          <a:xfrm>
-            <a:off x="6726600" y="4283999"/>
-            <a:ext cx="2166300" cy="216000"/>
-          </a:xfrm>
-          <a:prstGeom prst="rect">
-            <a:avLst/>
-          </a:prstGeom>
-          <a:noFill/>
-        </p:spPr>
-        <p:txBody>
-          <a:bodyPr wrap="square" lIns="28800" rIns="28800" tIns="14400" bIns="14400">
-            <a:spAutoFit/>
-          </a:bodyPr>
-          <a:lstStyle/>
-          <a:p>
-            <a:pPr algn="l"/>
-            <a:r>
-              <a:rPr sz="1300" b="1" i="0">
-                <a:solidFill>
-                  <a:srgbClr val="00D4FF"/>
-                </a:solidFill>
-                <a:latin typeface="맑은 고딕"/>
-              </a:rPr>
-              <a:t>금융 IT 실적</a:t>
-            </a:r>
-          </a:p>
-        </p:txBody>
-      </p:sp>
-      <p:sp>
-        <p:nvSpPr>
-          <p:cNvPr id="59" name="TextBox 58"/>
-          <p:cNvSpPr txBox="1"/>
-          <p:nvPr/>
-        </p:nvSpPr>
-        <p:spPr>
-          <a:xfrm>
-            <a:off x="6546599" y="4535999"/>
-            <a:ext cx="2346300" cy="198000"/>
-          </a:xfrm>
-          <a:prstGeom prst="rect">
-            <a:avLst/>
-          </a:prstGeom>
-          <a:noFill/>
-        </p:spPr>
-        <p:txBody>
-          <a:bodyPr wrap="square" lIns="28800" rIns="28800" tIns="14400" bIns="14400">
-            <a:spAutoFit/>
-          </a:bodyPr>
-          <a:lstStyle/>
-          <a:p>
-            <a:pPr algn="l"/>
-            <a:r>
-              <a:rPr sz="1100" b="0" i="0">
-                <a:solidFill>
-                  <a:srgbClr val="FFFFFF"/>
-                </a:solidFill>
-                <a:latin typeface="맑은 고딕"/>
-              </a:rPr>
-              <a:t>전 시중은행급 인프라 운영</a:t>
-            </a:r>
-          </a:p>
-        </p:txBody>
-      </p:sp>
-      <p:sp>
-        <p:nvSpPr>
-          <p:cNvPr id="60" name="TextBox 59"/>
-          <p:cNvSpPr txBox="1"/>
-          <p:nvPr/>
-        </p:nvSpPr>
-        <p:spPr>
-          <a:xfrm>
-            <a:off x="6546599" y="4733999"/>
-            <a:ext cx="2346300" cy="198000"/>
-          </a:xfrm>
-          <a:prstGeom prst="rect">
-            <a:avLst/>
-          </a:prstGeom>
-          <a:noFill/>
-        </p:spPr>
-        <p:txBody>
-          <a:bodyPr wrap="square" lIns="28800" rIns="28800" tIns="14400" bIns="14400">
-            <a:spAutoFit/>
-          </a:bodyPr>
-          <a:lstStyle/>
-          <a:p>
-            <a:pPr algn="l"/>
-            <a:r>
-              <a:rPr sz="1000" b="0" i="1">
-                <a:solidFill>
-                  <a:srgbClr val="E5B22D"/>
-                </a:solidFill>
-                <a:latin typeface="맑은 고딕"/>
-              </a:rPr>
-              <a:t>▸  규제 · 감사 대응 경험</a:t>
-            </a:r>
-          </a:p>
-        </p:txBody>
-      </p:sp>
-      <p:sp>
-        <p:nvSpPr>
-          <p:cNvPr id="61" name="Rectangle 60"/>
+          <p:cNvPr id="73" name="Rectangle 72"/>
           <p:cNvSpPr/>
           <p:nvPr/>
         </p:nvSpPr>
         <p:spPr>
           <a:xfrm>
-            <a:off x="9018900" y="4193999"/>
-            <a:ext cx="2526300" cy="1133999"/>
+            <a:off x="8194799" y="3438000"/>
+            <a:ext cx="3170400" cy="485999"/>
           </a:xfrm>
           <a:prstGeom prst="rect">
             <a:avLst/>
@@ -5466,20 +5916,20 @@
       </p:sp>
       <p:sp>
         <p:nvSpPr>
-          <p:cNvPr id="62" name="Oval 61"/>
+          <p:cNvPr id="74" name="Rectangle 73"/>
           <p:cNvSpPr/>
           <p:nvPr/>
         </p:nvSpPr>
         <p:spPr>
           <a:xfrm>
-            <a:off x="9126900" y="4301999"/>
-            <a:ext cx="144000" cy="144000"/>
-          </a:xfrm>
-          <a:prstGeom prst="ellipse">
+            <a:off x="8194799" y="3438000"/>
+            <a:ext cx="3170400" cy="198000"/>
+          </a:xfrm>
+          <a:prstGeom prst="rect">
             <a:avLst/>
           </a:prstGeom>
           <a:solidFill>
-            <a:srgbClr val="00D4FF"/>
+            <a:srgbClr val="0088A8"/>
           </a:solidFill>
           <a:ln>
             <a:noFill/>
@@ -5509,14 +5959,14 @@
       </p:sp>
       <p:sp>
         <p:nvSpPr>
-          <p:cNvPr id="63" name="TextBox 62"/>
+          <p:cNvPr id="75" name="TextBox 74"/>
           <p:cNvSpPr txBox="1"/>
           <p:nvPr/>
         </p:nvSpPr>
         <p:spPr>
           <a:xfrm>
-            <a:off x="9126900" y="4301999"/>
-            <a:ext cx="144000" cy="144000"/>
+            <a:off x="8284799" y="3466800"/>
+            <a:ext cx="360000" cy="144000"/>
           </a:xfrm>
           <a:prstGeom prst="rect">
             <a:avLst/>
@@ -5529,29 +5979,29 @@
           </a:bodyPr>
           <a:lstStyle/>
           <a:p>
-            <a:pPr algn="ctr"/>
-            <a:r>
-              <a:rPr sz="900" b="1" i="0">
+            <a:pPr algn="l"/>
+            <a:r>
+              <a:rPr sz="1000" b="1" i="0">
                 <a:solidFill>
                   <a:srgbClr val="07101E"/>
                 </a:solidFill>
                 <a:latin typeface="맑은 고딕"/>
               </a:rPr>
-              <a:t>4</a:t>
-            </a:r>
-          </a:p>
-        </p:txBody>
-      </p:sp>
-      <p:sp>
-        <p:nvSpPr>
-          <p:cNvPr id="64" name="TextBox 63"/>
+              <a:t>03</a:t>
+            </a:r>
+          </a:p>
+        </p:txBody>
+      </p:sp>
+      <p:sp>
+        <p:nvSpPr>
+          <p:cNvPr id="76" name="TextBox 75"/>
           <p:cNvSpPr txBox="1"/>
           <p:nvPr/>
         </p:nvSpPr>
         <p:spPr>
           <a:xfrm>
-            <a:off x="9324900" y="4283999"/>
-            <a:ext cx="2166300" cy="216000"/>
+            <a:off x="8194799" y="3466800"/>
+            <a:ext cx="3170400" cy="144000"/>
           </a:xfrm>
           <a:prstGeom prst="rect">
             <a:avLst/>
@@ -5564,29 +6014,29 @@
           </a:bodyPr>
           <a:lstStyle/>
           <a:p>
-            <a:pPr algn="l"/>
-            <a:r>
-              <a:rPr sz="1300" b="1" i="0">
-                <a:solidFill>
-                  <a:srgbClr val="00D4FF"/>
-                </a:solidFill>
-                <a:latin typeface="맑은 고딕"/>
-              </a:rPr>
-              <a:t>AI Foundation</a:t>
-            </a:r>
-          </a:p>
-        </p:txBody>
-      </p:sp>
-      <p:sp>
-        <p:nvSpPr>
-          <p:cNvPr id="65" name="TextBox 64"/>
+            <a:pPr algn="ctr"/>
+            <a:r>
+              <a:rPr sz="1200" b="1" i="0">
+                <a:solidFill>
+                  <a:srgbClr val="07101E"/>
+                </a:solidFill>
+                <a:latin typeface="맑은 고딕"/>
+              </a:rPr>
+              <a:t>가공</a:t>
+            </a:r>
+          </a:p>
+        </p:txBody>
+      </p:sp>
+      <p:sp>
+        <p:nvSpPr>
+          <p:cNvPr id="77" name="TextBox 76"/>
           <p:cNvSpPr txBox="1"/>
           <p:nvPr/>
         </p:nvSpPr>
         <p:spPr>
           <a:xfrm>
-            <a:off x="9144899" y="4535999"/>
-            <a:ext cx="2346300" cy="198000"/>
+            <a:off x="8194799" y="3672000"/>
+            <a:ext cx="3170400" cy="144000"/>
           </a:xfrm>
           <a:prstGeom prst="rect">
             <a:avLst/>
@@ -5599,29 +6049,29 @@
           </a:bodyPr>
           <a:lstStyle/>
           <a:p>
-            <a:pPr algn="l"/>
-            <a:r>
-              <a:rPr sz="1100" b="0" i="0">
-                <a:solidFill>
-                  <a:srgbClr val="FFFFFF"/>
-                </a:solidFill>
-                <a:latin typeface="맑은 고딕"/>
-              </a:rPr>
-              <a:t>자체 모델 + KT Cloud</a:t>
-            </a:r>
-          </a:p>
-        </p:txBody>
-      </p:sp>
-      <p:sp>
-        <p:nvSpPr>
-          <p:cNvPr id="66" name="TextBox 65"/>
+            <a:pPr algn="ctr"/>
+            <a:r>
+              <a:rPr sz="900" b="0" i="1">
+                <a:solidFill>
+                  <a:srgbClr val="00D4FF"/>
+                </a:solidFill>
+                <a:latin typeface="맑은 고딕"/>
+              </a:rPr>
+              <a:t>Process</a:t>
+            </a:r>
+          </a:p>
+        </p:txBody>
+      </p:sp>
+      <p:sp>
+        <p:nvSpPr>
+          <p:cNvPr id="78" name="TextBox 77"/>
           <p:cNvSpPr txBox="1"/>
           <p:nvPr/>
         </p:nvSpPr>
         <p:spPr>
           <a:xfrm>
-            <a:off x="9144899" y="4733999"/>
-            <a:ext cx="2346300" cy="198000"/>
+            <a:off x="8284799" y="3816000"/>
+            <a:ext cx="2990400" cy="180000"/>
           </a:xfrm>
           <a:prstGeom prst="rect">
             <a:avLst/>
@@ -5634,35 +6084,70 @@
           </a:bodyPr>
           <a:lstStyle/>
           <a:p>
-            <a:pPr algn="l"/>
-            <a:r>
-              <a:rPr sz="1000" b="0" i="1">
+            <a:pPr algn="ctr"/>
+            <a:r>
+              <a:rPr sz="1000" b="0" i="0">
+                <a:solidFill>
+                  <a:srgbClr val="FFFFFF"/>
+                </a:solidFill>
+                <a:latin typeface="맑은 고딕"/>
+              </a:rPr>
+              <a:t>AI Ready化 + 정합성</a:t>
+            </a:r>
+          </a:p>
+        </p:txBody>
+      </p:sp>
+      <p:sp>
+        <p:nvSpPr>
+          <p:cNvPr id="79" name="TextBox 78"/>
+          <p:cNvSpPr txBox="1"/>
+          <p:nvPr/>
+        </p:nvSpPr>
+        <p:spPr>
+          <a:xfrm>
+            <a:off x="1529999" y="3995999"/>
+            <a:ext cx="10231201" cy="144000"/>
+          </a:xfrm>
+          <a:prstGeom prst="rect">
+            <a:avLst/>
+          </a:prstGeom>
+          <a:noFill/>
+        </p:spPr>
+        <p:txBody>
+          <a:bodyPr wrap="square" lIns="28800" rIns="28800" tIns="14400" bIns="14400">
+            <a:spAutoFit/>
+          </a:bodyPr>
+          <a:lstStyle/>
+          <a:p>
+            <a:pPr algn="ctr"/>
+            <a:r>
+              <a:rPr sz="900" b="0" i="1">
                 <a:solidFill>
                   <a:srgbClr val="E5B22D"/>
                 </a:solidFill>
                 <a:latin typeface="맑은 고딕"/>
               </a:rPr>
-              <a:t>▸  외부 의존 없는 통제 가능</a:t>
-            </a:r>
-          </a:p>
-        </p:txBody>
-      </p:sp>
-      <p:sp>
-        <p:nvSpPr>
-          <p:cNvPr id="67" name="Rectangle 66"/>
+              <a:t>▲   받쳐주고  ·  멈추지 않게 한다</a:t>
+            </a:r>
+          </a:p>
+        </p:txBody>
+      </p:sp>
+      <p:sp>
+        <p:nvSpPr>
+          <p:cNvPr id="80" name="Rectangle 79"/>
           <p:cNvSpPr/>
           <p:nvPr/>
         </p:nvSpPr>
         <p:spPr>
           <a:xfrm>
-            <a:off x="432000" y="5886000"/>
-            <a:ext cx="11329200" cy="558000"/>
+            <a:off x="1529999" y="4157999"/>
+            <a:ext cx="10231201" cy="1044000"/>
           </a:xfrm>
           <a:prstGeom prst="rect">
             <a:avLst/>
           </a:prstGeom>
           <a:solidFill>
-            <a:srgbClr val="E5B22D"/>
+            <a:srgbClr val="E31435"/>
           </a:solidFill>
           <a:ln>
             <a:noFill/>
@@ -5692,14 +6177,102 @@
       </p:sp>
       <p:sp>
         <p:nvSpPr>
-          <p:cNvPr id="68" name="TextBox 67"/>
+          <p:cNvPr id="81" name="Rectangle 80"/>
+          <p:cNvSpPr/>
+          <p:nvPr/>
+        </p:nvSpPr>
+        <p:spPr>
+          <a:xfrm>
+            <a:off x="1637999" y="5201999"/>
+            <a:ext cx="10015201" cy="64800"/>
+          </a:xfrm>
+          <a:prstGeom prst="rect">
+            <a:avLst/>
+          </a:prstGeom>
+          <a:solidFill>
+            <a:srgbClr val="600818"/>
+          </a:solidFill>
+          <a:ln>
+            <a:noFill/>
+          </a:ln>
+        </p:spPr>
+        <p:style>
+          <a:lnRef idx="1">
+            <a:schemeClr val="accent1"/>
+          </a:lnRef>
+          <a:fillRef idx="3">
+            <a:schemeClr val="accent1"/>
+          </a:fillRef>
+          <a:effectRef idx="2">
+            <a:schemeClr val="accent1"/>
+          </a:effectRef>
+          <a:fontRef idx="minor">
+            <a:schemeClr val="lt1"/>
+          </a:fontRef>
+        </p:style>
+        <p:txBody>
+          <a:bodyPr rtlCol="0" anchor="ctr"/>
+          <a:lstStyle/>
+          <a:p>
+            <a:pPr algn="ctr"/>
+          </a:p>
+        </p:txBody>
+      </p:sp>
+      <p:sp>
+        <p:nvSpPr>
+          <p:cNvPr id="82" name="Rectangle 81"/>
+          <p:cNvSpPr/>
+          <p:nvPr/>
+        </p:nvSpPr>
+        <p:spPr>
+          <a:xfrm>
+            <a:off x="432000" y="4157999"/>
+            <a:ext cx="1007999" cy="1044000"/>
+          </a:xfrm>
+          <a:prstGeom prst="rect">
+            <a:avLst/>
+          </a:prstGeom>
+          <a:solidFill>
+            <a:srgbClr val="E31435"/>
+          </a:solidFill>
+          <a:ln w="6350">
+            <a:solidFill>
+              <a:srgbClr val="FFFFFF"/>
+            </a:solidFill>
+          </a:ln>
+        </p:spPr>
+        <p:style>
+          <a:lnRef idx="1">
+            <a:schemeClr val="accent1"/>
+          </a:lnRef>
+          <a:fillRef idx="3">
+            <a:schemeClr val="accent1"/>
+          </a:fillRef>
+          <a:effectRef idx="2">
+            <a:schemeClr val="accent1"/>
+          </a:effectRef>
+          <a:fontRef idx="minor">
+            <a:schemeClr val="lt1"/>
+          </a:fontRef>
+        </p:style>
+        <p:txBody>
+          <a:bodyPr rtlCol="0" anchor="ctr"/>
+          <a:lstStyle/>
+          <a:p>
+            <a:pPr algn="ctr"/>
+          </a:p>
+        </p:txBody>
+      </p:sp>
+      <p:sp>
+        <p:nvSpPr>
+          <p:cNvPr id="83" name="TextBox 82"/>
           <p:cNvSpPr txBox="1"/>
           <p:nvPr/>
         </p:nvSpPr>
         <p:spPr>
           <a:xfrm>
-            <a:off x="540000" y="5940000"/>
-            <a:ext cx="11113200" cy="324000"/>
+            <a:off x="432000" y="4283998"/>
+            <a:ext cx="1007999" cy="162000"/>
           </a:xfrm>
           <a:prstGeom prst="rect">
             <a:avLst/>
@@ -5712,29 +6285,29 @@
           </a:bodyPr>
           <a:lstStyle/>
           <a:p>
-            <a:pPr algn="l"/>
-            <a:r>
-              <a:rPr sz="2200" b="1" i="0">
-                <a:solidFill>
-                  <a:srgbClr val="07101E"/>
-                </a:solidFill>
-                <a:latin typeface="맑은 고딕"/>
-              </a:rPr>
-              <a:t>통제권을 가진 자가 AI 시대 금융을 이깁니다</a:t>
-            </a:r>
-          </a:p>
-        </p:txBody>
-      </p:sp>
-      <p:sp>
-        <p:nvSpPr>
-          <p:cNvPr id="69" name="TextBox 68"/>
+            <a:pPr algn="ctr"/>
+            <a:r>
+              <a:rPr sz="1000" b="1" i="0">
+                <a:solidFill>
+                  <a:srgbClr val="FFFFFF"/>
+                </a:solidFill>
+                <a:latin typeface="맑은 고딕"/>
+              </a:rPr>
+              <a:t>LAYER 01</a:t>
+            </a:r>
+          </a:p>
+        </p:txBody>
+      </p:sp>
+      <p:sp>
+        <p:nvSpPr>
+          <p:cNvPr id="84" name="TextBox 83"/>
           <p:cNvSpPr txBox="1"/>
           <p:nvPr/>
         </p:nvSpPr>
         <p:spPr>
           <a:xfrm>
-            <a:off x="540000" y="6228000"/>
-            <a:ext cx="11113200" cy="198000"/>
+            <a:off x="432000" y="4463999"/>
+            <a:ext cx="1007999" cy="306000"/>
           </a:xfrm>
           <a:prstGeom prst="rect">
             <a:avLst/>
@@ -5747,22 +6320,584 @@
           </a:bodyPr>
           <a:lstStyle/>
           <a:p>
+            <a:pPr algn="ctr"/>
+            <a:r>
+              <a:rPr sz="2200" b="1" i="0">
+                <a:solidFill>
+                  <a:srgbClr val="FFFFFF"/>
+                </a:solidFill>
+                <a:latin typeface="맑은 고딕"/>
+              </a:rPr>
+              <a:t>토대</a:t>
+            </a:r>
+          </a:p>
+        </p:txBody>
+      </p:sp>
+      <p:sp>
+        <p:nvSpPr>
+          <p:cNvPr id="85" name="TextBox 84"/>
+          <p:cNvSpPr txBox="1"/>
+          <p:nvPr/>
+        </p:nvSpPr>
+        <p:spPr>
+          <a:xfrm>
+            <a:off x="432000" y="4769999"/>
+            <a:ext cx="1007999" cy="144000"/>
+          </a:xfrm>
+          <a:prstGeom prst="rect">
+            <a:avLst/>
+          </a:prstGeom>
+          <a:noFill/>
+        </p:spPr>
+        <p:txBody>
+          <a:bodyPr wrap="square" lIns="28800" rIns="28800" tIns="14400" bIns="14400">
+            <a:spAutoFit/>
+          </a:bodyPr>
+          <a:lstStyle/>
+          <a:p>
+            <a:pPr algn="ctr"/>
+            <a:r>
+              <a:rPr sz="800" b="0" i="1">
+                <a:solidFill>
+                  <a:srgbClr val="CCD6E0"/>
+                </a:solidFill>
+                <a:latin typeface="맑은 고딕"/>
+              </a:rPr>
+              <a:t>Foundation</a:t>
+            </a:r>
+          </a:p>
+        </p:txBody>
+      </p:sp>
+      <p:sp>
+        <p:nvSpPr>
+          <p:cNvPr id="86" name="Rectangle 85"/>
+          <p:cNvSpPr/>
+          <p:nvPr/>
+        </p:nvSpPr>
+        <p:spPr>
+          <a:xfrm>
+            <a:off x="576000" y="4931999"/>
+            <a:ext cx="719999" cy="180000"/>
+          </a:xfrm>
+          <a:prstGeom prst="rect">
+            <a:avLst/>
+          </a:prstGeom>
+          <a:solidFill>
+            <a:srgbClr val="FFFFFF"/>
+          </a:solidFill>
+          <a:ln>
+            <a:noFill/>
+          </a:ln>
+        </p:spPr>
+        <p:style>
+          <a:lnRef idx="1">
+            <a:schemeClr val="accent1"/>
+          </a:lnRef>
+          <a:fillRef idx="3">
+            <a:schemeClr val="accent1"/>
+          </a:fillRef>
+          <a:effectRef idx="2">
+            <a:schemeClr val="accent1"/>
+          </a:effectRef>
+          <a:fontRef idx="minor">
+            <a:schemeClr val="lt1"/>
+          </a:fontRef>
+        </p:style>
+        <p:txBody>
+          <a:bodyPr rtlCol="0" anchor="ctr"/>
+          <a:lstStyle/>
+          <a:p>
+            <a:pPr algn="ctr"/>
+          </a:p>
+        </p:txBody>
+      </p:sp>
+      <p:sp>
+        <p:nvSpPr>
+          <p:cNvPr id="87" name="TextBox 86"/>
+          <p:cNvSpPr txBox="1"/>
+          <p:nvPr/>
+        </p:nvSpPr>
+        <p:spPr>
+          <a:xfrm>
+            <a:off x="576000" y="4931999"/>
+            <a:ext cx="719999" cy="180000"/>
+          </a:xfrm>
+          <a:prstGeom prst="rect">
+            <a:avLst/>
+          </a:prstGeom>
+          <a:noFill/>
+        </p:spPr>
+        <p:txBody>
+          <a:bodyPr wrap="square" lIns="28800" rIns="28800" tIns="14400" bIns="14400">
+            <a:spAutoFit/>
+          </a:bodyPr>
+          <a:lstStyle/>
+          <a:p>
+            <a:pPr algn="ctr"/>
+            <a:r>
+              <a:rPr sz="1000" b="1" i="0">
+                <a:solidFill>
+                  <a:srgbClr val="E31435"/>
+                </a:solidFill>
+                <a:latin typeface="맑은 고딕"/>
+              </a:rPr>
+              <a:t>WHY KT</a:t>
+            </a:r>
+          </a:p>
+        </p:txBody>
+      </p:sp>
+      <p:sp>
+        <p:nvSpPr>
+          <p:cNvPr id="88" name="TextBox 87"/>
+          <p:cNvSpPr txBox="1"/>
+          <p:nvPr/>
+        </p:nvSpPr>
+        <p:spPr>
+          <a:xfrm>
+            <a:off x="1745999" y="4247999"/>
+            <a:ext cx="9799201" cy="180000"/>
+          </a:xfrm>
+          <a:prstGeom prst="rect">
+            <a:avLst/>
+          </a:prstGeom>
+          <a:noFill/>
+        </p:spPr>
+        <p:txBody>
+          <a:bodyPr wrap="square" lIns="28800" rIns="28800" tIns="14400" bIns="14400">
+            <a:spAutoFit/>
+          </a:bodyPr>
+          <a:lstStyle/>
+          <a:p>
             <a:pPr algn="l"/>
             <a:r>
-              <a:rPr sz="1200" b="0" i="0">
-                <a:solidFill>
-                  <a:srgbClr val="07101E"/>
-                </a:solidFill>
-                <a:latin typeface="맑은 고딕"/>
-              </a:rPr>
-              <a:t>AI를 통제하는 금융, 하나은행  ─  KT가 그 통제 인프라를 짓습니다</a:t>
-            </a:r>
-          </a:p>
-        </p:txBody>
-      </p:sp>
-      <p:sp>
-        <p:nvSpPr>
-          <p:cNvPr id="70" name="Rectangle 69"/>
+              <a:rPr sz="1000" b="1" i="0">
+                <a:solidFill>
+                  <a:srgbClr val="FFFFFF"/>
+                </a:solidFill>
+                <a:latin typeface="맑은 고딕"/>
+              </a:rPr>
+              <a:t>INFRASTRUCTURE  ·  멈추지 않는 운영 DNA</a:t>
+            </a:r>
+          </a:p>
+        </p:txBody>
+      </p:sp>
+      <p:sp>
+        <p:nvSpPr>
+          <p:cNvPr id="89" name="TextBox 88"/>
+          <p:cNvSpPr txBox="1"/>
+          <p:nvPr/>
+        </p:nvSpPr>
+        <p:spPr>
+          <a:xfrm>
+            <a:off x="1745999" y="4445999"/>
+            <a:ext cx="9799201" cy="342000"/>
+          </a:xfrm>
+          <a:prstGeom prst="rect">
+            <a:avLst/>
+          </a:prstGeom>
+          <a:noFill/>
+        </p:spPr>
+        <p:txBody>
+          <a:bodyPr wrap="square" lIns="28800" rIns="28800" tIns="14400" bIns="14400">
+            <a:spAutoFit/>
+          </a:bodyPr>
+          <a:lstStyle/>
+          <a:p>
+            <a:pPr algn="l"/>
+            <a:r>
+              <a:rPr sz="2200" b="1" i="0">
+                <a:solidFill>
+                  <a:srgbClr val="FFFFFF"/>
+                </a:solidFill>
+                <a:latin typeface="맑은 고딕"/>
+              </a:rPr>
+              <a:t>통신을 멈추지 않게 운영해온 단 하나의 회사</a:t>
+            </a:r>
+          </a:p>
+        </p:txBody>
+      </p:sp>
+      <p:sp>
+        <p:nvSpPr>
+          <p:cNvPr id="90" name="TextBox 89"/>
+          <p:cNvSpPr txBox="1"/>
+          <p:nvPr/>
+        </p:nvSpPr>
+        <p:spPr>
+          <a:xfrm>
+            <a:off x="1745999" y="4823999"/>
+            <a:ext cx="9799201" cy="198000"/>
+          </a:xfrm>
+          <a:prstGeom prst="rect">
+            <a:avLst/>
+          </a:prstGeom>
+          <a:noFill/>
+        </p:spPr>
+        <p:txBody>
+          <a:bodyPr wrap="square" lIns="28800" rIns="28800" tIns="14400" bIns="14400">
+            <a:spAutoFit/>
+          </a:bodyPr>
+          <a:lstStyle/>
+          <a:p>
+            <a:pPr algn="l"/>
+            <a:r>
+              <a:rPr sz="1200" b="0" i="1">
+                <a:solidFill>
+                  <a:srgbClr val="FFFFFF"/>
+                </a:solidFill>
+                <a:latin typeface="맑은 고딕"/>
+              </a:rPr>
+              <a:t>이 모든 레이어를 받칠 수 있는 토대는, KT의 인프라 운영 DNA 하나입니다.</a:t>
+            </a:r>
+          </a:p>
+        </p:txBody>
+      </p:sp>
+      <p:sp>
+        <p:nvSpPr>
+          <p:cNvPr id="91" name="Trapezoid 90"/>
+          <p:cNvSpPr/>
+          <p:nvPr/>
+        </p:nvSpPr>
+        <p:spPr>
+          <a:xfrm>
+            <a:off x="1745999" y="4859999"/>
+            <a:ext cx="180000" cy="251999"/>
+          </a:xfrm>
+          <a:prstGeom prst="trapezoid">
+            <a:avLst/>
+          </a:prstGeom>
+          <a:solidFill>
+            <a:srgbClr val="FFB0B8"/>
+          </a:solidFill>
+          <a:ln>
+            <a:noFill/>
+          </a:ln>
+        </p:spPr>
+        <p:style>
+          <a:lnRef idx="1">
+            <a:schemeClr val="accent1"/>
+          </a:lnRef>
+          <a:fillRef idx="3">
+            <a:schemeClr val="accent1"/>
+          </a:fillRef>
+          <a:effectRef idx="2">
+            <a:schemeClr val="accent1"/>
+          </a:effectRef>
+          <a:fontRef idx="minor">
+            <a:schemeClr val="lt1"/>
+          </a:fontRef>
+        </p:style>
+        <p:txBody>
+          <a:bodyPr rtlCol="0" anchor="ctr"/>
+          <a:lstStyle/>
+          <a:p>
+            <a:pPr algn="ctr"/>
+          </a:p>
+        </p:txBody>
+      </p:sp>
+      <p:sp>
+        <p:nvSpPr>
+          <p:cNvPr id="92" name="Trapezoid 91"/>
+          <p:cNvSpPr/>
+          <p:nvPr/>
+        </p:nvSpPr>
+        <p:spPr>
+          <a:xfrm>
+            <a:off x="3120170" y="4859999"/>
+            <a:ext cx="180000" cy="251999"/>
+          </a:xfrm>
+          <a:prstGeom prst="trapezoid">
+            <a:avLst/>
+          </a:prstGeom>
+          <a:solidFill>
+            <a:srgbClr val="FFB0B8"/>
+          </a:solidFill>
+          <a:ln>
+            <a:noFill/>
+          </a:ln>
+        </p:spPr>
+        <p:style>
+          <a:lnRef idx="1">
+            <a:schemeClr val="accent1"/>
+          </a:lnRef>
+          <a:fillRef idx="3">
+            <a:schemeClr val="accent1"/>
+          </a:fillRef>
+          <a:effectRef idx="2">
+            <a:schemeClr val="accent1"/>
+          </a:effectRef>
+          <a:fontRef idx="minor">
+            <a:schemeClr val="lt1"/>
+          </a:fontRef>
+        </p:style>
+        <p:txBody>
+          <a:bodyPr rtlCol="0" anchor="ctr"/>
+          <a:lstStyle/>
+          <a:p>
+            <a:pPr algn="ctr"/>
+          </a:p>
+        </p:txBody>
+      </p:sp>
+      <p:sp>
+        <p:nvSpPr>
+          <p:cNvPr id="93" name="Trapezoid 92"/>
+          <p:cNvSpPr/>
+          <p:nvPr/>
+        </p:nvSpPr>
+        <p:spPr>
+          <a:xfrm>
+            <a:off x="4494342" y="4859999"/>
+            <a:ext cx="180000" cy="251999"/>
+          </a:xfrm>
+          <a:prstGeom prst="trapezoid">
+            <a:avLst/>
+          </a:prstGeom>
+          <a:solidFill>
+            <a:srgbClr val="FFB0B8"/>
+          </a:solidFill>
+          <a:ln>
+            <a:noFill/>
+          </a:ln>
+        </p:spPr>
+        <p:style>
+          <a:lnRef idx="1">
+            <a:schemeClr val="accent1"/>
+          </a:lnRef>
+          <a:fillRef idx="3">
+            <a:schemeClr val="accent1"/>
+          </a:fillRef>
+          <a:effectRef idx="2">
+            <a:schemeClr val="accent1"/>
+          </a:effectRef>
+          <a:fontRef idx="minor">
+            <a:schemeClr val="lt1"/>
+          </a:fontRef>
+        </p:style>
+        <p:txBody>
+          <a:bodyPr rtlCol="0" anchor="ctr"/>
+          <a:lstStyle/>
+          <a:p>
+            <a:pPr algn="ctr"/>
+          </a:p>
+        </p:txBody>
+      </p:sp>
+      <p:sp>
+        <p:nvSpPr>
+          <p:cNvPr id="94" name="Trapezoid 93"/>
+          <p:cNvSpPr/>
+          <p:nvPr/>
+        </p:nvSpPr>
+        <p:spPr>
+          <a:xfrm>
+            <a:off x="5868513" y="4859999"/>
+            <a:ext cx="180000" cy="251999"/>
+          </a:xfrm>
+          <a:prstGeom prst="trapezoid">
+            <a:avLst/>
+          </a:prstGeom>
+          <a:solidFill>
+            <a:srgbClr val="FFB0B8"/>
+          </a:solidFill>
+          <a:ln>
+            <a:noFill/>
+          </a:ln>
+        </p:spPr>
+        <p:style>
+          <a:lnRef idx="1">
+            <a:schemeClr val="accent1"/>
+          </a:lnRef>
+          <a:fillRef idx="3">
+            <a:schemeClr val="accent1"/>
+          </a:fillRef>
+          <a:effectRef idx="2">
+            <a:schemeClr val="accent1"/>
+          </a:effectRef>
+          <a:fontRef idx="minor">
+            <a:schemeClr val="lt1"/>
+          </a:fontRef>
+        </p:style>
+        <p:txBody>
+          <a:bodyPr rtlCol="0" anchor="ctr"/>
+          <a:lstStyle/>
+          <a:p>
+            <a:pPr algn="ctr"/>
+          </a:p>
+        </p:txBody>
+      </p:sp>
+      <p:sp>
+        <p:nvSpPr>
+          <p:cNvPr id="95" name="Trapezoid 94"/>
+          <p:cNvSpPr/>
+          <p:nvPr/>
+        </p:nvSpPr>
+        <p:spPr>
+          <a:xfrm>
+            <a:off x="7242685" y="4859999"/>
+            <a:ext cx="180000" cy="251999"/>
+          </a:xfrm>
+          <a:prstGeom prst="trapezoid">
+            <a:avLst/>
+          </a:prstGeom>
+          <a:solidFill>
+            <a:srgbClr val="FFB0B8"/>
+          </a:solidFill>
+          <a:ln>
+            <a:noFill/>
+          </a:ln>
+        </p:spPr>
+        <p:style>
+          <a:lnRef idx="1">
+            <a:schemeClr val="accent1"/>
+          </a:lnRef>
+          <a:fillRef idx="3">
+            <a:schemeClr val="accent1"/>
+          </a:fillRef>
+          <a:effectRef idx="2">
+            <a:schemeClr val="accent1"/>
+          </a:effectRef>
+          <a:fontRef idx="minor">
+            <a:schemeClr val="lt1"/>
+          </a:fontRef>
+        </p:style>
+        <p:txBody>
+          <a:bodyPr rtlCol="0" anchor="ctr"/>
+          <a:lstStyle/>
+          <a:p>
+            <a:pPr algn="ctr"/>
+          </a:p>
+        </p:txBody>
+      </p:sp>
+      <p:sp>
+        <p:nvSpPr>
+          <p:cNvPr id="96" name="Trapezoid 95"/>
+          <p:cNvSpPr/>
+          <p:nvPr/>
+        </p:nvSpPr>
+        <p:spPr>
+          <a:xfrm>
+            <a:off x="8616856" y="4859999"/>
+            <a:ext cx="180000" cy="251999"/>
+          </a:xfrm>
+          <a:prstGeom prst="trapezoid">
+            <a:avLst/>
+          </a:prstGeom>
+          <a:solidFill>
+            <a:srgbClr val="FFB0B8"/>
+          </a:solidFill>
+          <a:ln>
+            <a:noFill/>
+          </a:ln>
+        </p:spPr>
+        <p:style>
+          <a:lnRef idx="1">
+            <a:schemeClr val="accent1"/>
+          </a:lnRef>
+          <a:fillRef idx="3">
+            <a:schemeClr val="accent1"/>
+          </a:fillRef>
+          <a:effectRef idx="2">
+            <a:schemeClr val="accent1"/>
+          </a:effectRef>
+          <a:fontRef idx="minor">
+            <a:schemeClr val="lt1"/>
+          </a:fontRef>
+        </p:style>
+        <p:txBody>
+          <a:bodyPr rtlCol="0" anchor="ctr"/>
+          <a:lstStyle/>
+          <a:p>
+            <a:pPr algn="ctr"/>
+          </a:p>
+        </p:txBody>
+      </p:sp>
+      <p:sp>
+        <p:nvSpPr>
+          <p:cNvPr id="97" name="Trapezoid 96"/>
+          <p:cNvSpPr/>
+          <p:nvPr/>
+        </p:nvSpPr>
+        <p:spPr>
+          <a:xfrm>
+            <a:off x="9991028" y="4859999"/>
+            <a:ext cx="180000" cy="251999"/>
+          </a:xfrm>
+          <a:prstGeom prst="trapezoid">
+            <a:avLst/>
+          </a:prstGeom>
+          <a:solidFill>
+            <a:srgbClr val="FFB0B8"/>
+          </a:solidFill>
+          <a:ln>
+            <a:noFill/>
+          </a:ln>
+        </p:spPr>
+        <p:style>
+          <a:lnRef idx="1">
+            <a:schemeClr val="accent1"/>
+          </a:lnRef>
+          <a:fillRef idx="3">
+            <a:schemeClr val="accent1"/>
+          </a:fillRef>
+          <a:effectRef idx="2">
+            <a:schemeClr val="accent1"/>
+          </a:effectRef>
+          <a:fontRef idx="minor">
+            <a:schemeClr val="lt1"/>
+          </a:fontRef>
+        </p:style>
+        <p:txBody>
+          <a:bodyPr rtlCol="0" anchor="ctr"/>
+          <a:lstStyle/>
+          <a:p>
+            <a:pPr algn="ctr"/>
+          </a:p>
+        </p:txBody>
+      </p:sp>
+      <p:sp>
+        <p:nvSpPr>
+          <p:cNvPr id="98" name="Trapezoid 97"/>
+          <p:cNvSpPr/>
+          <p:nvPr/>
+        </p:nvSpPr>
+        <p:spPr>
+          <a:xfrm>
+            <a:off x="11365200" y="4859999"/>
+            <a:ext cx="180000" cy="251999"/>
+          </a:xfrm>
+          <a:prstGeom prst="trapezoid">
+            <a:avLst/>
+          </a:prstGeom>
+          <a:solidFill>
+            <a:srgbClr val="FFB0B8"/>
+          </a:solidFill>
+          <a:ln>
+            <a:noFill/>
+          </a:ln>
+        </p:spPr>
+        <p:style>
+          <a:lnRef idx="1">
+            <a:schemeClr val="accent1"/>
+          </a:lnRef>
+          <a:fillRef idx="3">
+            <a:schemeClr val="accent1"/>
+          </a:fillRef>
+          <a:effectRef idx="2">
+            <a:schemeClr val="accent1"/>
+          </a:effectRef>
+          <a:fontRef idx="minor">
+            <a:schemeClr val="lt1"/>
+          </a:fontRef>
+        </p:style>
+        <p:txBody>
+          <a:bodyPr rtlCol="0" anchor="ctr"/>
+          <a:lstStyle/>
+          <a:p>
+            <a:pPr algn="ctr"/>
+          </a:p>
+        </p:txBody>
+      </p:sp>
+      <p:sp>
+        <p:nvSpPr>
+          <p:cNvPr id="99" name="Rectangle 98"/>
           <p:cNvSpPr/>
           <p:nvPr/>
         </p:nvSpPr>
@@ -5805,7 +6940,7 @@
       </p:sp>
       <p:sp>
         <p:nvSpPr>
-          <p:cNvPr id="71" name="TextBox 70"/>
+          <p:cNvPr id="100" name="TextBox 99"/>
           <p:cNvSpPr txBox="1"/>
           <p:nvPr/>
         </p:nvSpPr>
@@ -5840,7 +6975,7 @@
       </p:sp>
       <p:sp>
         <p:nvSpPr>
-          <p:cNvPr id="72" name="TextBox 71"/>
+          <p:cNvPr id="101" name="TextBox 100"/>
           <p:cNvSpPr txBox="1"/>
           <p:nvPr/>
         </p:nvSpPr>

</xml_diff>

<commit_message>
Embed real KT logo JPG in all 3 slides via add_picture()
- Slide 1: Logo (2.6cm) on right end of KT_RED LAYER 01 base, replacing text badge
- Slide 2: Small logo (0.85cm) in footer right area, all slides via add_footer()
- Slide 3: Logo (1.1cm) + text in closing signature strip

https://claude.ai/code/session_01FxEo1w4vu492E7Ycwid7Mr
</commit_message>
<xml_diff>
--- a/하나은행_AI_통제하는금융.pptx
+++ b/하나은행_AI_통제하는금융.pptx
@@ -6368,49 +6368,30 @@
           </a:p>
         </p:txBody>
       </p:sp>
-      <p:sp>
-        <p:nvSpPr>
-          <p:cNvPr id="86" name="Rectangle 85"/>
-          <p:cNvSpPr/>
-          <p:nvPr/>
-        </p:nvSpPr>
-        <p:spPr>
-          <a:xfrm>
-            <a:off x="576000" y="4931999"/>
-            <a:ext cx="719999" cy="180000"/>
-          </a:xfrm>
-          <a:prstGeom prst="rect">
-            <a:avLst/>
-          </a:prstGeom>
-          <a:solidFill>
-            <a:srgbClr val="FFFFFF"/>
-          </a:solidFill>
-          <a:ln>
-            <a:noFill/>
-          </a:ln>
-        </p:spPr>
-        <p:style>
-          <a:lnRef idx="1">
-            <a:schemeClr val="accent1"/>
-          </a:lnRef>
-          <a:fillRef idx="3">
-            <a:schemeClr val="accent1"/>
-          </a:fillRef>
-          <a:effectRef idx="2">
-            <a:schemeClr val="accent1"/>
-          </a:effectRef>
-          <a:fontRef idx="minor">
-            <a:schemeClr val="lt1"/>
-          </a:fontRef>
-        </p:style>
-        <p:txBody>
-          <a:bodyPr rtlCol="0" anchor="ctr"/>
-          <a:lstStyle/>
-          <a:p>
-            <a:pPr algn="ctr"/>
-          </a:p>
-        </p:txBody>
-      </p:sp>
+      <p:pic>
+        <p:nvPicPr>
+          <p:cNvPr id="86" name="Picture 85" descr="85e35f1f-1000038771.jpg"/>
+          <p:cNvPicPr>
+            <a:picLocks noChangeAspect="1"/>
+          </p:cNvPicPr>
+          <p:nvPr/>
+        </p:nvPicPr>
+        <p:blipFill>
+          <a:blip r:embed="rId2"/>
+          <a:stretch>
+            <a:fillRect/>
+          </a:stretch>
+        </p:blipFill>
+        <p:spPr>
+          <a:xfrm>
+            <a:off x="10717200" y="4211999"/>
+            <a:ext cx="936000" cy="936000"/>
+          </a:xfrm>
+          <a:prstGeom prst="rect">
+            <a:avLst/>
+          </a:prstGeom>
+        </p:spPr>
+      </p:pic>
       <p:sp>
         <p:nvSpPr>
           <p:cNvPr id="87" name="TextBox 86"/>
@@ -6419,8 +6400,8 @@
         </p:nvSpPr>
         <p:spPr>
           <a:xfrm>
-            <a:off x="576000" y="4931999"/>
-            <a:ext cx="719999" cy="180000"/>
+            <a:off x="1745999" y="4247999"/>
+            <a:ext cx="9799201" cy="180000"/>
           </a:xfrm>
           <a:prstGeom prst="rect">
             <a:avLst/>
@@ -6433,15 +6414,15 @@
           </a:bodyPr>
           <a:lstStyle/>
           <a:p>
-            <a:pPr algn="ctr"/>
+            <a:pPr algn="l"/>
             <a:r>
               <a:rPr sz="1000" b="1" i="0">
                 <a:solidFill>
-                  <a:srgbClr val="E31435"/>
-                </a:solidFill>
-                <a:latin typeface="맑은 고딕"/>
-              </a:rPr>
-              <a:t>WHY KT</a:t>
+                  <a:srgbClr val="FFFFFF"/>
+                </a:solidFill>
+                <a:latin typeface="맑은 고딕"/>
+              </a:rPr>
+              <a:t>INFRASTRUCTURE  ·  멈추지 않는 운영 DNA</a:t>
             </a:r>
           </a:p>
         </p:txBody>
@@ -6454,8 +6435,8 @@
         </p:nvSpPr>
         <p:spPr>
           <a:xfrm>
-            <a:off x="1745999" y="4247999"/>
-            <a:ext cx="9799201" cy="180000"/>
+            <a:off x="1745999" y="4445999"/>
+            <a:ext cx="9799201" cy="342000"/>
           </a:xfrm>
           <a:prstGeom prst="rect">
             <a:avLst/>
@@ -6470,13 +6451,13 @@
           <a:p>
             <a:pPr algn="l"/>
             <a:r>
-              <a:rPr sz="1000" b="1" i="0">
+              <a:rPr sz="2200" b="1" i="0">
                 <a:solidFill>
                   <a:srgbClr val="FFFFFF"/>
                 </a:solidFill>
                 <a:latin typeface="맑은 고딕"/>
               </a:rPr>
-              <a:t>INFRASTRUCTURE  ·  멈추지 않는 운영 DNA</a:t>
+              <a:t>통신을 멈추지 않게 운영해온 단 하나의 회사</a:t>
             </a:r>
           </a:p>
         </p:txBody>
@@ -6489,8 +6470,8 @@
         </p:nvSpPr>
         <p:spPr>
           <a:xfrm>
-            <a:off x="1745999" y="4445999"/>
-            <a:ext cx="9799201" cy="342000"/>
+            <a:off x="1745999" y="4823999"/>
+            <a:ext cx="9799201" cy="198000"/>
           </a:xfrm>
           <a:prstGeom prst="rect">
             <a:avLst/>
@@ -6505,47 +6486,12 @@
           <a:p>
             <a:pPr algn="l"/>
             <a:r>
-              <a:rPr sz="2200" b="1" i="0">
+              <a:rPr sz="1200" b="0" i="1">
                 <a:solidFill>
                   <a:srgbClr val="FFFFFF"/>
                 </a:solidFill>
                 <a:latin typeface="맑은 고딕"/>
               </a:rPr>
-              <a:t>통신을 멈추지 않게 운영해온 단 하나의 회사</a:t>
-            </a:r>
-          </a:p>
-        </p:txBody>
-      </p:sp>
-      <p:sp>
-        <p:nvSpPr>
-          <p:cNvPr id="90" name="TextBox 89"/>
-          <p:cNvSpPr txBox="1"/>
-          <p:nvPr/>
-        </p:nvSpPr>
-        <p:spPr>
-          <a:xfrm>
-            <a:off x="1745999" y="4823999"/>
-            <a:ext cx="9799201" cy="198000"/>
-          </a:xfrm>
-          <a:prstGeom prst="rect">
-            <a:avLst/>
-          </a:prstGeom>
-          <a:noFill/>
-        </p:spPr>
-        <p:txBody>
-          <a:bodyPr wrap="square" lIns="28800" rIns="28800" tIns="14400" bIns="14400">
-            <a:spAutoFit/>
-          </a:bodyPr>
-          <a:lstStyle/>
-          <a:p>
-            <a:pPr algn="l"/>
-            <a:r>
-              <a:rPr sz="1200" b="0" i="1">
-                <a:solidFill>
-                  <a:srgbClr val="FFFFFF"/>
-                </a:solidFill>
-                <a:latin typeface="맑은 고딕"/>
-              </a:rPr>
               <a:t>이 모든 레이어를 받칠 수 있는 토대는, KT의 인프라 운영 DNA 하나입니다.</a:t>
             </a:r>
           </a:p>
@@ -6553,7 +6499,7 @@
       </p:sp>
       <p:sp>
         <p:nvSpPr>
-          <p:cNvPr id="91" name="Trapezoid 90"/>
+          <p:cNvPr id="90" name="Trapezoid 89"/>
           <p:cNvSpPr/>
           <p:nvPr/>
         </p:nvSpPr>
@@ -6596,7 +6542,7 @@
       </p:sp>
       <p:sp>
         <p:nvSpPr>
-          <p:cNvPr id="92" name="Trapezoid 91"/>
+          <p:cNvPr id="91" name="Trapezoid 90"/>
           <p:cNvSpPr/>
           <p:nvPr/>
         </p:nvSpPr>
@@ -6639,7 +6585,7 @@
       </p:sp>
       <p:sp>
         <p:nvSpPr>
-          <p:cNvPr id="93" name="Trapezoid 92"/>
+          <p:cNvPr id="92" name="Trapezoid 91"/>
           <p:cNvSpPr/>
           <p:nvPr/>
         </p:nvSpPr>
@@ -6682,7 +6628,7 @@
       </p:sp>
       <p:sp>
         <p:nvSpPr>
-          <p:cNvPr id="94" name="Trapezoid 93"/>
+          <p:cNvPr id="93" name="Trapezoid 92"/>
           <p:cNvSpPr/>
           <p:nvPr/>
         </p:nvSpPr>
@@ -6725,7 +6671,7 @@
       </p:sp>
       <p:sp>
         <p:nvSpPr>
-          <p:cNvPr id="95" name="Trapezoid 94"/>
+          <p:cNvPr id="94" name="Trapezoid 93"/>
           <p:cNvSpPr/>
           <p:nvPr/>
         </p:nvSpPr>
@@ -6768,7 +6714,7 @@
       </p:sp>
       <p:sp>
         <p:nvSpPr>
-          <p:cNvPr id="96" name="Trapezoid 95"/>
+          <p:cNvPr id="95" name="Trapezoid 94"/>
           <p:cNvSpPr/>
           <p:nvPr/>
         </p:nvSpPr>
@@ -6811,7 +6757,7 @@
       </p:sp>
       <p:sp>
         <p:nvSpPr>
-          <p:cNvPr id="97" name="Trapezoid 96"/>
+          <p:cNvPr id="96" name="Trapezoid 95"/>
           <p:cNvSpPr/>
           <p:nvPr/>
         </p:nvSpPr>
@@ -6854,7 +6800,7 @@
       </p:sp>
       <p:sp>
         <p:nvSpPr>
-          <p:cNvPr id="98" name="Trapezoid 97"/>
+          <p:cNvPr id="97" name="Trapezoid 96"/>
           <p:cNvSpPr/>
           <p:nvPr/>
         </p:nvSpPr>
@@ -6897,7 +6843,7 @@
       </p:sp>
       <p:sp>
         <p:nvSpPr>
-          <p:cNvPr id="99" name="Rectangle 98"/>
+          <p:cNvPr id="98" name="Rectangle 97"/>
           <p:cNvSpPr/>
           <p:nvPr/>
         </p:nvSpPr>
@@ -6940,7 +6886,7 @@
       </p:sp>
       <p:sp>
         <p:nvSpPr>
-          <p:cNvPr id="100" name="TextBox 99"/>
+          <p:cNvPr id="99" name="TextBox 98"/>
           <p:cNvSpPr txBox="1"/>
           <p:nvPr/>
         </p:nvSpPr>
@@ -6975,7 +6921,7 @@
       </p:sp>
       <p:sp>
         <p:nvSpPr>
-          <p:cNvPr id="101" name="TextBox 100"/>
+          <p:cNvPr id="100" name="TextBox 99"/>
           <p:cNvSpPr txBox="1"/>
           <p:nvPr/>
         </p:nvSpPr>
@@ -7008,6 +6954,30 @@
           </a:p>
         </p:txBody>
       </p:sp>
+      <p:pic>
+        <p:nvPicPr>
+          <p:cNvPr id="101" name="Picture 100" descr="85e35f1f-1000038771.jpg"/>
+          <p:cNvPicPr>
+            <a:picLocks noChangeAspect="1"/>
+          </p:cNvPicPr>
+          <p:nvPr/>
+        </p:nvPicPr>
+        <p:blipFill>
+          <a:blip r:embed="rId2"/>
+          <a:stretch>
+            <a:fillRect/>
+          </a:stretch>
+        </p:blipFill>
+        <p:spPr>
+          <a:xfrm>
+            <a:off x="10105200" y="6469200"/>
+            <a:ext cx="306000" cy="306000"/>
+          </a:xfrm>
+          <a:prstGeom prst="rect">
+            <a:avLst/>
+          </a:prstGeom>
+        </p:spPr>
+      </p:pic>
     </p:spTree>
   </p:cSld>
   <p:clrMapOvr>
@@ -10355,6 +10325,30 @@
           </a:p>
         </p:txBody>
       </p:sp>
+      <p:pic>
+        <p:nvPicPr>
+          <p:cNvPr id="87" name="Picture 86" descr="85e35f1f-1000038771.jpg"/>
+          <p:cNvPicPr>
+            <a:picLocks noChangeAspect="1"/>
+          </p:cNvPicPr>
+          <p:nvPr/>
+        </p:nvPicPr>
+        <p:blipFill>
+          <a:blip r:embed="rId2"/>
+          <a:stretch>
+            <a:fillRect/>
+          </a:stretch>
+        </p:blipFill>
+        <p:spPr>
+          <a:xfrm>
+            <a:off x="10105200" y="6469200"/>
+            <a:ext cx="306000" cy="306000"/>
+          </a:xfrm>
+          <a:prstGeom prst="rect">
+            <a:avLst/>
+          </a:prstGeom>
+        </p:spPr>
+      </p:pic>
     </p:spTree>
   </p:cSld>
   <p:clrMapOvr>
@@ -11618,16 +11612,40 @@
           </a:p>
         </p:txBody>
       </p:sp>
-      <p:sp>
-        <p:nvSpPr>
-          <p:cNvPr id="33" name="TextBox 32"/>
+      <p:pic>
+        <p:nvPicPr>
+          <p:cNvPr id="33" name="Picture 32" descr="85e35f1f-1000038771.jpg"/>
+          <p:cNvPicPr>
+            <a:picLocks noChangeAspect="1"/>
+          </p:cNvPicPr>
+          <p:nvPr/>
+        </p:nvPicPr>
+        <p:blipFill>
+          <a:blip r:embed="rId2"/>
+          <a:stretch>
+            <a:fillRect/>
+          </a:stretch>
+        </p:blipFill>
+        <p:spPr>
+          <a:xfrm>
+            <a:off x="4296600" y="6408000"/>
+            <a:ext cx="396000" cy="396000"/>
+          </a:xfrm>
+          <a:prstGeom prst="rect">
+            <a:avLst/>
+          </a:prstGeom>
+        </p:spPr>
+      </p:pic>
+      <p:sp>
+        <p:nvSpPr>
+          <p:cNvPr id="34" name="TextBox 33"/>
           <p:cNvSpPr txBox="1"/>
           <p:nvPr/>
         </p:nvSpPr>
         <p:spPr>
           <a:xfrm>
-            <a:off x="0" y="6534000"/>
-            <a:ext cx="12193200" cy="234000"/>
+            <a:off x="4764600" y="6480000"/>
+            <a:ext cx="2664000" cy="234000"/>
           </a:xfrm>
           <a:prstGeom prst="rect">
             <a:avLst/>
@@ -11640,7 +11658,7 @@
           </a:bodyPr>
           <a:lstStyle/>
           <a:p>
-            <a:pPr algn="ctr"/>
+            <a:pPr algn="l"/>
             <a:r>
               <a:rPr sz="900" b="0" i="0">
                 <a:solidFill>
@@ -11648,7 +11666,7 @@
                 </a:solidFill>
                 <a:latin typeface="맑은 고딕"/>
               </a:rPr>
-              <a:t>KT B2B 수주전략팀  ·  2026.05</a:t>
+              <a:t>B2B 수주전략팀  ·  2026.05</a:t>
             </a:r>
           </a:p>
         </p:txBody>

</xml_diff>